<commit_message>
Final documentation and presentation changes for USP
</commit_message>
<xml_diff>
--- a/ТУ ВАРНА Music App Presentation.pptx
+++ b/ТУ ВАРНА Music App Presentation.pptx
@@ -7,14 +7,16 @@
   <p:sldIdLst>
     <p:sldId id="256" r:id="rId2"/>
     <p:sldId id="257" r:id="rId3"/>
-    <p:sldId id="258" r:id="rId4"/>
-    <p:sldId id="259" r:id="rId5"/>
-    <p:sldId id="260" r:id="rId6"/>
-    <p:sldId id="261" r:id="rId7"/>
-    <p:sldId id="262" r:id="rId8"/>
-    <p:sldId id="263" r:id="rId9"/>
-    <p:sldId id="264" r:id="rId10"/>
-    <p:sldId id="265" r:id="rId11"/>
+    <p:sldId id="266" r:id="rId4"/>
+    <p:sldId id="267" r:id="rId5"/>
+    <p:sldId id="258" r:id="rId6"/>
+    <p:sldId id="259" r:id="rId7"/>
+    <p:sldId id="260" r:id="rId8"/>
+    <p:sldId id="261" r:id="rId9"/>
+    <p:sldId id="262" r:id="rId10"/>
+    <p:sldId id="263" r:id="rId11"/>
+    <p:sldId id="264" r:id="rId12"/>
+    <p:sldId id="265" r:id="rId13"/>
   </p:sldIdLst>
   <p:sldSz cx="12192000" cy="6858000"/>
   <p:notesSz cx="6858000" cy="9144000"/>
@@ -113,6 +115,11 @@
       </a:defRPr>
     </a:lvl9pPr>
   </p:defaultTextStyle>
+  <p:extLst>
+    <p:ext uri="{EFAFB233-063F-42B5-8137-9DF3F51BA10A}">
+      <p15:sldGuideLst xmlns:p15="http://schemas.microsoft.com/office/powerpoint/2012/main"/>
+    </p:ext>
+  </p:extLst>
 </p:presentation>
 </file>
 
@@ -158,10 +165,9 @@
           </a:lstStyle>
           <a:p>
             <a:r>
-              <a:rPr lang="en-US" smtClean="0"/>
+              <a:rPr lang="en-US"/>
               <a:t>Click to edit Master title style</a:t>
             </a:r>
-            <a:endParaRPr lang="en-US"/>
           </a:p>
         </p:txBody>
       </p:sp>
@@ -223,10 +229,9 @@
           </a:lstStyle>
           <a:p>
             <a:r>
-              <a:rPr lang="en-US" smtClean="0"/>
+              <a:rPr lang="en-US"/>
               <a:t>Click to edit Master subtitle style</a:t>
             </a:r>
-            <a:endParaRPr lang="en-US"/>
           </a:p>
         </p:txBody>
       </p:sp>
@@ -247,7 +252,7 @@
           <a:p>
             <a:fld id="{343BBA07-A3FE-4952-8777-070CB8556D2F}" type="datetimeFigureOut">
               <a:rPr lang="en-US" smtClean="0"/>
-              <a:t>5/17/2026</a:t>
+              <a:t>5/18/2026</a:t>
             </a:fld>
             <a:endParaRPr lang="en-US"/>
           </a:p>
@@ -341,10 +346,9 @@
           <a:lstStyle/>
           <a:p>
             <a:r>
-              <a:rPr lang="en-US" smtClean="0"/>
+              <a:rPr lang="en-US"/>
               <a:t>Click to edit Master title style</a:t>
             </a:r>
-            <a:endParaRPr lang="en-US"/>
           </a:p>
         </p:txBody>
       </p:sp>
@@ -365,38 +369,37 @@
           <a:p>
             <a:pPr lvl="0"/>
             <a:r>
-              <a:rPr lang="en-US" smtClean="0"/>
+              <a:rPr lang="en-US"/>
               <a:t>Edit Master text styles</a:t>
             </a:r>
           </a:p>
           <a:p>
             <a:pPr lvl="1"/>
             <a:r>
-              <a:rPr lang="en-US" smtClean="0"/>
+              <a:rPr lang="en-US"/>
               <a:t>Second level</a:t>
             </a:r>
           </a:p>
           <a:p>
             <a:pPr lvl="2"/>
             <a:r>
-              <a:rPr lang="en-US" smtClean="0"/>
+              <a:rPr lang="en-US"/>
               <a:t>Third level</a:t>
             </a:r>
           </a:p>
           <a:p>
             <a:pPr lvl="3"/>
             <a:r>
-              <a:rPr lang="en-US" smtClean="0"/>
+              <a:rPr lang="en-US"/>
               <a:t>Fourth level</a:t>
             </a:r>
           </a:p>
           <a:p>
             <a:pPr lvl="4"/>
             <a:r>
-              <a:rPr lang="en-US" smtClean="0"/>
+              <a:rPr lang="en-US"/>
               <a:t>Fifth level</a:t>
             </a:r>
-            <a:endParaRPr lang="en-US"/>
           </a:p>
         </p:txBody>
       </p:sp>
@@ -417,7 +420,7 @@
           <a:p>
             <a:fld id="{343BBA07-A3FE-4952-8777-070CB8556D2F}" type="datetimeFigureOut">
               <a:rPr lang="en-US" smtClean="0"/>
-              <a:t>5/17/2026</a:t>
+              <a:t>5/18/2026</a:t>
             </a:fld>
             <a:endParaRPr lang="en-US"/>
           </a:p>
@@ -516,10 +519,9 @@
           <a:lstStyle/>
           <a:p>
             <a:r>
-              <a:rPr lang="en-US" smtClean="0"/>
+              <a:rPr lang="en-US"/>
               <a:t>Click to edit Master title style</a:t>
             </a:r>
-            <a:endParaRPr lang="en-US"/>
           </a:p>
         </p:txBody>
       </p:sp>
@@ -545,38 +547,37 @@
           <a:p>
             <a:pPr lvl="0"/>
             <a:r>
-              <a:rPr lang="en-US" smtClean="0"/>
+              <a:rPr lang="en-US"/>
               <a:t>Edit Master text styles</a:t>
             </a:r>
           </a:p>
           <a:p>
             <a:pPr lvl="1"/>
             <a:r>
-              <a:rPr lang="en-US" smtClean="0"/>
+              <a:rPr lang="en-US"/>
               <a:t>Second level</a:t>
             </a:r>
           </a:p>
           <a:p>
             <a:pPr lvl="2"/>
             <a:r>
-              <a:rPr lang="en-US" smtClean="0"/>
+              <a:rPr lang="en-US"/>
               <a:t>Third level</a:t>
             </a:r>
           </a:p>
           <a:p>
             <a:pPr lvl="3"/>
             <a:r>
-              <a:rPr lang="en-US" smtClean="0"/>
+              <a:rPr lang="en-US"/>
               <a:t>Fourth level</a:t>
             </a:r>
           </a:p>
           <a:p>
             <a:pPr lvl="4"/>
             <a:r>
-              <a:rPr lang="en-US" smtClean="0"/>
+              <a:rPr lang="en-US"/>
               <a:t>Fifth level</a:t>
             </a:r>
-            <a:endParaRPr lang="en-US"/>
           </a:p>
         </p:txBody>
       </p:sp>
@@ -597,7 +598,7 @@
           <a:p>
             <a:fld id="{343BBA07-A3FE-4952-8777-070CB8556D2F}" type="datetimeFigureOut">
               <a:rPr lang="en-US" smtClean="0"/>
-              <a:t>5/17/2026</a:t>
+              <a:t>5/18/2026</a:t>
             </a:fld>
             <a:endParaRPr lang="en-US"/>
           </a:p>
@@ -691,10 +692,9 @@
           <a:lstStyle/>
           <a:p>
             <a:r>
-              <a:rPr lang="en-US" smtClean="0"/>
+              <a:rPr lang="en-US"/>
               <a:t>Click to edit Master title style</a:t>
             </a:r>
-            <a:endParaRPr lang="en-US"/>
           </a:p>
         </p:txBody>
       </p:sp>
@@ -715,38 +715,37 @@
           <a:p>
             <a:pPr lvl="0"/>
             <a:r>
-              <a:rPr lang="en-US" smtClean="0"/>
+              <a:rPr lang="en-US"/>
               <a:t>Edit Master text styles</a:t>
             </a:r>
           </a:p>
           <a:p>
             <a:pPr lvl="1"/>
             <a:r>
-              <a:rPr lang="en-US" smtClean="0"/>
+              <a:rPr lang="en-US"/>
               <a:t>Second level</a:t>
             </a:r>
           </a:p>
           <a:p>
             <a:pPr lvl="2"/>
             <a:r>
-              <a:rPr lang="en-US" smtClean="0"/>
+              <a:rPr lang="en-US"/>
               <a:t>Third level</a:t>
             </a:r>
           </a:p>
           <a:p>
             <a:pPr lvl="3"/>
             <a:r>
-              <a:rPr lang="en-US" smtClean="0"/>
+              <a:rPr lang="en-US"/>
               <a:t>Fourth level</a:t>
             </a:r>
           </a:p>
           <a:p>
             <a:pPr lvl="4"/>
             <a:r>
-              <a:rPr lang="en-US" smtClean="0"/>
+              <a:rPr lang="en-US"/>
               <a:t>Fifth level</a:t>
             </a:r>
-            <a:endParaRPr lang="en-US"/>
           </a:p>
         </p:txBody>
       </p:sp>
@@ -767,7 +766,7 @@
           <a:p>
             <a:fld id="{343BBA07-A3FE-4952-8777-070CB8556D2F}" type="datetimeFigureOut">
               <a:rPr lang="en-US" smtClean="0"/>
-              <a:t>5/17/2026</a:t>
+              <a:t>5/18/2026</a:t>
             </a:fld>
             <a:endParaRPr lang="en-US"/>
           </a:p>
@@ -870,10 +869,9 @@
           </a:lstStyle>
           <a:p>
             <a:r>
-              <a:rPr lang="en-US" smtClean="0"/>
+              <a:rPr lang="en-US"/>
               <a:t>Click to edit Master title style</a:t>
             </a:r>
-            <a:endParaRPr lang="en-US"/>
           </a:p>
         </p:txBody>
       </p:sp>
@@ -990,7 +988,7 @@
           <a:p>
             <a:pPr lvl="0"/>
             <a:r>
-              <a:rPr lang="en-US" smtClean="0"/>
+              <a:rPr lang="en-US"/>
               <a:t>Edit Master text styles</a:t>
             </a:r>
           </a:p>
@@ -1013,7 +1011,7 @@
           <a:p>
             <a:fld id="{343BBA07-A3FE-4952-8777-070CB8556D2F}" type="datetimeFigureOut">
               <a:rPr lang="en-US" smtClean="0"/>
-              <a:t>5/17/2026</a:t>
+              <a:t>5/18/2026</a:t>
             </a:fld>
             <a:endParaRPr lang="en-US"/>
           </a:p>
@@ -1107,10 +1105,9 @@
           <a:lstStyle/>
           <a:p>
             <a:r>
-              <a:rPr lang="en-US" smtClean="0"/>
+              <a:rPr lang="en-US"/>
               <a:t>Click to edit Master title style</a:t>
             </a:r>
-            <a:endParaRPr lang="en-US"/>
           </a:p>
         </p:txBody>
       </p:sp>
@@ -1136,38 +1133,37 @@
           <a:p>
             <a:pPr lvl="0"/>
             <a:r>
-              <a:rPr lang="en-US" smtClean="0"/>
+              <a:rPr lang="en-US"/>
               <a:t>Edit Master text styles</a:t>
             </a:r>
           </a:p>
           <a:p>
             <a:pPr lvl="1"/>
             <a:r>
-              <a:rPr lang="en-US" smtClean="0"/>
+              <a:rPr lang="en-US"/>
               <a:t>Second level</a:t>
             </a:r>
           </a:p>
           <a:p>
             <a:pPr lvl="2"/>
             <a:r>
-              <a:rPr lang="en-US" smtClean="0"/>
+              <a:rPr lang="en-US"/>
               <a:t>Third level</a:t>
             </a:r>
           </a:p>
           <a:p>
             <a:pPr lvl="3"/>
             <a:r>
-              <a:rPr lang="en-US" smtClean="0"/>
+              <a:rPr lang="en-US"/>
               <a:t>Fourth level</a:t>
             </a:r>
           </a:p>
           <a:p>
             <a:pPr lvl="4"/>
             <a:r>
-              <a:rPr lang="en-US" smtClean="0"/>
+              <a:rPr lang="en-US"/>
               <a:t>Fifth level</a:t>
             </a:r>
-            <a:endParaRPr lang="en-US"/>
           </a:p>
         </p:txBody>
       </p:sp>
@@ -1193,38 +1189,37 @@
           <a:p>
             <a:pPr lvl="0"/>
             <a:r>
-              <a:rPr lang="en-US" smtClean="0"/>
+              <a:rPr lang="en-US"/>
               <a:t>Edit Master text styles</a:t>
             </a:r>
           </a:p>
           <a:p>
             <a:pPr lvl="1"/>
             <a:r>
-              <a:rPr lang="en-US" smtClean="0"/>
+              <a:rPr lang="en-US"/>
               <a:t>Second level</a:t>
             </a:r>
           </a:p>
           <a:p>
             <a:pPr lvl="2"/>
             <a:r>
-              <a:rPr lang="en-US" smtClean="0"/>
+              <a:rPr lang="en-US"/>
               <a:t>Third level</a:t>
             </a:r>
           </a:p>
           <a:p>
             <a:pPr lvl="3"/>
             <a:r>
-              <a:rPr lang="en-US" smtClean="0"/>
+              <a:rPr lang="en-US"/>
               <a:t>Fourth level</a:t>
             </a:r>
           </a:p>
           <a:p>
             <a:pPr lvl="4"/>
             <a:r>
-              <a:rPr lang="en-US" smtClean="0"/>
+              <a:rPr lang="en-US"/>
               <a:t>Fifth level</a:t>
             </a:r>
-            <a:endParaRPr lang="en-US"/>
           </a:p>
         </p:txBody>
       </p:sp>
@@ -1245,7 +1240,7 @@
           <a:p>
             <a:fld id="{343BBA07-A3FE-4952-8777-070CB8556D2F}" type="datetimeFigureOut">
               <a:rPr lang="en-US" smtClean="0"/>
-              <a:t>5/17/2026</a:t>
+              <a:t>5/18/2026</a:t>
             </a:fld>
             <a:endParaRPr lang="en-US"/>
           </a:p>
@@ -1344,10 +1339,9 @@
           <a:lstStyle/>
           <a:p>
             <a:r>
-              <a:rPr lang="en-US" smtClean="0"/>
+              <a:rPr lang="en-US"/>
               <a:t>Click to edit Master title style</a:t>
             </a:r>
-            <a:endParaRPr lang="en-US"/>
           </a:p>
         </p:txBody>
       </p:sp>
@@ -1410,7 +1404,7 @@
           <a:p>
             <a:pPr lvl="0"/>
             <a:r>
-              <a:rPr lang="en-US" smtClean="0"/>
+              <a:rPr lang="en-US"/>
               <a:t>Edit Master text styles</a:t>
             </a:r>
           </a:p>
@@ -1438,38 +1432,37 @@
           <a:p>
             <a:pPr lvl="0"/>
             <a:r>
-              <a:rPr lang="en-US" smtClean="0"/>
+              <a:rPr lang="en-US"/>
               <a:t>Edit Master text styles</a:t>
             </a:r>
           </a:p>
           <a:p>
             <a:pPr lvl="1"/>
             <a:r>
-              <a:rPr lang="en-US" smtClean="0"/>
+              <a:rPr lang="en-US"/>
               <a:t>Second level</a:t>
             </a:r>
           </a:p>
           <a:p>
             <a:pPr lvl="2"/>
             <a:r>
-              <a:rPr lang="en-US" smtClean="0"/>
+              <a:rPr lang="en-US"/>
               <a:t>Third level</a:t>
             </a:r>
           </a:p>
           <a:p>
             <a:pPr lvl="3"/>
             <a:r>
-              <a:rPr lang="en-US" smtClean="0"/>
+              <a:rPr lang="en-US"/>
               <a:t>Fourth level</a:t>
             </a:r>
           </a:p>
           <a:p>
             <a:pPr lvl="4"/>
             <a:r>
-              <a:rPr lang="en-US" smtClean="0"/>
+              <a:rPr lang="en-US"/>
               <a:t>Fifth level</a:t>
             </a:r>
-            <a:endParaRPr lang="en-US"/>
           </a:p>
         </p:txBody>
       </p:sp>
@@ -1532,7 +1525,7 @@
           <a:p>
             <a:pPr lvl="0"/>
             <a:r>
-              <a:rPr lang="en-US" smtClean="0"/>
+              <a:rPr lang="en-US"/>
               <a:t>Edit Master text styles</a:t>
             </a:r>
           </a:p>
@@ -1560,38 +1553,37 @@
           <a:p>
             <a:pPr lvl="0"/>
             <a:r>
-              <a:rPr lang="en-US" smtClean="0"/>
+              <a:rPr lang="en-US"/>
               <a:t>Edit Master text styles</a:t>
             </a:r>
           </a:p>
           <a:p>
             <a:pPr lvl="1"/>
             <a:r>
-              <a:rPr lang="en-US" smtClean="0"/>
+              <a:rPr lang="en-US"/>
               <a:t>Second level</a:t>
             </a:r>
           </a:p>
           <a:p>
             <a:pPr lvl="2"/>
             <a:r>
-              <a:rPr lang="en-US" smtClean="0"/>
+              <a:rPr lang="en-US"/>
               <a:t>Third level</a:t>
             </a:r>
           </a:p>
           <a:p>
             <a:pPr lvl="3"/>
             <a:r>
-              <a:rPr lang="en-US" smtClean="0"/>
+              <a:rPr lang="en-US"/>
               <a:t>Fourth level</a:t>
             </a:r>
           </a:p>
           <a:p>
             <a:pPr lvl="4"/>
             <a:r>
-              <a:rPr lang="en-US" smtClean="0"/>
+              <a:rPr lang="en-US"/>
               <a:t>Fifth level</a:t>
             </a:r>
-            <a:endParaRPr lang="en-US"/>
           </a:p>
         </p:txBody>
       </p:sp>
@@ -1612,7 +1604,7 @@
           <a:p>
             <a:fld id="{343BBA07-A3FE-4952-8777-070CB8556D2F}" type="datetimeFigureOut">
               <a:rPr lang="en-US" smtClean="0"/>
-              <a:t>5/17/2026</a:t>
+              <a:t>5/18/2026</a:t>
             </a:fld>
             <a:endParaRPr lang="en-US"/>
           </a:p>
@@ -1706,10 +1698,9 @@
           <a:lstStyle/>
           <a:p>
             <a:r>
-              <a:rPr lang="en-US" smtClean="0"/>
+              <a:rPr lang="en-US"/>
               <a:t>Click to edit Master title style</a:t>
             </a:r>
-            <a:endParaRPr lang="en-US"/>
           </a:p>
         </p:txBody>
       </p:sp>
@@ -1730,7 +1721,7 @@
           <a:p>
             <a:fld id="{343BBA07-A3FE-4952-8777-070CB8556D2F}" type="datetimeFigureOut">
               <a:rPr lang="en-US" smtClean="0"/>
-              <a:t>5/17/2026</a:t>
+              <a:t>5/18/2026</a:t>
             </a:fld>
             <a:endParaRPr lang="en-US"/>
           </a:p>
@@ -1825,7 +1816,7 @@
           <a:p>
             <a:fld id="{343BBA07-A3FE-4952-8777-070CB8556D2F}" type="datetimeFigureOut">
               <a:rPr lang="en-US" smtClean="0"/>
-              <a:t>5/17/2026</a:t>
+              <a:t>5/18/2026</a:t>
             </a:fld>
             <a:endParaRPr lang="en-US"/>
           </a:p>
@@ -1928,10 +1919,9 @@
           </a:lstStyle>
           <a:p>
             <a:r>
-              <a:rPr lang="en-US" smtClean="0"/>
+              <a:rPr lang="en-US"/>
               <a:t>Click to edit Master title style</a:t>
             </a:r>
-            <a:endParaRPr lang="en-US"/>
           </a:p>
         </p:txBody>
       </p:sp>
@@ -1985,38 +1975,37 @@
           <a:p>
             <a:pPr lvl="0"/>
             <a:r>
-              <a:rPr lang="en-US" smtClean="0"/>
+              <a:rPr lang="en-US"/>
               <a:t>Edit Master text styles</a:t>
             </a:r>
           </a:p>
           <a:p>
             <a:pPr lvl="1"/>
             <a:r>
-              <a:rPr lang="en-US" smtClean="0"/>
+              <a:rPr lang="en-US"/>
               <a:t>Second level</a:t>
             </a:r>
           </a:p>
           <a:p>
             <a:pPr lvl="2"/>
             <a:r>
-              <a:rPr lang="en-US" smtClean="0"/>
+              <a:rPr lang="en-US"/>
               <a:t>Third level</a:t>
             </a:r>
           </a:p>
           <a:p>
             <a:pPr lvl="3"/>
             <a:r>
-              <a:rPr lang="en-US" smtClean="0"/>
+              <a:rPr lang="en-US"/>
               <a:t>Fourth level</a:t>
             </a:r>
           </a:p>
           <a:p>
             <a:pPr lvl="4"/>
             <a:r>
-              <a:rPr lang="en-US" smtClean="0"/>
+              <a:rPr lang="en-US"/>
               <a:t>Fifth level</a:t>
             </a:r>
-            <a:endParaRPr lang="en-US"/>
           </a:p>
         </p:txBody>
       </p:sp>
@@ -2079,7 +2068,7 @@
           <a:p>
             <a:pPr lvl="0"/>
             <a:r>
-              <a:rPr lang="en-US" smtClean="0"/>
+              <a:rPr lang="en-US"/>
               <a:t>Edit Master text styles</a:t>
             </a:r>
           </a:p>
@@ -2102,7 +2091,7 @@
           <a:p>
             <a:fld id="{343BBA07-A3FE-4952-8777-070CB8556D2F}" type="datetimeFigureOut">
               <a:rPr lang="en-US" smtClean="0"/>
-              <a:t>5/17/2026</a:t>
+              <a:t>5/18/2026</a:t>
             </a:fld>
             <a:endParaRPr lang="en-US"/>
           </a:p>
@@ -2205,10 +2194,9 @@
           </a:lstStyle>
           <a:p>
             <a:r>
-              <a:rPr lang="en-US" smtClean="0"/>
+              <a:rPr lang="en-US"/>
               <a:t>Click to edit Master title style</a:t>
             </a:r>
-            <a:endParaRPr lang="en-US"/>
           </a:p>
         </p:txBody>
       </p:sp>
@@ -2332,7 +2320,7 @@
           <a:p>
             <a:pPr lvl="0"/>
             <a:r>
-              <a:rPr lang="en-US" smtClean="0"/>
+              <a:rPr lang="en-US"/>
               <a:t>Edit Master text styles</a:t>
             </a:r>
           </a:p>
@@ -2355,7 +2343,7 @@
           <a:p>
             <a:fld id="{343BBA07-A3FE-4952-8777-070CB8556D2F}" type="datetimeFigureOut">
               <a:rPr lang="en-US" smtClean="0"/>
-              <a:t>5/17/2026</a:t>
+              <a:t>5/18/2026</a:t>
             </a:fld>
             <a:endParaRPr lang="en-US"/>
           </a:p>
@@ -2464,10 +2452,9 @@
           <a:lstStyle/>
           <a:p>
             <a:r>
-              <a:rPr lang="en-US" smtClean="0"/>
+              <a:rPr lang="en-US"/>
               <a:t>Click to edit Master title style</a:t>
             </a:r>
-            <a:endParaRPr lang="en-US"/>
           </a:p>
         </p:txBody>
       </p:sp>
@@ -2498,38 +2485,37 @@
           <a:p>
             <a:pPr lvl="0"/>
             <a:r>
-              <a:rPr lang="en-US" smtClean="0"/>
+              <a:rPr lang="en-US"/>
               <a:t>Edit Master text styles</a:t>
             </a:r>
           </a:p>
           <a:p>
             <a:pPr lvl="1"/>
             <a:r>
-              <a:rPr lang="en-US" smtClean="0"/>
+              <a:rPr lang="en-US"/>
               <a:t>Second level</a:t>
             </a:r>
           </a:p>
           <a:p>
             <a:pPr lvl="2"/>
             <a:r>
-              <a:rPr lang="en-US" smtClean="0"/>
+              <a:rPr lang="en-US"/>
               <a:t>Third level</a:t>
             </a:r>
           </a:p>
           <a:p>
             <a:pPr lvl="3"/>
             <a:r>
-              <a:rPr lang="en-US" smtClean="0"/>
+              <a:rPr lang="en-US"/>
               <a:t>Fourth level</a:t>
             </a:r>
           </a:p>
           <a:p>
             <a:pPr lvl="4"/>
             <a:r>
-              <a:rPr lang="en-US" smtClean="0"/>
+              <a:rPr lang="en-US"/>
               <a:t>Fifth level</a:t>
             </a:r>
-            <a:endParaRPr lang="en-US"/>
           </a:p>
         </p:txBody>
       </p:sp>
@@ -2568,7 +2554,7 @@
           <a:p>
             <a:fld id="{343BBA07-A3FE-4952-8777-070CB8556D2F}" type="datetimeFigureOut">
               <a:rPr lang="en-US" smtClean="0"/>
-              <a:t>5/17/2026</a:t>
+              <a:t>5/18/2026</a:t>
             </a:fld>
             <a:endParaRPr lang="en-US"/>
           </a:p>
@@ -2983,52 +2969,53 @@
             <p:ph type="ctrTitle"/>
           </p:nvPr>
         </p:nvSpPr>
-        <p:spPr>
-          <a:xfrm>
-            <a:off x="1490749" y="2161454"/>
-            <a:ext cx="9144000" cy="2387600"/>
-          </a:xfrm>
-        </p:spPr>
+        <p:spPr/>
         <p:txBody>
           <a:bodyPr>
-            <a:normAutofit fontScale="90000"/>
+            <a:normAutofit/>
           </a:bodyPr>
           <a:lstStyle/>
           <a:p>
             <a:r>
-              <a:rPr lang="bg-BG"/>
-              <a:t>ТУ ВАРНА</a:t>
-            </a:r>
-            <a:r>
-              <a:rPr lang="en-US"/>
-              <a:t/>
-            </a:r>
-            <a:br>
-              <a:rPr lang="en-US"/>
-            </a:br>
-            <a:r>
-              <a:rPr lang="bg-BG"/>
-              <a:t>Проект по тема </a:t>
-            </a:r>
-            <a:r>
-              <a:rPr lang="en-US"/>
-              <a:t/>
-            </a:r>
-            <a:br>
-              <a:rPr lang="en-US"/>
-            </a:br>
-            <a:r>
-              <a:rPr lang="bg-BG"/>
-              <a:t>“Система за избор на песен“</a:t>
-            </a:r>
-            <a:r>
-              <a:rPr lang="en-US"/>
-              <a:t/>
-            </a:r>
-            <a:br>
-              <a:rPr lang="en-US"/>
-            </a:br>
-            <a:endParaRPr lang="en-US"/>
+              <a:rPr lang="bg-BG" noProof="0" dirty="0"/>
+              <a:t>ТЕМА 6 – СИСТЕМА ЗА ИЗБОР НА ПЕСЕН</a:t>
+            </a:r>
+          </a:p>
+        </p:txBody>
+      </p:sp>
+      <p:sp>
+        <p:nvSpPr>
+          <p:cNvPr id="4" name="Подзаглавие 3">
+            <a:extLst>
+              <a:ext uri="{FF2B5EF4-FFF2-40B4-BE49-F238E27FC236}">
+                <a16:creationId xmlns:a16="http://schemas.microsoft.com/office/drawing/2014/main" id="{EBA7FFAA-E257-AE54-AF44-2A65B50D3A4E}"/>
+              </a:ext>
+            </a:extLst>
+          </p:cNvPr>
+          <p:cNvSpPr>
+            <a:spLocks noGrp="1"/>
+          </p:cNvSpPr>
+          <p:nvPr>
+            <p:ph type="subTitle" idx="1"/>
+          </p:nvPr>
+        </p:nvSpPr>
+        <p:spPr/>
+        <p:txBody>
+          <a:bodyPr>
+            <a:normAutofit/>
+          </a:bodyPr>
+          <a:lstStyle/>
+          <a:p>
+            <a:r>
+              <a:rPr lang="bg-BG" noProof="0" dirty="0"/>
+              <a:t>Изработена от Теодор Ангелов и Йово Неделчев</a:t>
+            </a:r>
+          </a:p>
+          <a:p>
+            <a:r>
+              <a:rPr lang="bg-BG" noProof="0" dirty="0"/>
+              <a:t>Курсов проект от ТУ Варна</a:t>
+            </a:r>
           </a:p>
         </p:txBody>
       </p:sp>
@@ -3074,1111 +3061,20 @@
         </p:nvSpPr>
         <p:spPr/>
         <p:txBody>
-          <a:bodyPr/>
-          <a:lstStyle/>
-          <a:p>
-            <a:r>
-              <a:rPr lang="en-US"/>
-              <a:t>9.</a:t>
-            </a:r>
-            <a:r>
-              <a:rPr lang="bg-BG"/>
-              <a:t>Използвани класове</a:t>
-            </a:r>
-            <a:r>
-              <a:rPr lang="en-US"/>
-              <a:t/>
+          <a:bodyPr>
+            <a:normAutofit/>
+          </a:bodyPr>
+          <a:lstStyle/>
+          <a:p>
+            <a:pPr algn="ctr"/>
+            <a:r>
+              <a:rPr lang="bg-BG" noProof="0" dirty="0"/>
+              <a:t>Програмни средства за реализацията </a:t>
             </a:r>
             <a:br>
-              <a:rPr lang="en-US"/>
+              <a:rPr lang="bg-BG" noProof="0" dirty="0"/>
             </a:br>
-            <a:endParaRPr lang="en-US"/>
-          </a:p>
-        </p:txBody>
-      </p:sp>
-      <p:sp>
-        <p:nvSpPr>
-          <p:cNvPr id="3" name="Content Placeholder 2"/>
-          <p:cNvSpPr>
-            <a:spLocks noGrp="1"/>
-          </p:cNvSpPr>
-          <p:nvPr>
-            <p:ph idx="1"/>
-          </p:nvPr>
-        </p:nvSpPr>
-        <p:spPr>
-          <a:xfrm>
-            <a:off x="0" y="1038224"/>
-            <a:ext cx="8801100" cy="5819775"/>
-          </a:xfrm>
-        </p:spPr>
-        <p:txBody>
-          <a:bodyPr>
-            <a:normAutofit fontScale="85000" lnSpcReduction="20000"/>
-          </a:bodyPr>
-          <a:lstStyle/>
-          <a:p>
-            <a:r>
-              <a:rPr lang="en-US"/>
-              <a:t>Program – </a:t>
-            </a:r>
-            <a:r>
-              <a:rPr lang="bg-BG"/>
-              <a:t>Класът, който съдържа логиката за подкарване на </a:t>
-            </a:r>
-            <a:r>
-              <a:rPr lang="en-US"/>
-              <a:t>web </a:t>
-            </a:r>
-            <a:r>
-              <a:rPr lang="bg-BG"/>
-              <a:t>апликацията.</a:t>
-            </a:r>
-            <a:endParaRPr lang="en-US"/>
-          </a:p>
-          <a:p>
-            <a:r>
-              <a:rPr lang="en-US"/>
-              <a:t>ApplicationDbContext</a:t>
-            </a:r>
-            <a:r>
-              <a:rPr lang="bg-BG"/>
-              <a:t> – В този клас се съдържа информацията за песните, коята се извилича от базата данни, и от коята се пише в базата данни.</a:t>
-            </a:r>
-            <a:endParaRPr lang="en-US"/>
-          </a:p>
-          <a:p>
-            <a:r>
-              <a:rPr lang="en-US"/>
-              <a:t>Song – </a:t>
-            </a:r>
-            <a:r>
-              <a:rPr lang="bg-BG"/>
-              <a:t>Това е класът модел, който служи за създаване на обектите за песни.</a:t>
-            </a:r>
-            <a:endParaRPr lang="en-US"/>
-          </a:p>
-          <a:p>
-            <a:r>
-              <a:rPr lang="en-US"/>
-              <a:t>Genres – </a:t>
-            </a:r>
-            <a:r>
-              <a:rPr lang="bg-BG"/>
-              <a:t>Клас, който съдържа статичен лист с популярни жанрове на песни, с цел да помага в създаването на обекти.</a:t>
-            </a:r>
-            <a:endParaRPr lang="en-US"/>
-          </a:p>
-          <a:p>
-            <a:r>
-              <a:rPr lang="en-US"/>
-              <a:t>HomeController – </a:t>
-            </a:r>
-            <a:r>
-              <a:rPr lang="bg-BG"/>
-              <a:t>Класът за контролера, който съдържа всички методи, които позволяват работата между базата данни и потребителският интерфейс.</a:t>
-            </a:r>
-            <a:endParaRPr lang="en-US"/>
-          </a:p>
-          <a:p>
-            <a:r>
-              <a:rPr lang="en-US"/>
-              <a:t>AddSongViewModel/BasicSongViewModel/DeleteSongViewModel – </a:t>
-            </a:r>
-            <a:r>
-              <a:rPr lang="bg-BG"/>
-              <a:t>класове, които служат за помощ с иползването на данни от модела </a:t>
-            </a:r>
-            <a:r>
-              <a:rPr lang="en-US"/>
-              <a:t>Song </a:t>
-            </a:r>
-            <a:r>
-              <a:rPr lang="bg-BG"/>
-              <a:t>в страниците на апликацията.</a:t>
-            </a:r>
-            <a:endParaRPr lang="en-US"/>
-          </a:p>
-          <a:p>
-            <a:r>
-              <a:rPr lang="en-US"/>
-              <a:t>Add</a:t>
-            </a:r>
-            <a:r>
-              <a:rPr lang="bg-BG"/>
-              <a:t>/</a:t>
-            </a:r>
-            <a:r>
-              <a:rPr lang="en-US"/>
-              <a:t>Edit/Delete/Index – View </a:t>
-            </a:r>
-            <a:r>
-              <a:rPr lang="bg-BG"/>
-              <a:t>файлoвете, които съдържат структурата на страниците за апликацията.</a:t>
-            </a:r>
-            <a:endParaRPr lang="en-US"/>
-          </a:p>
-        </p:txBody>
-      </p:sp>
-      <p:pic>
-        <p:nvPicPr>
-          <p:cNvPr id="4" name="Picture 3"/>
-          <p:cNvPicPr>
-            <a:picLocks noChangeAspect="1"/>
-          </p:cNvPicPr>
-          <p:nvPr/>
-        </p:nvPicPr>
-        <p:blipFill>
-          <a:blip r:embed="rId2"/>
-          <a:stretch>
-            <a:fillRect/>
-          </a:stretch>
-        </p:blipFill>
-        <p:spPr>
-          <a:xfrm>
-            <a:off x="9534524" y="128587"/>
-            <a:ext cx="2533651" cy="6656390"/>
-          </a:xfrm>
-          <a:prstGeom prst="rect">
-            <a:avLst/>
-          </a:prstGeom>
-        </p:spPr>
-      </p:pic>
-    </p:spTree>
-    <p:extLst>
-      <p:ext uri="{BB962C8B-B14F-4D97-AF65-F5344CB8AC3E}">
-        <p14:creationId xmlns:p14="http://schemas.microsoft.com/office/powerpoint/2010/main" val="233053847"/>
-      </p:ext>
-    </p:extLst>
-  </p:cSld>
-  <p:clrMapOvr>
-    <a:masterClrMapping/>
-  </p:clrMapOvr>
-</p:sld>
-</file>
-
-<file path=ppt/slides/slide2.xml><?xml version="1.0" encoding="utf-8"?>
-<p:sld xmlns:a="http://schemas.openxmlformats.org/drawingml/2006/main" xmlns:r="http://schemas.openxmlformats.org/officeDocument/2006/relationships" xmlns:p="http://schemas.openxmlformats.org/presentationml/2006/main">
-  <p:cSld>
-    <p:spTree>
-      <p:nvGrpSpPr>
-        <p:cNvPr id="1" name=""/>
-        <p:cNvGrpSpPr/>
-        <p:nvPr/>
-      </p:nvGrpSpPr>
-      <p:grpSpPr>
-        <a:xfrm>
-          <a:off x="0" y="0"/>
-          <a:ext cx="0" cy="0"/>
-          <a:chOff x="0" y="0"/>
-          <a:chExt cx="0" cy="0"/>
-        </a:xfrm>
-      </p:grpSpPr>
-      <p:sp>
-        <p:nvSpPr>
-          <p:cNvPr id="2" name="Title 1"/>
-          <p:cNvSpPr>
-            <a:spLocks noGrp="1"/>
-          </p:cNvSpPr>
-          <p:nvPr>
-            <p:ph type="title"/>
-          </p:nvPr>
-        </p:nvSpPr>
-        <p:spPr/>
-        <p:txBody>
-          <a:bodyPr/>
-          <a:lstStyle/>
-          <a:p>
-            <a:r>
-              <a:rPr lang="bg-BG"/>
-              <a:t>1.Техническо Задание</a:t>
-            </a:r>
-            <a:r>
-              <a:rPr lang="en-US"/>
-              <a:t/>
-            </a:r>
-            <a:br>
-              <a:rPr lang="en-US"/>
-            </a:br>
-            <a:endParaRPr lang="en-US"/>
-          </a:p>
-        </p:txBody>
-      </p:sp>
-      <p:pic>
-        <p:nvPicPr>
-          <p:cNvPr id="1026" name="Picture 2" descr="https://cdn.discordapp.com/attachments/1422853389347455053/1495497283985346701/image.png?ex=6a0ab721&amp;is=6a0965a1&amp;hm=9a2e02aad2993d7120b8b8182d290f112d47b42f7fc38aa751a05fbbaec48b6e&amp;"/>
-          <p:cNvPicPr>
-            <a:picLocks noGrp="1" noChangeAspect="1" noChangeArrowheads="1"/>
-          </p:cNvPicPr>
-          <p:nvPr>
-            <p:ph idx="1"/>
-          </p:nvPr>
-        </p:nvPicPr>
-        <p:blipFill>
-          <a:blip r:embed="rId2">
-            <a:extLst>
-              <a:ext uri="{28A0092B-C50C-407E-A947-70E740481C1C}">
-                <a14:useLocalDpi xmlns:a14="http://schemas.microsoft.com/office/drawing/2010/main" val="0"/>
-              </a:ext>
-            </a:extLst>
-          </a:blip>
-          <a:srcRect/>
-          <a:stretch>
-            <a:fillRect/>
-          </a:stretch>
-        </p:blipFill>
-        <p:spPr bwMode="auto">
-          <a:xfrm>
-            <a:off x="778766" y="1690688"/>
-            <a:ext cx="10327557" cy="2074977"/>
-          </a:xfrm>
-          <a:prstGeom prst="rect">
-            <a:avLst/>
-          </a:prstGeom>
-          <a:noFill/>
-          <a:extLst>
-            <a:ext uri="{909E8E84-426E-40DD-AFC4-6F175D3DCCD1}">
-              <a14:hiddenFill xmlns:a14="http://schemas.microsoft.com/office/drawing/2010/main">
-                <a:solidFill>
-                  <a:srgbClr val="FFFFFF"/>
-                </a:solidFill>
-              </a14:hiddenFill>
-            </a:ext>
-          </a:extLst>
-        </p:spPr>
-      </p:pic>
-    </p:spTree>
-    <p:extLst>
-      <p:ext uri="{BB962C8B-B14F-4D97-AF65-F5344CB8AC3E}">
-        <p14:creationId xmlns:p14="http://schemas.microsoft.com/office/powerpoint/2010/main" val="1768123233"/>
-      </p:ext>
-    </p:extLst>
-  </p:cSld>
-  <p:clrMapOvr>
-    <a:masterClrMapping/>
-  </p:clrMapOvr>
-</p:sld>
-</file>
-
-<file path=ppt/slides/slide3.xml><?xml version="1.0" encoding="utf-8"?>
-<p:sld xmlns:a="http://schemas.openxmlformats.org/drawingml/2006/main" xmlns:r="http://schemas.openxmlformats.org/officeDocument/2006/relationships" xmlns:p="http://schemas.openxmlformats.org/presentationml/2006/main">
-  <p:cSld>
-    <p:spTree>
-      <p:nvGrpSpPr>
-        <p:cNvPr id="1" name=""/>
-        <p:cNvGrpSpPr/>
-        <p:nvPr/>
-      </p:nvGrpSpPr>
-      <p:grpSpPr>
-        <a:xfrm>
-          <a:off x="0" y="0"/>
-          <a:ext cx="0" cy="0"/>
-          <a:chOff x="0" y="0"/>
-          <a:chExt cx="0" cy="0"/>
-        </a:xfrm>
-      </p:grpSpPr>
-      <p:sp>
-        <p:nvSpPr>
-          <p:cNvPr id="2" name="Title 1"/>
-          <p:cNvSpPr>
-            <a:spLocks noGrp="1"/>
-          </p:cNvSpPr>
-          <p:nvPr>
-            <p:ph type="title"/>
-          </p:nvPr>
-        </p:nvSpPr>
-        <p:spPr/>
-        <p:txBody>
-          <a:bodyPr>
-            <a:normAutofit fontScale="90000"/>
-          </a:bodyPr>
-          <a:lstStyle/>
-          <a:p>
-            <a:r>
-              <a:rPr lang="en-US"/>
-              <a:t>2.</a:t>
-            </a:r>
-            <a:r>
-              <a:rPr lang="bg-BG"/>
-              <a:t>Избраната система за контрол на версиите </a:t>
-            </a:r>
-            <a:r>
-              <a:rPr lang="en-US"/>
-              <a:t/>
-            </a:r>
-            <a:br>
-              <a:rPr lang="en-US"/>
-            </a:br>
-            <a:endParaRPr lang="en-US"/>
-          </a:p>
-        </p:txBody>
-      </p:sp>
-      <p:sp>
-        <p:nvSpPr>
-          <p:cNvPr id="3" name="Content Placeholder 2"/>
-          <p:cNvSpPr>
-            <a:spLocks noGrp="1"/>
-          </p:cNvSpPr>
-          <p:nvPr>
-            <p:ph idx="1"/>
-          </p:nvPr>
-        </p:nvSpPr>
-        <p:spPr>
-          <a:xfrm>
-            <a:off x="58189" y="1379913"/>
-            <a:ext cx="12133811" cy="2119745"/>
-          </a:xfrm>
-        </p:spPr>
-        <p:txBody>
-          <a:bodyPr/>
-          <a:lstStyle/>
-          <a:p>
-            <a:pPr marL="0" indent="0">
-              <a:buNone/>
-            </a:pPr>
-            <a:r>
-              <a:rPr lang="bg-BG"/>
-              <a:t>Избраната система е </a:t>
-            </a:r>
-            <a:r>
-              <a:rPr lang="en-US"/>
-              <a:t>Github . </a:t>
-            </a:r>
-            <a:r>
-              <a:rPr lang="bg-BG"/>
-              <a:t>Причината за изборът , е че </a:t>
-            </a:r>
-            <a:r>
-              <a:rPr lang="en-US"/>
-              <a:t>Github</a:t>
-            </a:r>
-            <a:r>
-              <a:rPr lang="bg-BG"/>
-              <a:t> е една от най-популярните системи за контрол на версиите и изключително лесна за използване и олеснява работата в екип. Също приложението </a:t>
-            </a:r>
-            <a:r>
-              <a:rPr lang="en-US"/>
-              <a:t>Github Desktop </a:t>
-            </a:r>
-            <a:r>
-              <a:rPr lang="bg-BG"/>
-              <a:t>позволява </a:t>
-            </a:r>
-            <a:r>
-              <a:rPr lang="en-US"/>
-              <a:t>push-</a:t>
-            </a:r>
-            <a:r>
-              <a:rPr lang="bg-BG"/>
-              <a:t>ването </a:t>
-            </a:r>
-            <a:r>
-              <a:rPr lang="en-US"/>
-              <a:t>и commit-</a:t>
-            </a:r>
-            <a:r>
-              <a:rPr lang="bg-BG"/>
-              <a:t>ването на промени по-лесно , понеже не се налага да се пишат команди в конзолата.</a:t>
-            </a:r>
-            <a:endParaRPr lang="en-US"/>
-          </a:p>
-          <a:p>
-            <a:pPr marL="0" indent="0">
-              <a:buNone/>
-            </a:pPr>
-            <a:endParaRPr lang="en-US"/>
-          </a:p>
-        </p:txBody>
-      </p:sp>
-      <p:pic>
-        <p:nvPicPr>
-          <p:cNvPr id="2050" name="Picture 2" descr="Logo - Brand Toolkit"/>
-          <p:cNvPicPr>
-            <a:picLocks noChangeAspect="1" noChangeArrowheads="1"/>
-          </p:cNvPicPr>
-          <p:nvPr/>
-        </p:nvPicPr>
-        <p:blipFill>
-          <a:blip r:embed="rId2" cstate="print">
-            <a:extLst>
-              <a:ext uri="{28A0092B-C50C-407E-A947-70E740481C1C}">
-                <a14:useLocalDpi xmlns:a14="http://schemas.microsoft.com/office/drawing/2010/main" val="0"/>
-              </a:ext>
-            </a:extLst>
-          </a:blip>
-          <a:srcRect/>
-          <a:stretch>
-            <a:fillRect/>
-          </a:stretch>
-        </p:blipFill>
-        <p:spPr bwMode="auto">
-          <a:xfrm>
-            <a:off x="297028" y="4080230"/>
-            <a:ext cx="5546970" cy="2059313"/>
-          </a:xfrm>
-          <a:prstGeom prst="rect">
-            <a:avLst/>
-          </a:prstGeom>
-          <a:noFill/>
-          <a:extLst>
-            <a:ext uri="{909E8E84-426E-40DD-AFC4-6F175D3DCCD1}">
-              <a14:hiddenFill xmlns:a14="http://schemas.microsoft.com/office/drawing/2010/main">
-                <a:solidFill>
-                  <a:srgbClr val="FFFFFF"/>
-                </a:solidFill>
-              </a14:hiddenFill>
-            </a:ext>
-          </a:extLst>
-        </p:spPr>
-      </p:pic>
-      <p:pic>
-        <p:nvPicPr>
-          <p:cNvPr id="2052" name="Picture 4" descr="Getting Started with G... | Wiki | UAL Creative Computing Institute"/>
-          <p:cNvPicPr>
-            <a:picLocks noChangeAspect="1" noChangeArrowheads="1"/>
-          </p:cNvPicPr>
-          <p:nvPr/>
-        </p:nvPicPr>
-        <p:blipFill>
-          <a:blip r:embed="rId3">
-            <a:extLst>
-              <a:ext uri="{28A0092B-C50C-407E-A947-70E740481C1C}">
-                <a14:useLocalDpi xmlns:a14="http://schemas.microsoft.com/office/drawing/2010/main" val="0"/>
-              </a:ext>
-            </a:extLst>
-          </a:blip>
-          <a:srcRect/>
-          <a:stretch>
-            <a:fillRect/>
-          </a:stretch>
-        </p:blipFill>
-        <p:spPr bwMode="auto">
-          <a:xfrm>
-            <a:off x="5961289" y="4157386"/>
-            <a:ext cx="5715000" cy="1905000"/>
-          </a:xfrm>
-          <a:prstGeom prst="rect">
-            <a:avLst/>
-          </a:prstGeom>
-          <a:noFill/>
-          <a:extLst>
-            <a:ext uri="{909E8E84-426E-40DD-AFC4-6F175D3DCCD1}">
-              <a14:hiddenFill xmlns:a14="http://schemas.microsoft.com/office/drawing/2010/main">
-                <a:solidFill>
-                  <a:srgbClr val="FFFFFF"/>
-                </a:solidFill>
-              </a14:hiddenFill>
-            </a:ext>
-          </a:extLst>
-        </p:spPr>
-      </p:pic>
-    </p:spTree>
-    <p:extLst>
-      <p:ext uri="{BB962C8B-B14F-4D97-AF65-F5344CB8AC3E}">
-        <p14:creationId xmlns:p14="http://schemas.microsoft.com/office/powerpoint/2010/main" val="1432200802"/>
-      </p:ext>
-    </p:extLst>
-  </p:cSld>
-  <p:clrMapOvr>
-    <a:masterClrMapping/>
-  </p:clrMapOvr>
-</p:sld>
-</file>
-
-<file path=ppt/slides/slide4.xml><?xml version="1.0" encoding="utf-8"?>
-<p:sld xmlns:a="http://schemas.openxmlformats.org/drawingml/2006/main" xmlns:r="http://schemas.openxmlformats.org/officeDocument/2006/relationships" xmlns:p="http://schemas.openxmlformats.org/presentationml/2006/main">
-  <p:cSld>
-    <p:spTree>
-      <p:nvGrpSpPr>
-        <p:cNvPr id="1" name=""/>
-        <p:cNvGrpSpPr/>
-        <p:nvPr/>
-      </p:nvGrpSpPr>
-      <p:grpSpPr>
-        <a:xfrm>
-          <a:off x="0" y="0"/>
-          <a:ext cx="0" cy="0"/>
-          <a:chOff x="0" y="0"/>
-          <a:chExt cx="0" cy="0"/>
-        </a:xfrm>
-      </p:grpSpPr>
-      <p:sp>
-        <p:nvSpPr>
-          <p:cNvPr id="2" name="Title 1"/>
-          <p:cNvSpPr>
-            <a:spLocks noGrp="1"/>
-          </p:cNvSpPr>
-          <p:nvPr>
-            <p:ph type="title"/>
-          </p:nvPr>
-        </p:nvSpPr>
-        <p:spPr/>
-        <p:txBody>
-          <a:bodyPr>
-            <a:normAutofit fontScale="90000"/>
-          </a:bodyPr>
-          <a:lstStyle/>
-          <a:p>
-            <a:r>
-              <a:rPr lang="en-US"/>
-              <a:t>3. </a:t>
-            </a:r>
-            <a:r>
-              <a:rPr lang="bg-BG"/>
-              <a:t>Избраната система за управление на проекта</a:t>
-            </a:r>
-            <a:r>
-              <a:rPr lang="en-US"/>
-              <a:t/>
-            </a:r>
-            <a:br>
-              <a:rPr lang="en-US"/>
-            </a:br>
-            <a:endParaRPr lang="en-US"/>
-          </a:p>
-        </p:txBody>
-      </p:sp>
-      <p:pic>
-        <p:nvPicPr>
-          <p:cNvPr id="3074" name="Picture 2" descr="File:Jira Logo.svg - Wikimedia Commons"/>
-          <p:cNvPicPr>
-            <a:picLocks noGrp="1" noChangeAspect="1" noChangeArrowheads="1"/>
-          </p:cNvPicPr>
-          <p:nvPr>
-            <p:ph idx="1"/>
-          </p:nvPr>
-        </p:nvPicPr>
-        <p:blipFill>
-          <a:blip r:embed="rId2" cstate="print">
-            <a:extLst>
-              <a:ext uri="{28A0092B-C50C-407E-A947-70E740481C1C}">
-                <a14:useLocalDpi xmlns:a14="http://schemas.microsoft.com/office/drawing/2010/main" val="0"/>
-              </a:ext>
-            </a:extLst>
-          </a:blip>
-          <a:srcRect/>
-          <a:stretch>
-            <a:fillRect/>
-          </a:stretch>
-        </p:blipFill>
-        <p:spPr bwMode="auto">
-          <a:xfrm>
-            <a:off x="1176034" y="1690688"/>
-            <a:ext cx="2394480" cy="1008301"/>
-          </a:xfrm>
-          <a:prstGeom prst="rect">
-            <a:avLst/>
-          </a:prstGeom>
-          <a:noFill/>
-          <a:extLst>
-            <a:ext uri="{909E8E84-426E-40DD-AFC4-6F175D3DCCD1}">
-              <a14:hiddenFill xmlns:a14="http://schemas.microsoft.com/office/drawing/2010/main">
-                <a:solidFill>
-                  <a:srgbClr val="FFFFFF"/>
-                </a:solidFill>
-              </a14:hiddenFill>
-            </a:ext>
-          </a:extLst>
-        </p:spPr>
-      </p:pic>
-    </p:spTree>
-    <p:extLst>
-      <p:ext uri="{BB962C8B-B14F-4D97-AF65-F5344CB8AC3E}">
-        <p14:creationId xmlns:p14="http://schemas.microsoft.com/office/powerpoint/2010/main" val="1157703078"/>
-      </p:ext>
-    </p:extLst>
-  </p:cSld>
-  <p:clrMapOvr>
-    <a:masterClrMapping/>
-  </p:clrMapOvr>
-</p:sld>
-</file>
-
-<file path=ppt/slides/slide5.xml><?xml version="1.0" encoding="utf-8"?>
-<p:sld xmlns:a="http://schemas.openxmlformats.org/drawingml/2006/main" xmlns:r="http://schemas.openxmlformats.org/officeDocument/2006/relationships" xmlns:p="http://schemas.openxmlformats.org/presentationml/2006/main">
-  <p:cSld>
-    <p:spTree>
-      <p:nvGrpSpPr>
-        <p:cNvPr id="1" name=""/>
-        <p:cNvGrpSpPr/>
-        <p:nvPr/>
-      </p:nvGrpSpPr>
-      <p:grpSpPr>
-        <a:xfrm>
-          <a:off x="0" y="0"/>
-          <a:ext cx="0" cy="0"/>
-          <a:chOff x="0" y="0"/>
-          <a:chExt cx="0" cy="0"/>
-        </a:xfrm>
-      </p:grpSpPr>
-      <p:sp>
-        <p:nvSpPr>
-          <p:cNvPr id="2" name="Title 1"/>
-          <p:cNvSpPr>
-            <a:spLocks noGrp="1"/>
-          </p:cNvSpPr>
-          <p:nvPr>
-            <p:ph type="title"/>
-          </p:nvPr>
-        </p:nvSpPr>
-        <p:spPr/>
-        <p:txBody>
-          <a:bodyPr/>
-          <a:lstStyle/>
-          <a:p>
-            <a:r>
-              <a:rPr lang="en-US"/>
-              <a:t>4.Web </a:t>
-            </a:r>
-            <a:r>
-              <a:rPr lang="bg-BG"/>
-              <a:t>Приложение</a:t>
-            </a:r>
-            <a:r>
-              <a:rPr lang="en-US"/>
-              <a:t/>
-            </a:r>
-            <a:br>
-              <a:rPr lang="en-US"/>
-            </a:br>
-            <a:endParaRPr lang="en-US"/>
-          </a:p>
-        </p:txBody>
-      </p:sp>
-      <p:sp>
-        <p:nvSpPr>
-          <p:cNvPr id="3" name="Content Placeholder 2"/>
-          <p:cNvSpPr>
-            <a:spLocks noGrp="1"/>
-          </p:cNvSpPr>
-          <p:nvPr>
-            <p:ph idx="1"/>
-          </p:nvPr>
-        </p:nvSpPr>
-        <p:spPr>
-          <a:xfrm>
-            <a:off x="838200" y="1520825"/>
-            <a:ext cx="10515600" cy="1425575"/>
-          </a:xfrm>
-        </p:spPr>
-        <p:txBody>
-          <a:bodyPr/>
-          <a:lstStyle/>
-          <a:p>
-            <a:pPr marL="0" indent="0">
-              <a:buNone/>
-            </a:pPr>
-            <a:r>
-              <a:rPr lang="bg-BG"/>
-              <a:t>Проектът е под формата на </a:t>
-            </a:r>
-            <a:r>
-              <a:rPr lang="en-US"/>
-              <a:t>Web </a:t>
-            </a:r>
-            <a:r>
-              <a:rPr lang="bg-BG"/>
-              <a:t>приложение . Това е поради използваната технология </a:t>
-            </a:r>
-            <a:r>
-              <a:rPr lang="en-US"/>
-              <a:t>.NET Web App </a:t>
-            </a:r>
-            <a:r>
-              <a:rPr lang="bg-BG"/>
-              <a:t>със структура </a:t>
-            </a:r>
-            <a:r>
-              <a:rPr lang="en-US"/>
-              <a:t>MVC (Model View Controller).</a:t>
-            </a:r>
-          </a:p>
-          <a:p>
-            <a:endParaRPr lang="en-US"/>
-          </a:p>
-        </p:txBody>
-      </p:sp>
-      <p:pic>
-        <p:nvPicPr>
-          <p:cNvPr id="4" name="Picture 3"/>
-          <p:cNvPicPr>
-            <a:picLocks noChangeAspect="1"/>
-          </p:cNvPicPr>
-          <p:nvPr/>
-        </p:nvPicPr>
-        <p:blipFill>
-          <a:blip r:embed="rId2"/>
-          <a:stretch>
-            <a:fillRect/>
-          </a:stretch>
-        </p:blipFill>
-        <p:spPr>
-          <a:xfrm>
-            <a:off x="1568070" y="2846388"/>
-            <a:ext cx="8573457" cy="3915001"/>
-          </a:xfrm>
-          <a:prstGeom prst="rect">
-            <a:avLst/>
-          </a:prstGeom>
-        </p:spPr>
-      </p:pic>
-    </p:spTree>
-    <p:extLst>
-      <p:ext uri="{BB962C8B-B14F-4D97-AF65-F5344CB8AC3E}">
-        <p14:creationId xmlns:p14="http://schemas.microsoft.com/office/powerpoint/2010/main" val="1685781362"/>
-      </p:ext>
-    </p:extLst>
-  </p:cSld>
-  <p:clrMapOvr>
-    <a:masterClrMapping/>
-  </p:clrMapOvr>
-</p:sld>
-</file>
-
-<file path=ppt/slides/slide6.xml><?xml version="1.0" encoding="utf-8"?>
-<p:sld xmlns:a="http://schemas.openxmlformats.org/drawingml/2006/main" xmlns:r="http://schemas.openxmlformats.org/officeDocument/2006/relationships" xmlns:p="http://schemas.openxmlformats.org/presentationml/2006/main">
-  <p:cSld>
-    <p:spTree>
-      <p:nvGrpSpPr>
-        <p:cNvPr id="1" name=""/>
-        <p:cNvGrpSpPr/>
-        <p:nvPr/>
-      </p:nvGrpSpPr>
-      <p:grpSpPr>
-        <a:xfrm>
-          <a:off x="0" y="0"/>
-          <a:ext cx="0" cy="0"/>
-          <a:chOff x="0" y="0"/>
-          <a:chExt cx="0" cy="0"/>
-        </a:xfrm>
-      </p:grpSpPr>
-      <p:sp>
-        <p:nvSpPr>
-          <p:cNvPr id="2" name="Title 1"/>
-          <p:cNvSpPr>
-            <a:spLocks noGrp="1"/>
-          </p:cNvSpPr>
-          <p:nvPr>
-            <p:ph type="title"/>
-          </p:nvPr>
-        </p:nvSpPr>
-        <p:spPr/>
-        <p:txBody>
-          <a:bodyPr/>
-          <a:lstStyle/>
-          <a:p>
-            <a:r>
-              <a:rPr lang="bg-BG"/>
-              <a:t>5.Използвани функционалности</a:t>
-            </a:r>
-            <a:r>
-              <a:rPr lang="en-US"/>
-              <a:t/>
-            </a:r>
-            <a:br>
-              <a:rPr lang="en-US"/>
-            </a:br>
-            <a:endParaRPr lang="en-US"/>
-          </a:p>
-        </p:txBody>
-      </p:sp>
-      <p:sp>
-        <p:nvSpPr>
-          <p:cNvPr id="3" name="Content Placeholder 2"/>
-          <p:cNvSpPr>
-            <a:spLocks noGrp="1"/>
-          </p:cNvSpPr>
-          <p:nvPr>
-            <p:ph idx="1"/>
-          </p:nvPr>
-        </p:nvSpPr>
-        <p:spPr>
-          <a:xfrm>
-            <a:off x="58189" y="1168920"/>
-            <a:ext cx="12133811" cy="2380615"/>
-          </a:xfrm>
-        </p:spPr>
-        <p:txBody>
-          <a:bodyPr>
-            <a:normAutofit lnSpcReduction="10000"/>
-          </a:bodyPr>
-          <a:lstStyle/>
-          <a:p>
-            <a:pPr marL="0" indent="0">
-              <a:buNone/>
-            </a:pPr>
-            <a:r>
-              <a:rPr lang="bg-BG"/>
-              <a:t>Приложението дава възможност на потребителите да добавят , променят и изтриват песни . След като една песен е добавена , тя може да се види в </a:t>
-            </a:r>
-            <a:r>
-              <a:rPr lang="en-US"/>
-              <a:t>Home Page-</a:t>
-            </a:r>
-            <a:r>
-              <a:rPr lang="bg-BG"/>
-              <a:t>а на приложението , от където също може да се ходи директно в </a:t>
-            </a:r>
-            <a:r>
-              <a:rPr lang="en-US"/>
-              <a:t>Wikipedia  </a:t>
-            </a:r>
-            <a:r>
-              <a:rPr lang="bg-BG"/>
-              <a:t>и </a:t>
-            </a:r>
-            <a:r>
-              <a:rPr lang="en-US"/>
-              <a:t>Youtube </a:t>
-            </a:r>
-            <a:r>
-              <a:rPr lang="bg-BG"/>
-              <a:t>страниците на песента ( ако са добавени адресите към данните на песента). Песни могат да се търсят по техните създатели , име , жанр и година.</a:t>
-            </a:r>
-            <a:endParaRPr lang="en-US"/>
-          </a:p>
-          <a:p>
-            <a:endParaRPr lang="en-US"/>
-          </a:p>
-        </p:txBody>
-      </p:sp>
-      <p:pic>
-        <p:nvPicPr>
-          <p:cNvPr id="4" name="Picture 3"/>
-          <p:cNvPicPr>
-            <a:picLocks noChangeAspect="1"/>
-          </p:cNvPicPr>
-          <p:nvPr/>
-        </p:nvPicPr>
-        <p:blipFill>
-          <a:blip r:embed="rId2"/>
-          <a:stretch>
-            <a:fillRect/>
-          </a:stretch>
-        </p:blipFill>
-        <p:spPr>
-          <a:xfrm>
-            <a:off x="174568" y="3356091"/>
-            <a:ext cx="6916188" cy="3105150"/>
-          </a:xfrm>
-          <a:prstGeom prst="rect">
-            <a:avLst/>
-          </a:prstGeom>
-        </p:spPr>
-      </p:pic>
-      <p:pic>
-        <p:nvPicPr>
-          <p:cNvPr id="5" name="Picture 4"/>
-          <p:cNvPicPr>
-            <a:picLocks noChangeAspect="1"/>
-          </p:cNvPicPr>
-          <p:nvPr/>
-        </p:nvPicPr>
-        <p:blipFill>
-          <a:blip r:embed="rId3"/>
-          <a:stretch>
-            <a:fillRect/>
-          </a:stretch>
-        </p:blipFill>
-        <p:spPr>
-          <a:xfrm>
-            <a:off x="9102436" y="2913348"/>
-            <a:ext cx="2933354" cy="2092039"/>
-          </a:xfrm>
-          <a:prstGeom prst="rect">
-            <a:avLst/>
-          </a:prstGeom>
-        </p:spPr>
-      </p:pic>
-      <p:pic>
-        <p:nvPicPr>
-          <p:cNvPr id="6" name="Picture 5"/>
-          <p:cNvPicPr>
-            <a:picLocks noChangeAspect="1"/>
-          </p:cNvPicPr>
-          <p:nvPr/>
-        </p:nvPicPr>
-        <p:blipFill>
-          <a:blip r:embed="rId4"/>
-          <a:stretch>
-            <a:fillRect/>
-          </a:stretch>
-        </p:blipFill>
-        <p:spPr>
-          <a:xfrm>
-            <a:off x="8019963" y="5293963"/>
-            <a:ext cx="4087004" cy="1360952"/>
-          </a:xfrm>
-          <a:prstGeom prst="rect">
-            <a:avLst/>
-          </a:prstGeom>
-        </p:spPr>
-      </p:pic>
-    </p:spTree>
-    <p:extLst>
-      <p:ext uri="{BB962C8B-B14F-4D97-AF65-F5344CB8AC3E}">
-        <p14:creationId xmlns:p14="http://schemas.microsoft.com/office/powerpoint/2010/main" val="3479705222"/>
-      </p:ext>
-    </p:extLst>
-  </p:cSld>
-  <p:clrMapOvr>
-    <a:masterClrMapping/>
-  </p:clrMapOvr>
-</p:sld>
-</file>
-
-<file path=ppt/slides/slide7.xml><?xml version="1.0" encoding="utf-8"?>
-<p:sld xmlns:a="http://schemas.openxmlformats.org/drawingml/2006/main" xmlns:r="http://schemas.openxmlformats.org/officeDocument/2006/relationships" xmlns:p="http://schemas.openxmlformats.org/presentationml/2006/main">
-  <p:cSld>
-    <p:spTree>
-      <p:nvGrpSpPr>
-        <p:cNvPr id="1" name=""/>
-        <p:cNvGrpSpPr/>
-        <p:nvPr/>
-      </p:nvGrpSpPr>
-      <p:grpSpPr>
-        <a:xfrm>
-          <a:off x="0" y="0"/>
-          <a:ext cx="0" cy="0"/>
-          <a:chOff x="0" y="0"/>
-          <a:chExt cx="0" cy="0"/>
-        </a:xfrm>
-      </p:grpSpPr>
-      <p:sp>
-        <p:nvSpPr>
-          <p:cNvPr id="2" name="Title 1"/>
-          <p:cNvSpPr>
-            <a:spLocks noGrp="1"/>
-          </p:cNvSpPr>
-          <p:nvPr>
-            <p:ph type="title"/>
-          </p:nvPr>
-        </p:nvSpPr>
-        <p:spPr/>
-        <p:txBody>
-          <a:bodyPr>
-            <a:normAutofit fontScale="90000"/>
-          </a:bodyPr>
-          <a:lstStyle/>
-          <a:p>
-            <a:r>
-              <a:rPr lang="bg-BG"/>
-              <a:t>6. </a:t>
-            </a:r>
-            <a:r>
-              <a:rPr lang="ru-RU"/>
-              <a:t>Обосновка и разяснения към избраната методология за разработка на софтуера</a:t>
-            </a:r>
-            <a:r>
-              <a:rPr lang="en-US"/>
-              <a:t/>
-            </a:r>
-            <a:br>
-              <a:rPr lang="en-US"/>
-            </a:br>
-            <a:endParaRPr lang="en-US"/>
-          </a:p>
-        </p:txBody>
-      </p:sp>
-      <p:sp>
-        <p:nvSpPr>
-          <p:cNvPr id="3" name="Content Placeholder 2"/>
-          <p:cNvSpPr>
-            <a:spLocks noGrp="1"/>
-          </p:cNvSpPr>
-          <p:nvPr>
-            <p:ph idx="1"/>
-          </p:nvPr>
-        </p:nvSpPr>
-        <p:spPr/>
-        <p:txBody>
-          <a:bodyPr/>
-          <a:lstStyle/>
-          <a:p>
-            <a:pPr marL="0" indent="0">
-              <a:buNone/>
-            </a:pPr>
-            <a:r>
-              <a:rPr lang="bg-BG"/>
-              <a:t>Използваната методология е </a:t>
-            </a:r>
-            <a:r>
-              <a:rPr lang="en-US"/>
-              <a:t>Kanban . </a:t>
-            </a:r>
-          </a:p>
-          <a:p>
-            <a:endParaRPr lang="en-US"/>
-          </a:p>
-        </p:txBody>
-      </p:sp>
-    </p:spTree>
-    <p:extLst>
-      <p:ext uri="{BB962C8B-B14F-4D97-AF65-F5344CB8AC3E}">
-        <p14:creationId xmlns:p14="http://schemas.microsoft.com/office/powerpoint/2010/main" val="3916397861"/>
-      </p:ext>
-    </p:extLst>
-  </p:cSld>
-  <p:clrMapOvr>
-    <a:masterClrMapping/>
-  </p:clrMapOvr>
-</p:sld>
-</file>
-
-<file path=ppt/slides/slide8.xml><?xml version="1.0" encoding="utf-8"?>
-<p:sld xmlns:a="http://schemas.openxmlformats.org/drawingml/2006/main" xmlns:r="http://schemas.openxmlformats.org/officeDocument/2006/relationships" xmlns:p="http://schemas.openxmlformats.org/presentationml/2006/main">
-  <p:cSld>
-    <p:spTree>
-      <p:nvGrpSpPr>
-        <p:cNvPr id="1" name=""/>
-        <p:cNvGrpSpPr/>
-        <p:nvPr/>
-      </p:nvGrpSpPr>
-      <p:grpSpPr>
-        <a:xfrm>
-          <a:off x="0" y="0"/>
-          <a:ext cx="0" cy="0"/>
-          <a:chOff x="0" y="0"/>
-          <a:chExt cx="0" cy="0"/>
-        </a:xfrm>
-      </p:grpSpPr>
-      <p:sp>
-        <p:nvSpPr>
-          <p:cNvPr id="2" name="Title 1"/>
-          <p:cNvSpPr>
-            <a:spLocks noGrp="1"/>
-          </p:cNvSpPr>
-          <p:nvPr>
-            <p:ph type="title"/>
-          </p:nvPr>
-        </p:nvSpPr>
-        <p:spPr/>
-        <p:txBody>
-          <a:bodyPr>
-            <a:normAutofit fontScale="90000"/>
-          </a:bodyPr>
-          <a:lstStyle/>
-          <a:p>
-            <a:r>
-              <a:rPr lang="en-US"/>
-              <a:t>7.</a:t>
-            </a:r>
-            <a:r>
-              <a:rPr lang="bg-BG"/>
-              <a:t>И</a:t>
-            </a:r>
-            <a:r>
-              <a:rPr lang="ru-RU"/>
-              <a:t>збор на програмни средства за реализацията </a:t>
-            </a:r>
-            <a:r>
-              <a:rPr lang="en-US"/>
-              <a:t/>
-            </a:r>
-            <a:br>
-              <a:rPr lang="en-US"/>
-            </a:br>
-            <a:endParaRPr lang="en-US"/>
+            <a:endParaRPr lang="bg-BG" noProof="0" dirty="0"/>
           </a:p>
         </p:txBody>
       </p:sp>
@@ -4206,106 +3102,97 @@
               <a:buNone/>
             </a:pPr>
             <a:r>
-              <a:rPr lang="ru-RU"/>
-              <a:t>Избраният програмен език за проекта е </a:t>
-            </a:r>
-            <a:r>
-              <a:rPr lang="en-US"/>
-              <a:t>C# , </a:t>
-            </a:r>
-            <a:r>
-              <a:rPr lang="bg-BG"/>
-              <a:t>а избраната среда за разработка е </a:t>
-            </a:r>
-            <a:r>
-              <a:rPr lang="en-US"/>
-              <a:t>Microsoft Visual Studio . </a:t>
-            </a:r>
-            <a:r>
-              <a:rPr lang="bg-BG"/>
-              <a:t>Причинините за избора са , че </a:t>
-            </a:r>
-            <a:r>
-              <a:rPr lang="en-US"/>
-              <a:t>Microsoft Visual Studio </a:t>
-            </a:r>
-            <a:r>
-              <a:rPr lang="bg-BG"/>
-              <a:t>е направено специално за използването на </a:t>
-            </a:r>
-            <a:r>
-              <a:rPr lang="en-US"/>
-              <a:t>C# , </a:t>
-            </a:r>
-            <a:r>
-              <a:rPr lang="bg-BG"/>
-              <a:t>а </a:t>
-            </a:r>
-            <a:r>
-              <a:rPr lang="en-US"/>
-              <a:t>C# </a:t>
-            </a:r>
-            <a:r>
-              <a:rPr lang="bg-BG"/>
-              <a:t>позволява достъпа до </a:t>
-            </a:r>
-            <a:r>
-              <a:rPr lang="en-US"/>
-              <a:t>.NET </a:t>
-            </a:r>
-            <a:r>
-              <a:rPr lang="bg-BG"/>
-              <a:t>библиотеките за създаване на </a:t>
-            </a:r>
-            <a:r>
-              <a:rPr lang="en-US"/>
-              <a:t>Web </a:t>
-            </a:r>
-            <a:r>
-              <a:rPr lang="bg-BG"/>
-              <a:t>апликации . Използваната среда за съхранение на базата данни е </a:t>
-            </a:r>
-            <a:r>
-              <a:rPr lang="en-US"/>
-              <a:t>Microsoft Server Management Studio , </a:t>
-            </a:r>
-            <a:r>
-              <a:rPr lang="bg-BG"/>
-              <a:t>поради това че функционира добре с </a:t>
-            </a:r>
-            <a:r>
-              <a:rPr lang="en-US"/>
-              <a:t>.NET </a:t>
-            </a:r>
-            <a:r>
-              <a:rPr lang="bg-BG"/>
-              <a:t>приложения (защото също е направена от </a:t>
-            </a:r>
-            <a:r>
-              <a:rPr lang="en-US"/>
-              <a:t>Microsoft).</a:t>
-            </a:r>
-            <a:r>
-              <a:rPr lang="bg-BG"/>
-              <a:t> Използвани са също и езиците </a:t>
-            </a:r>
-            <a:r>
-              <a:rPr lang="en-US"/>
-              <a:t>JavaScript/Html/CSS , </a:t>
-            </a:r>
-            <a:r>
-              <a:rPr lang="bg-BG"/>
-              <a:t>защото те са стандартните програмни езици за работа с </a:t>
-            </a:r>
-            <a:r>
-              <a:rPr lang="en-US"/>
-              <a:t>Web </a:t>
-            </a:r>
-            <a:r>
-              <a:rPr lang="bg-BG"/>
-              <a:t>приложения и сайтове.</a:t>
-            </a:r>
-            <a:endParaRPr lang="en-US"/>
+              <a:rPr lang="bg-BG" noProof="0" dirty="0"/>
+              <a:t>Избраният програмен език за проекта е C# , а избраната среда за разработка е Microsoft </a:t>
+            </a:r>
+            <a:r>
+              <a:rPr lang="bg-BG" noProof="0" dirty="0" err="1"/>
+              <a:t>Visual</a:t>
+            </a:r>
+            <a:r>
+              <a:rPr lang="bg-BG" noProof="0" dirty="0"/>
+              <a:t> </a:t>
+            </a:r>
+            <a:r>
+              <a:rPr lang="bg-BG" noProof="0" dirty="0" err="1"/>
+              <a:t>Studio</a:t>
+            </a:r>
+            <a:r>
+              <a:rPr lang="bg-BG" noProof="0" dirty="0"/>
+              <a:t> . </a:t>
+            </a:r>
+            <a:r>
+              <a:rPr lang="bg-BG" noProof="0" dirty="0" err="1"/>
+              <a:t>Причинините</a:t>
+            </a:r>
+            <a:r>
+              <a:rPr lang="bg-BG" noProof="0" dirty="0"/>
+              <a:t> за избора са , че Microsoft </a:t>
+            </a:r>
+            <a:r>
+              <a:rPr lang="bg-BG" noProof="0" dirty="0" err="1"/>
+              <a:t>Visual</a:t>
+            </a:r>
+            <a:r>
+              <a:rPr lang="bg-BG" noProof="0" dirty="0"/>
+              <a:t> </a:t>
+            </a:r>
+            <a:r>
+              <a:rPr lang="bg-BG" noProof="0" dirty="0" err="1"/>
+              <a:t>Studio</a:t>
+            </a:r>
+            <a:r>
+              <a:rPr lang="bg-BG" noProof="0" dirty="0"/>
+              <a:t> е направено специално за използването на C# , а C# позволява достъпа до .NET библиотеките за създаване на </a:t>
+            </a:r>
+            <a:r>
+              <a:rPr lang="bg-BG" noProof="0" dirty="0" err="1"/>
+              <a:t>Web</a:t>
+            </a:r>
+            <a:r>
+              <a:rPr lang="bg-BG" noProof="0" dirty="0"/>
+              <a:t> апликации . Използваната среда за съхранение на базата данни е Microsoft Server </a:t>
+            </a:r>
+            <a:r>
+              <a:rPr lang="bg-BG" noProof="0" dirty="0" err="1"/>
+              <a:t>Management</a:t>
+            </a:r>
+            <a:r>
+              <a:rPr lang="bg-BG" noProof="0" dirty="0"/>
+              <a:t> </a:t>
+            </a:r>
+            <a:r>
+              <a:rPr lang="bg-BG" noProof="0" dirty="0" err="1"/>
+              <a:t>Studio</a:t>
+            </a:r>
+            <a:r>
+              <a:rPr lang="bg-BG" noProof="0" dirty="0"/>
+              <a:t> , поради това че функционира добре с .NET приложения (защото също е направена от Microsoft). Използвани са също и езиците </a:t>
+            </a:r>
+            <a:r>
+              <a:rPr lang="bg-BG" noProof="0" dirty="0" err="1"/>
+              <a:t>JavaScript</a:t>
+            </a:r>
+            <a:r>
+              <a:rPr lang="bg-BG" noProof="0" dirty="0"/>
+              <a:t>/</a:t>
+            </a:r>
+            <a:r>
+              <a:rPr lang="bg-BG" noProof="0" dirty="0" err="1"/>
+              <a:t>Html</a:t>
+            </a:r>
+            <a:r>
+              <a:rPr lang="bg-BG" noProof="0" dirty="0"/>
+              <a:t>/CSS , защото те са стандартните програмни езици за работа с </a:t>
+            </a:r>
+            <a:r>
+              <a:rPr lang="bg-BG" noProof="0" dirty="0" err="1"/>
+              <a:t>Web</a:t>
+            </a:r>
+            <a:r>
+              <a:rPr lang="bg-BG" noProof="0" dirty="0"/>
+              <a:t> приложения и сайтове.</a:t>
+            </a:r>
           </a:p>
         </p:txBody>
       </p:sp>
@@ -4568,6 +3455,1384 @@
 </p:sld>
 </file>
 
+<file path=ppt/slides/slide11.xml><?xml version="1.0" encoding="utf-8"?>
+<p:sld xmlns:a="http://schemas.openxmlformats.org/drawingml/2006/main" xmlns:r="http://schemas.openxmlformats.org/officeDocument/2006/relationships" xmlns:p="http://schemas.openxmlformats.org/presentationml/2006/main">
+  <p:cSld>
+    <p:spTree>
+      <p:nvGrpSpPr>
+        <p:cNvPr id="1" name=""/>
+        <p:cNvGrpSpPr/>
+        <p:nvPr/>
+      </p:nvGrpSpPr>
+      <p:grpSpPr>
+        <a:xfrm>
+          <a:off x="0" y="0"/>
+          <a:ext cx="0" cy="0"/>
+          <a:chOff x="0" y="0"/>
+          <a:chExt cx="0" cy="0"/>
+        </a:xfrm>
+      </p:grpSpPr>
+      <p:sp>
+        <p:nvSpPr>
+          <p:cNvPr id="2" name="Title 1"/>
+          <p:cNvSpPr>
+            <a:spLocks noGrp="1"/>
+          </p:cNvSpPr>
+          <p:nvPr>
+            <p:ph type="title"/>
+          </p:nvPr>
+        </p:nvSpPr>
+        <p:spPr/>
+        <p:txBody>
+          <a:bodyPr>
+            <a:normAutofit fontScale="90000"/>
+          </a:bodyPr>
+          <a:lstStyle/>
+          <a:p>
+            <a:pPr algn="ctr"/>
+            <a:r>
+              <a:rPr lang="bg-BG" noProof="0" dirty="0"/>
+              <a:t>Стъпки, зависещи от конкретния подход за разработка</a:t>
+            </a:r>
+            <a:br>
+              <a:rPr lang="bg-BG" noProof="0" dirty="0"/>
+            </a:br>
+            <a:endParaRPr lang="bg-BG" noProof="0" dirty="0"/>
+          </a:p>
+        </p:txBody>
+      </p:sp>
+      <p:sp>
+        <p:nvSpPr>
+          <p:cNvPr id="3" name="Content Placeholder 2"/>
+          <p:cNvSpPr>
+            <a:spLocks noGrp="1"/>
+          </p:cNvSpPr>
+          <p:nvPr>
+            <p:ph idx="1"/>
+          </p:nvPr>
+        </p:nvSpPr>
+        <p:spPr/>
+        <p:txBody>
+          <a:bodyPr>
+            <a:normAutofit fontScale="92500" lnSpcReduction="10000"/>
+          </a:bodyPr>
+          <a:lstStyle/>
+          <a:p>
+            <a:pPr marL="0" indent="0">
+              <a:buNone/>
+            </a:pPr>
+            <a:r>
+              <a:rPr lang="bg-BG" noProof="0" dirty="0"/>
+              <a:t>Използваната за създаване на проекта MVC структура , изисква някои спецификации , за да може да функционира приложението. Трябва да се </a:t>
+            </a:r>
+            <a:r>
+              <a:rPr lang="bg-BG" noProof="0" dirty="0" err="1"/>
+              <a:t>останови</a:t>
+            </a:r>
+            <a:r>
+              <a:rPr lang="bg-BG" noProof="0" dirty="0"/>
+              <a:t> връзка към базата данни  , за да може да се съхраняват и взимат данните за песни в приложението . Трябва да се направят модели , чрез които се създават обекти . Нужни са контролери , които да съдържат логиката за работа с обектите направени от моделите . </a:t>
+            </a:r>
+            <a:r>
+              <a:rPr lang="bg-BG" noProof="0" dirty="0" err="1"/>
+              <a:t>ViewModels</a:t>
+            </a:r>
+            <a:r>
+              <a:rPr lang="bg-BG" noProof="0" dirty="0"/>
+              <a:t> са класове, които се използват за да помагат с четенето и писането на данни в обектите, като различните </a:t>
+            </a:r>
+            <a:r>
+              <a:rPr lang="bg-BG" noProof="0" dirty="0" err="1"/>
+              <a:t>ViewModel</a:t>
+            </a:r>
+            <a:r>
+              <a:rPr lang="bg-BG" noProof="0" dirty="0"/>
+              <a:t>-и имат различен подбор от данни, които да използват за различни страници от </a:t>
+            </a:r>
+            <a:r>
+              <a:rPr lang="bg-BG" noProof="0" dirty="0" err="1"/>
+              <a:t>Web</a:t>
+            </a:r>
+            <a:r>
+              <a:rPr lang="bg-BG" noProof="0" dirty="0"/>
+              <a:t> приложението. </a:t>
+            </a:r>
+            <a:r>
+              <a:rPr lang="bg-BG" noProof="0" dirty="0" err="1"/>
+              <a:t>View</a:t>
+            </a:r>
+            <a:r>
+              <a:rPr lang="bg-BG" noProof="0" dirty="0"/>
+              <a:t>-тата са структурите на страниците в приложението. Те представляват  как ще изглежда и как ще е структурирана една страница. </a:t>
+            </a:r>
+          </a:p>
+          <a:p>
+            <a:endParaRPr lang="bg-BG" noProof="0" dirty="0"/>
+          </a:p>
+        </p:txBody>
+      </p:sp>
+    </p:spTree>
+    <p:extLst>
+      <p:ext uri="{BB962C8B-B14F-4D97-AF65-F5344CB8AC3E}">
+        <p14:creationId xmlns:p14="http://schemas.microsoft.com/office/powerpoint/2010/main" val="3329442785"/>
+      </p:ext>
+    </p:extLst>
+  </p:cSld>
+  <p:clrMapOvr>
+    <a:masterClrMapping/>
+  </p:clrMapOvr>
+</p:sld>
+</file>
+
+<file path=ppt/slides/slide12.xml><?xml version="1.0" encoding="utf-8"?>
+<p:sld xmlns:a="http://schemas.openxmlformats.org/drawingml/2006/main" xmlns:r="http://schemas.openxmlformats.org/officeDocument/2006/relationships" xmlns:p="http://schemas.openxmlformats.org/presentationml/2006/main">
+  <p:cSld>
+    <p:spTree>
+      <p:nvGrpSpPr>
+        <p:cNvPr id="1" name=""/>
+        <p:cNvGrpSpPr/>
+        <p:nvPr/>
+      </p:nvGrpSpPr>
+      <p:grpSpPr>
+        <a:xfrm>
+          <a:off x="0" y="0"/>
+          <a:ext cx="0" cy="0"/>
+          <a:chOff x="0" y="0"/>
+          <a:chExt cx="0" cy="0"/>
+        </a:xfrm>
+      </p:grpSpPr>
+      <p:sp>
+        <p:nvSpPr>
+          <p:cNvPr id="2" name="Title 1"/>
+          <p:cNvSpPr>
+            <a:spLocks noGrp="1"/>
+          </p:cNvSpPr>
+          <p:nvPr>
+            <p:ph type="title"/>
+          </p:nvPr>
+        </p:nvSpPr>
+        <p:spPr>
+          <a:xfrm>
+            <a:off x="838200" y="365125"/>
+            <a:ext cx="8570720" cy="1325563"/>
+          </a:xfrm>
+        </p:spPr>
+        <p:txBody>
+          <a:bodyPr/>
+          <a:lstStyle/>
+          <a:p>
+            <a:pPr algn="ctr"/>
+            <a:r>
+              <a:rPr lang="bg-BG" noProof="0" dirty="0"/>
+              <a:t>Използвани класове</a:t>
+            </a:r>
+            <a:br>
+              <a:rPr lang="bg-BG" noProof="0" dirty="0"/>
+            </a:br>
+            <a:endParaRPr lang="bg-BG" noProof="0" dirty="0"/>
+          </a:p>
+        </p:txBody>
+      </p:sp>
+      <p:sp>
+        <p:nvSpPr>
+          <p:cNvPr id="3" name="Content Placeholder 2"/>
+          <p:cNvSpPr>
+            <a:spLocks noGrp="1"/>
+          </p:cNvSpPr>
+          <p:nvPr>
+            <p:ph idx="1"/>
+          </p:nvPr>
+        </p:nvSpPr>
+        <p:spPr>
+          <a:xfrm>
+            <a:off x="0" y="1038224"/>
+            <a:ext cx="8801100" cy="5819775"/>
+          </a:xfrm>
+        </p:spPr>
+        <p:txBody>
+          <a:bodyPr>
+            <a:normAutofit fontScale="85000" lnSpcReduction="20000"/>
+          </a:bodyPr>
+          <a:lstStyle/>
+          <a:p>
+            <a:r>
+              <a:rPr lang="bg-BG" noProof="0" dirty="0" err="1"/>
+              <a:t>Program</a:t>
+            </a:r>
+            <a:r>
+              <a:rPr lang="bg-BG" noProof="0" dirty="0"/>
+              <a:t> – Класът, който съдържа логиката за подкарване на </a:t>
+            </a:r>
+            <a:r>
+              <a:rPr lang="bg-BG" noProof="0" dirty="0" err="1"/>
+              <a:t>web</a:t>
+            </a:r>
+            <a:r>
+              <a:rPr lang="bg-BG" noProof="0" dirty="0"/>
+              <a:t> апликацията.</a:t>
+            </a:r>
+          </a:p>
+          <a:p>
+            <a:r>
+              <a:rPr lang="bg-BG" noProof="0" dirty="0" err="1"/>
+              <a:t>ApplicationDbContext</a:t>
+            </a:r>
+            <a:r>
+              <a:rPr lang="bg-BG" noProof="0" dirty="0"/>
+              <a:t> – В този клас се съдържа информацията за песните, </a:t>
+            </a:r>
+            <a:r>
+              <a:rPr lang="bg-BG" noProof="0" dirty="0" err="1"/>
+              <a:t>коята</a:t>
+            </a:r>
+            <a:r>
+              <a:rPr lang="bg-BG" noProof="0" dirty="0"/>
+              <a:t> се </a:t>
+            </a:r>
+            <a:r>
+              <a:rPr lang="bg-BG" noProof="0" dirty="0" err="1"/>
+              <a:t>извилича</a:t>
+            </a:r>
+            <a:r>
+              <a:rPr lang="bg-BG" noProof="0" dirty="0"/>
+              <a:t> от базата данни, и от </a:t>
+            </a:r>
+            <a:r>
+              <a:rPr lang="bg-BG" noProof="0" dirty="0" err="1"/>
+              <a:t>коята</a:t>
+            </a:r>
+            <a:r>
+              <a:rPr lang="bg-BG" noProof="0" dirty="0"/>
+              <a:t> се пише в базата данни.</a:t>
+            </a:r>
+          </a:p>
+          <a:p>
+            <a:r>
+              <a:rPr lang="bg-BG" noProof="0" dirty="0" err="1"/>
+              <a:t>Song</a:t>
+            </a:r>
+            <a:r>
+              <a:rPr lang="bg-BG" noProof="0" dirty="0"/>
+              <a:t> – Това е класът модел, който служи за създаване на обектите за песни.</a:t>
+            </a:r>
+          </a:p>
+          <a:p>
+            <a:r>
+              <a:rPr lang="bg-BG" noProof="0" dirty="0" err="1"/>
+              <a:t>Genres</a:t>
+            </a:r>
+            <a:r>
+              <a:rPr lang="bg-BG" noProof="0" dirty="0"/>
+              <a:t> – Клас, който съдържа статичен лист с популярни жанрове на песни, с цел да помага в създаването на обекти.</a:t>
+            </a:r>
+          </a:p>
+          <a:p>
+            <a:r>
+              <a:rPr lang="bg-BG" noProof="0" dirty="0" err="1"/>
+              <a:t>HomeController</a:t>
+            </a:r>
+            <a:r>
+              <a:rPr lang="bg-BG" noProof="0" dirty="0"/>
+              <a:t> – Класът за контролера, който съдържа всички методи, които позволяват работата между базата данни и потребителският интерфейс.</a:t>
+            </a:r>
+          </a:p>
+          <a:p>
+            <a:r>
+              <a:rPr lang="bg-BG" noProof="0" dirty="0" err="1"/>
+              <a:t>AddSongViewModel</a:t>
+            </a:r>
+            <a:r>
+              <a:rPr lang="bg-BG" noProof="0" dirty="0"/>
+              <a:t>/</a:t>
+            </a:r>
+            <a:r>
+              <a:rPr lang="bg-BG" noProof="0" dirty="0" err="1"/>
+              <a:t>BasicSongViewModel</a:t>
+            </a:r>
+            <a:r>
+              <a:rPr lang="bg-BG" noProof="0" dirty="0"/>
+              <a:t>/</a:t>
+            </a:r>
+            <a:r>
+              <a:rPr lang="bg-BG" noProof="0" dirty="0" err="1"/>
+              <a:t>DeleteSongViewModel</a:t>
+            </a:r>
+            <a:r>
+              <a:rPr lang="bg-BG" noProof="0" dirty="0"/>
+              <a:t> – класове, които служат за помощ с </a:t>
+            </a:r>
+            <a:r>
+              <a:rPr lang="bg-BG" noProof="0" dirty="0" err="1"/>
+              <a:t>иползването</a:t>
+            </a:r>
+            <a:r>
+              <a:rPr lang="bg-BG" noProof="0" dirty="0"/>
+              <a:t> на данни от модела </a:t>
+            </a:r>
+            <a:r>
+              <a:rPr lang="bg-BG" noProof="0" dirty="0" err="1"/>
+              <a:t>Song</a:t>
+            </a:r>
+            <a:r>
+              <a:rPr lang="bg-BG" noProof="0" dirty="0"/>
+              <a:t> в страниците на апликацията.</a:t>
+            </a:r>
+          </a:p>
+          <a:p>
+            <a:r>
+              <a:rPr lang="bg-BG" noProof="0" dirty="0" err="1"/>
+              <a:t>Add</a:t>
+            </a:r>
+            <a:r>
+              <a:rPr lang="bg-BG" noProof="0" dirty="0"/>
+              <a:t>/</a:t>
+            </a:r>
+            <a:r>
+              <a:rPr lang="bg-BG" noProof="0" dirty="0" err="1"/>
+              <a:t>Edit</a:t>
+            </a:r>
+            <a:r>
+              <a:rPr lang="bg-BG" noProof="0" dirty="0"/>
+              <a:t>/</a:t>
+            </a:r>
+            <a:r>
+              <a:rPr lang="bg-BG" noProof="0" dirty="0" err="1"/>
+              <a:t>Delete</a:t>
+            </a:r>
+            <a:r>
+              <a:rPr lang="bg-BG" noProof="0" dirty="0"/>
+              <a:t>/</a:t>
+            </a:r>
+            <a:r>
+              <a:rPr lang="bg-BG" noProof="0" dirty="0" err="1"/>
+              <a:t>Index</a:t>
+            </a:r>
+            <a:r>
+              <a:rPr lang="bg-BG" noProof="0" dirty="0"/>
+              <a:t> – </a:t>
+            </a:r>
+            <a:r>
+              <a:rPr lang="bg-BG" noProof="0" dirty="0" err="1"/>
+              <a:t>View</a:t>
+            </a:r>
+            <a:r>
+              <a:rPr lang="bg-BG" noProof="0" dirty="0"/>
+              <a:t> </a:t>
+            </a:r>
+            <a:r>
+              <a:rPr lang="bg-BG" noProof="0" dirty="0" err="1"/>
+              <a:t>файлoвете</a:t>
+            </a:r>
+            <a:r>
+              <a:rPr lang="bg-BG" noProof="0" dirty="0"/>
+              <a:t>, които съдържат структурата на страниците за апликацията.</a:t>
+            </a:r>
+          </a:p>
+        </p:txBody>
+      </p:sp>
+      <p:pic>
+        <p:nvPicPr>
+          <p:cNvPr id="4" name="Picture 3"/>
+          <p:cNvPicPr>
+            <a:picLocks noChangeAspect="1"/>
+          </p:cNvPicPr>
+          <p:nvPr/>
+        </p:nvPicPr>
+        <p:blipFill>
+          <a:blip r:embed="rId2"/>
+          <a:stretch>
+            <a:fillRect/>
+          </a:stretch>
+        </p:blipFill>
+        <p:spPr>
+          <a:xfrm>
+            <a:off x="9534524" y="128587"/>
+            <a:ext cx="2533651" cy="6656390"/>
+          </a:xfrm>
+          <a:prstGeom prst="rect">
+            <a:avLst/>
+          </a:prstGeom>
+        </p:spPr>
+      </p:pic>
+    </p:spTree>
+    <p:extLst>
+      <p:ext uri="{BB962C8B-B14F-4D97-AF65-F5344CB8AC3E}">
+        <p14:creationId xmlns:p14="http://schemas.microsoft.com/office/powerpoint/2010/main" val="233053847"/>
+      </p:ext>
+    </p:extLst>
+  </p:cSld>
+  <p:clrMapOvr>
+    <a:masterClrMapping/>
+  </p:clrMapOvr>
+</p:sld>
+</file>
+
+<file path=ppt/slides/slide2.xml><?xml version="1.0" encoding="utf-8"?>
+<p:sld xmlns:a="http://schemas.openxmlformats.org/drawingml/2006/main" xmlns:r="http://schemas.openxmlformats.org/officeDocument/2006/relationships" xmlns:p="http://schemas.openxmlformats.org/presentationml/2006/main">
+  <p:cSld>
+    <p:spTree>
+      <p:nvGrpSpPr>
+        <p:cNvPr id="1" name=""/>
+        <p:cNvGrpSpPr/>
+        <p:nvPr/>
+      </p:nvGrpSpPr>
+      <p:grpSpPr>
+        <a:xfrm>
+          <a:off x="0" y="0"/>
+          <a:ext cx="0" cy="0"/>
+          <a:chOff x="0" y="0"/>
+          <a:chExt cx="0" cy="0"/>
+        </a:xfrm>
+      </p:grpSpPr>
+      <p:sp>
+        <p:nvSpPr>
+          <p:cNvPr id="2" name="Title 1"/>
+          <p:cNvSpPr>
+            <a:spLocks noGrp="1"/>
+          </p:cNvSpPr>
+          <p:nvPr>
+            <p:ph type="title"/>
+          </p:nvPr>
+        </p:nvSpPr>
+        <p:spPr/>
+        <p:txBody>
+          <a:bodyPr/>
+          <a:lstStyle/>
+          <a:p>
+            <a:pPr algn="ctr"/>
+            <a:r>
+              <a:rPr lang="bg-BG" noProof="0" dirty="0"/>
+              <a:t>Техническо Задание</a:t>
+            </a:r>
+            <a:br>
+              <a:rPr lang="bg-BG" noProof="0" dirty="0"/>
+            </a:br>
+            <a:endParaRPr lang="bg-BG" noProof="0" dirty="0"/>
+          </a:p>
+        </p:txBody>
+      </p:sp>
+      <p:pic>
+        <p:nvPicPr>
+          <p:cNvPr id="1026" name="Picture 2" descr="https://cdn.discordapp.com/attachments/1422853389347455053/1495497283985346701/image.png?ex=6a0ab721&amp;is=6a0965a1&amp;hm=9a2e02aad2993d7120b8b8182d290f112d47b42f7fc38aa751a05fbbaec48b6e&amp;"/>
+          <p:cNvPicPr>
+            <a:picLocks noGrp="1" noChangeAspect="1" noChangeArrowheads="1"/>
+          </p:cNvPicPr>
+          <p:nvPr>
+            <p:ph idx="1"/>
+          </p:nvPr>
+        </p:nvPicPr>
+        <p:blipFill>
+          <a:blip r:embed="rId2">
+            <a:extLst>
+              <a:ext uri="{28A0092B-C50C-407E-A947-70E740481C1C}">
+                <a14:useLocalDpi xmlns:a14="http://schemas.microsoft.com/office/drawing/2010/main" val="0"/>
+              </a:ext>
+            </a:extLst>
+          </a:blip>
+          <a:srcRect/>
+          <a:stretch>
+            <a:fillRect/>
+          </a:stretch>
+        </p:blipFill>
+        <p:spPr bwMode="auto">
+          <a:xfrm>
+            <a:off x="778766" y="1690689"/>
+            <a:ext cx="10327557" cy="1738311"/>
+          </a:xfrm>
+          <a:prstGeom prst="rect">
+            <a:avLst/>
+          </a:prstGeom>
+          <a:noFill/>
+          <a:extLst>
+            <a:ext uri="{909E8E84-426E-40DD-AFC4-6F175D3DCCD1}">
+              <a14:hiddenFill xmlns:a14="http://schemas.microsoft.com/office/drawing/2010/main">
+                <a:solidFill>
+                  <a:srgbClr val="FFFFFF"/>
+                </a:solidFill>
+              </a14:hiddenFill>
+            </a:ext>
+          </a:extLst>
+        </p:spPr>
+      </p:pic>
+    </p:spTree>
+    <p:extLst>
+      <p:ext uri="{BB962C8B-B14F-4D97-AF65-F5344CB8AC3E}">
+        <p14:creationId xmlns:p14="http://schemas.microsoft.com/office/powerpoint/2010/main" val="1768123233"/>
+      </p:ext>
+    </p:extLst>
+  </p:cSld>
+  <p:clrMapOvr>
+    <a:masterClrMapping/>
+  </p:clrMapOvr>
+</p:sld>
+</file>
+
+<file path=ppt/slides/slide3.xml><?xml version="1.0" encoding="utf-8"?>
+<p:sld xmlns:a="http://schemas.openxmlformats.org/drawingml/2006/main" xmlns:r="http://schemas.openxmlformats.org/officeDocument/2006/relationships" xmlns:p="http://schemas.openxmlformats.org/presentationml/2006/main">
+  <p:cSld>
+    <p:spTree>
+      <p:nvGrpSpPr>
+        <p:cNvPr id="1" name=""/>
+        <p:cNvGrpSpPr/>
+        <p:nvPr/>
+      </p:nvGrpSpPr>
+      <p:grpSpPr>
+        <a:xfrm>
+          <a:off x="0" y="0"/>
+          <a:ext cx="0" cy="0"/>
+          <a:chOff x="0" y="0"/>
+          <a:chExt cx="0" cy="0"/>
+        </a:xfrm>
+      </p:grpSpPr>
+      <p:sp>
+        <p:nvSpPr>
+          <p:cNvPr id="2" name="Заглавие 1">
+            <a:extLst>
+              <a:ext uri="{FF2B5EF4-FFF2-40B4-BE49-F238E27FC236}">
+                <a16:creationId xmlns:a16="http://schemas.microsoft.com/office/drawing/2014/main" id="{4535143F-BD9F-A2EE-8911-02B997326E37}"/>
+              </a:ext>
+            </a:extLst>
+          </p:cNvPr>
+          <p:cNvSpPr>
+            <a:spLocks noGrp="1"/>
+          </p:cNvSpPr>
+          <p:nvPr>
+            <p:ph type="title"/>
+          </p:nvPr>
+        </p:nvSpPr>
+        <p:spPr/>
+        <p:txBody>
+          <a:bodyPr/>
+          <a:lstStyle/>
+          <a:p>
+            <a:pPr algn="ctr"/>
+            <a:r>
+              <a:rPr lang="bg-BG" noProof="0" dirty="0"/>
+              <a:t>Цел на проекта</a:t>
+            </a:r>
+          </a:p>
+        </p:txBody>
+      </p:sp>
+      <p:sp>
+        <p:nvSpPr>
+          <p:cNvPr id="3" name="Контейнер за съдържание 2">
+            <a:extLst>
+              <a:ext uri="{FF2B5EF4-FFF2-40B4-BE49-F238E27FC236}">
+                <a16:creationId xmlns:a16="http://schemas.microsoft.com/office/drawing/2014/main" id="{C97A9712-540C-819E-2D95-42F40EF5EFA2}"/>
+              </a:ext>
+            </a:extLst>
+          </p:cNvPr>
+          <p:cNvSpPr>
+            <a:spLocks noGrp="1"/>
+          </p:cNvSpPr>
+          <p:nvPr>
+            <p:ph idx="1"/>
+          </p:nvPr>
+        </p:nvSpPr>
+        <p:spPr/>
+        <p:txBody>
+          <a:bodyPr/>
+          <a:lstStyle/>
+          <a:p>
+            <a:pPr fontAlgn="base"/>
+            <a:r>
+              <a:rPr lang="bg-BG" noProof="0" dirty="0"/>
+              <a:t>Бързо, лесно, достъпно и удобно споделяне и откриване на музика</a:t>
+            </a:r>
+          </a:p>
+          <a:p>
+            <a:pPr fontAlgn="base"/>
+            <a:r>
+              <a:rPr lang="bg-BG" noProof="0" dirty="0"/>
+              <a:t>Всеки може да качва линкове към песни</a:t>
+            </a:r>
+          </a:p>
+          <a:p>
+            <a:pPr fontAlgn="base"/>
+            <a:r>
+              <a:rPr lang="bg-BG" noProof="0" dirty="0"/>
+              <a:t>Полезно за събиране на песни, когато изпълнители качват на няколко платформи</a:t>
+            </a:r>
+          </a:p>
+        </p:txBody>
+      </p:sp>
+    </p:spTree>
+    <p:extLst>
+      <p:ext uri="{BB962C8B-B14F-4D97-AF65-F5344CB8AC3E}">
+        <p14:creationId xmlns:p14="http://schemas.microsoft.com/office/powerpoint/2010/main" val="1721509745"/>
+      </p:ext>
+    </p:extLst>
+  </p:cSld>
+  <p:clrMapOvr>
+    <a:masterClrMapping/>
+  </p:clrMapOvr>
+</p:sld>
+</file>
+
+<file path=ppt/slides/slide4.xml><?xml version="1.0" encoding="utf-8"?>
+<p:sld xmlns:a="http://schemas.openxmlformats.org/drawingml/2006/main" xmlns:r="http://schemas.openxmlformats.org/officeDocument/2006/relationships" xmlns:p="http://schemas.openxmlformats.org/presentationml/2006/main">
+  <p:cSld>
+    <p:spTree>
+      <p:nvGrpSpPr>
+        <p:cNvPr id="1" name=""/>
+        <p:cNvGrpSpPr/>
+        <p:nvPr/>
+      </p:nvGrpSpPr>
+      <p:grpSpPr>
+        <a:xfrm>
+          <a:off x="0" y="0"/>
+          <a:ext cx="0" cy="0"/>
+          <a:chOff x="0" y="0"/>
+          <a:chExt cx="0" cy="0"/>
+        </a:xfrm>
+      </p:grpSpPr>
+      <p:sp>
+        <p:nvSpPr>
+          <p:cNvPr id="2" name="Заглавие 1">
+            <a:extLst>
+              <a:ext uri="{FF2B5EF4-FFF2-40B4-BE49-F238E27FC236}">
+                <a16:creationId xmlns:a16="http://schemas.microsoft.com/office/drawing/2014/main" id="{7EB9B3BA-0A8C-766F-1917-31BA6F8FDC15}"/>
+              </a:ext>
+            </a:extLst>
+          </p:cNvPr>
+          <p:cNvSpPr>
+            <a:spLocks noGrp="1"/>
+          </p:cNvSpPr>
+          <p:nvPr>
+            <p:ph type="title"/>
+          </p:nvPr>
+        </p:nvSpPr>
+        <p:spPr/>
+        <p:txBody>
+          <a:bodyPr/>
+          <a:lstStyle/>
+          <a:p>
+            <a:pPr algn="ctr"/>
+            <a:r>
+              <a:rPr lang="bg-BG" dirty="0"/>
+              <a:t>Задачи</a:t>
+            </a:r>
+            <a:endParaRPr lang="en-US" dirty="0"/>
+          </a:p>
+        </p:txBody>
+      </p:sp>
+      <p:pic>
+        <p:nvPicPr>
+          <p:cNvPr id="5" name="Контейнер за съдържание 4">
+            <a:extLst>
+              <a:ext uri="{FF2B5EF4-FFF2-40B4-BE49-F238E27FC236}">
+                <a16:creationId xmlns:a16="http://schemas.microsoft.com/office/drawing/2014/main" id="{88E4B618-9710-6F4D-FB42-E1DF08640B32}"/>
+              </a:ext>
+            </a:extLst>
+          </p:cNvPr>
+          <p:cNvPicPr>
+            <a:picLocks noGrp="1" noChangeAspect="1"/>
+          </p:cNvPicPr>
+          <p:nvPr>
+            <p:ph idx="1"/>
+          </p:nvPr>
+        </p:nvPicPr>
+        <p:blipFill>
+          <a:blip r:embed="rId2"/>
+          <a:stretch>
+            <a:fillRect/>
+          </a:stretch>
+        </p:blipFill>
+        <p:spPr>
+          <a:xfrm>
+            <a:off x="4121911" y="1825625"/>
+            <a:ext cx="3948178" cy="4351338"/>
+          </a:xfrm>
+          <a:prstGeom prst="rect">
+            <a:avLst/>
+          </a:prstGeom>
+        </p:spPr>
+      </p:pic>
+    </p:spTree>
+    <p:extLst>
+      <p:ext uri="{BB962C8B-B14F-4D97-AF65-F5344CB8AC3E}">
+        <p14:creationId xmlns:p14="http://schemas.microsoft.com/office/powerpoint/2010/main" val="3811949936"/>
+      </p:ext>
+    </p:extLst>
+  </p:cSld>
+  <p:clrMapOvr>
+    <a:masterClrMapping/>
+  </p:clrMapOvr>
+</p:sld>
+</file>
+
+<file path=ppt/slides/slide5.xml><?xml version="1.0" encoding="utf-8"?>
+<p:sld xmlns:a="http://schemas.openxmlformats.org/drawingml/2006/main" xmlns:r="http://schemas.openxmlformats.org/officeDocument/2006/relationships" xmlns:p="http://schemas.openxmlformats.org/presentationml/2006/main">
+  <p:cSld>
+    <p:spTree>
+      <p:nvGrpSpPr>
+        <p:cNvPr id="1" name=""/>
+        <p:cNvGrpSpPr/>
+        <p:nvPr/>
+      </p:nvGrpSpPr>
+      <p:grpSpPr>
+        <a:xfrm>
+          <a:off x="0" y="0"/>
+          <a:ext cx="0" cy="0"/>
+          <a:chOff x="0" y="0"/>
+          <a:chExt cx="0" cy="0"/>
+        </a:xfrm>
+      </p:grpSpPr>
+      <p:sp>
+        <p:nvSpPr>
+          <p:cNvPr id="2" name="Title 1"/>
+          <p:cNvSpPr>
+            <a:spLocks noGrp="1"/>
+          </p:cNvSpPr>
+          <p:nvPr>
+            <p:ph type="title"/>
+          </p:nvPr>
+        </p:nvSpPr>
+        <p:spPr/>
+        <p:txBody>
+          <a:bodyPr>
+            <a:normAutofit/>
+          </a:bodyPr>
+          <a:lstStyle/>
+          <a:p>
+            <a:pPr algn="ctr"/>
+            <a:r>
+              <a:rPr lang="bg-BG" noProof="0" dirty="0"/>
+              <a:t>Система за контрол на версиите </a:t>
+            </a:r>
+            <a:br>
+              <a:rPr lang="bg-BG" noProof="0" dirty="0"/>
+            </a:br>
+            <a:endParaRPr lang="bg-BG" noProof="0" dirty="0"/>
+          </a:p>
+        </p:txBody>
+      </p:sp>
+      <p:sp>
+        <p:nvSpPr>
+          <p:cNvPr id="3" name="Content Placeholder 2"/>
+          <p:cNvSpPr>
+            <a:spLocks noGrp="1"/>
+          </p:cNvSpPr>
+          <p:nvPr>
+            <p:ph idx="1"/>
+          </p:nvPr>
+        </p:nvSpPr>
+        <p:spPr>
+          <a:xfrm>
+            <a:off x="58189" y="1379913"/>
+            <a:ext cx="12133811" cy="2119745"/>
+          </a:xfrm>
+        </p:spPr>
+        <p:txBody>
+          <a:bodyPr/>
+          <a:lstStyle/>
+          <a:p>
+            <a:pPr marL="0" indent="0">
+              <a:buNone/>
+            </a:pPr>
+            <a:r>
+              <a:rPr lang="bg-BG" noProof="0" dirty="0"/>
+              <a:t>Избраната система е </a:t>
+            </a:r>
+            <a:r>
+              <a:rPr lang="bg-BG" noProof="0" dirty="0" err="1"/>
+              <a:t>GitHub</a:t>
+            </a:r>
+            <a:r>
+              <a:rPr lang="bg-BG" noProof="0" dirty="0"/>
+              <a:t>. Причината за изборът, е че </a:t>
+            </a:r>
+            <a:r>
+              <a:rPr lang="bg-BG" noProof="0" dirty="0" err="1"/>
+              <a:t>GitHub</a:t>
+            </a:r>
+            <a:r>
+              <a:rPr lang="bg-BG" noProof="0" dirty="0"/>
+              <a:t> е една от най-популярните системи за контрол на версиите и изключително лесна за използване и улеснява работата в екип. Също приложението </a:t>
+            </a:r>
+            <a:r>
+              <a:rPr lang="bg-BG" noProof="0" dirty="0" err="1"/>
+              <a:t>GitHub</a:t>
+            </a:r>
+            <a:r>
+              <a:rPr lang="bg-BG" noProof="0" dirty="0"/>
+              <a:t> </a:t>
+            </a:r>
+            <a:r>
+              <a:rPr lang="bg-BG" noProof="0" dirty="0" err="1"/>
+              <a:t>Desktop</a:t>
+            </a:r>
+            <a:r>
+              <a:rPr lang="bg-BG" noProof="0" dirty="0"/>
+              <a:t> позволява по-лесна промяна и качване на промени по проекта, понеже не се налага да се пишат команди в конзолата.</a:t>
+            </a:r>
+          </a:p>
+          <a:p>
+            <a:pPr marL="0" indent="0">
+              <a:buNone/>
+            </a:pPr>
+            <a:endParaRPr lang="bg-BG" noProof="0" dirty="0"/>
+          </a:p>
+        </p:txBody>
+      </p:sp>
+      <p:pic>
+        <p:nvPicPr>
+          <p:cNvPr id="2050" name="Picture 2" descr="Logo - Brand Toolkit"/>
+          <p:cNvPicPr>
+            <a:picLocks noChangeAspect="1" noChangeArrowheads="1"/>
+          </p:cNvPicPr>
+          <p:nvPr/>
+        </p:nvPicPr>
+        <p:blipFill>
+          <a:blip r:embed="rId2" cstate="print">
+            <a:extLst>
+              <a:ext uri="{28A0092B-C50C-407E-A947-70E740481C1C}">
+                <a14:useLocalDpi xmlns:a14="http://schemas.microsoft.com/office/drawing/2010/main" val="0"/>
+              </a:ext>
+            </a:extLst>
+          </a:blip>
+          <a:srcRect/>
+          <a:stretch>
+            <a:fillRect/>
+          </a:stretch>
+        </p:blipFill>
+        <p:spPr bwMode="auto">
+          <a:xfrm>
+            <a:off x="297028" y="4080230"/>
+            <a:ext cx="5546970" cy="2059313"/>
+          </a:xfrm>
+          <a:prstGeom prst="rect">
+            <a:avLst/>
+          </a:prstGeom>
+          <a:noFill/>
+          <a:extLst>
+            <a:ext uri="{909E8E84-426E-40DD-AFC4-6F175D3DCCD1}">
+              <a14:hiddenFill xmlns:a14="http://schemas.microsoft.com/office/drawing/2010/main">
+                <a:solidFill>
+                  <a:srgbClr val="FFFFFF"/>
+                </a:solidFill>
+              </a14:hiddenFill>
+            </a:ext>
+          </a:extLst>
+        </p:spPr>
+      </p:pic>
+      <p:pic>
+        <p:nvPicPr>
+          <p:cNvPr id="2052" name="Picture 4" descr="Getting Started with G... | Wiki | UAL Creative Computing Institute"/>
+          <p:cNvPicPr>
+            <a:picLocks noChangeAspect="1" noChangeArrowheads="1"/>
+          </p:cNvPicPr>
+          <p:nvPr/>
+        </p:nvPicPr>
+        <p:blipFill>
+          <a:blip r:embed="rId3">
+            <a:extLst>
+              <a:ext uri="{28A0092B-C50C-407E-A947-70E740481C1C}">
+                <a14:useLocalDpi xmlns:a14="http://schemas.microsoft.com/office/drawing/2010/main" val="0"/>
+              </a:ext>
+            </a:extLst>
+          </a:blip>
+          <a:srcRect/>
+          <a:stretch>
+            <a:fillRect/>
+          </a:stretch>
+        </p:blipFill>
+        <p:spPr bwMode="auto">
+          <a:xfrm>
+            <a:off x="5961289" y="4157386"/>
+            <a:ext cx="5715000" cy="1905000"/>
+          </a:xfrm>
+          <a:prstGeom prst="rect">
+            <a:avLst/>
+          </a:prstGeom>
+          <a:noFill/>
+          <a:extLst>
+            <a:ext uri="{909E8E84-426E-40DD-AFC4-6F175D3DCCD1}">
+              <a14:hiddenFill xmlns:a14="http://schemas.microsoft.com/office/drawing/2010/main">
+                <a:solidFill>
+                  <a:srgbClr val="FFFFFF"/>
+                </a:solidFill>
+              </a14:hiddenFill>
+            </a:ext>
+          </a:extLst>
+        </p:spPr>
+      </p:pic>
+    </p:spTree>
+    <p:extLst>
+      <p:ext uri="{BB962C8B-B14F-4D97-AF65-F5344CB8AC3E}">
+        <p14:creationId xmlns:p14="http://schemas.microsoft.com/office/powerpoint/2010/main" val="1432200802"/>
+      </p:ext>
+    </p:extLst>
+  </p:cSld>
+  <p:clrMapOvr>
+    <a:masterClrMapping/>
+  </p:clrMapOvr>
+</p:sld>
+</file>
+
+<file path=ppt/slides/slide6.xml><?xml version="1.0" encoding="utf-8"?>
+<p:sld xmlns:a="http://schemas.openxmlformats.org/drawingml/2006/main" xmlns:r="http://schemas.openxmlformats.org/officeDocument/2006/relationships" xmlns:p="http://schemas.openxmlformats.org/presentationml/2006/main">
+  <p:cSld>
+    <p:spTree>
+      <p:nvGrpSpPr>
+        <p:cNvPr id="1" name=""/>
+        <p:cNvGrpSpPr/>
+        <p:nvPr/>
+      </p:nvGrpSpPr>
+      <p:grpSpPr>
+        <a:xfrm>
+          <a:off x="0" y="0"/>
+          <a:ext cx="0" cy="0"/>
+          <a:chOff x="0" y="0"/>
+          <a:chExt cx="0" cy="0"/>
+        </a:xfrm>
+      </p:grpSpPr>
+      <p:sp>
+        <p:nvSpPr>
+          <p:cNvPr id="2" name="Title 1"/>
+          <p:cNvSpPr>
+            <a:spLocks noGrp="1"/>
+          </p:cNvSpPr>
+          <p:nvPr>
+            <p:ph type="title"/>
+          </p:nvPr>
+        </p:nvSpPr>
+        <p:spPr/>
+        <p:txBody>
+          <a:bodyPr>
+            <a:normAutofit/>
+          </a:bodyPr>
+          <a:lstStyle/>
+          <a:p>
+            <a:pPr algn="ctr"/>
+            <a:r>
+              <a:rPr lang="bg-BG" noProof="0" dirty="0"/>
+              <a:t>Система за управление на проекта</a:t>
+            </a:r>
+          </a:p>
+        </p:txBody>
+      </p:sp>
+      <p:pic>
+        <p:nvPicPr>
+          <p:cNvPr id="3074" name="Picture 2" descr="File:Jira Logo.svg - Wikimedia Commons"/>
+          <p:cNvPicPr>
+            <a:picLocks noGrp="1" noChangeAspect="1" noChangeArrowheads="1"/>
+          </p:cNvPicPr>
+          <p:nvPr>
+            <p:ph sz="half" idx="1"/>
+          </p:nvPr>
+        </p:nvPicPr>
+        <p:blipFill>
+          <a:blip r:embed="rId2" cstate="print">
+            <a:extLst>
+              <a:ext uri="{28A0092B-C50C-407E-A947-70E740481C1C}">
+                <a14:useLocalDpi xmlns:a14="http://schemas.microsoft.com/office/drawing/2010/main" val="0"/>
+              </a:ext>
+            </a:extLst>
+          </a:blip>
+          <a:stretch>
+            <a:fillRect/>
+          </a:stretch>
+        </p:blipFill>
+        <p:spPr bwMode="auto">
+          <a:xfrm>
+            <a:off x="1018407" y="5290888"/>
+            <a:ext cx="2394181" cy="1010045"/>
+          </a:xfrm>
+          <a:prstGeom prst="rect">
+            <a:avLst/>
+          </a:prstGeom>
+          <a:noFill/>
+          <a:extLst>
+            <a:ext uri="{909E8E84-426E-40DD-AFC4-6F175D3DCCD1}">
+              <a14:hiddenFill xmlns:a14="http://schemas.microsoft.com/office/drawing/2010/main">
+                <a:solidFill>
+                  <a:srgbClr val="FFFFFF"/>
+                </a:solidFill>
+              </a14:hiddenFill>
+            </a:ext>
+          </a:extLst>
+        </p:spPr>
+      </p:pic>
+      <p:sp>
+        <p:nvSpPr>
+          <p:cNvPr id="4" name="Контейнер за съдържание 3">
+            <a:extLst>
+              <a:ext uri="{FF2B5EF4-FFF2-40B4-BE49-F238E27FC236}">
+                <a16:creationId xmlns:a16="http://schemas.microsoft.com/office/drawing/2014/main" id="{A19340FF-5881-8D7C-13AD-5E45FA7B6BDF}"/>
+              </a:ext>
+            </a:extLst>
+          </p:cNvPr>
+          <p:cNvSpPr>
+            <a:spLocks noGrp="1"/>
+          </p:cNvSpPr>
+          <p:nvPr>
+            <p:ph sz="half" idx="2"/>
+          </p:nvPr>
+        </p:nvSpPr>
+        <p:spPr>
+          <a:xfrm>
+            <a:off x="1018407" y="1825625"/>
+            <a:ext cx="10335393" cy="4351338"/>
+          </a:xfrm>
+        </p:spPr>
+        <p:txBody>
+          <a:bodyPr/>
+          <a:lstStyle/>
+          <a:p>
+            <a:r>
+              <a:rPr lang="bg-BG" noProof="0" dirty="0"/>
+              <a:t>Избраната система е JIRA. Системата е подходяща и съвместима с методологиите, използвани от отбора и доставя всички нужни функционалности по удобен и лесен за ползване начин с неговия потребителски интерфейс.</a:t>
+            </a:r>
+          </a:p>
+          <a:p>
+            <a:pPr marL="0" indent="0">
+              <a:buNone/>
+            </a:pPr>
+            <a:endParaRPr lang="bg-BG" noProof="0" dirty="0"/>
+          </a:p>
+        </p:txBody>
+      </p:sp>
+    </p:spTree>
+    <p:extLst>
+      <p:ext uri="{BB962C8B-B14F-4D97-AF65-F5344CB8AC3E}">
+        <p14:creationId xmlns:p14="http://schemas.microsoft.com/office/powerpoint/2010/main" val="1157703078"/>
+      </p:ext>
+    </p:extLst>
+  </p:cSld>
+  <p:clrMapOvr>
+    <a:masterClrMapping/>
+  </p:clrMapOvr>
+</p:sld>
+</file>
+
+<file path=ppt/slides/slide7.xml><?xml version="1.0" encoding="utf-8"?>
+<p:sld xmlns:a="http://schemas.openxmlformats.org/drawingml/2006/main" xmlns:r="http://schemas.openxmlformats.org/officeDocument/2006/relationships" xmlns:p="http://schemas.openxmlformats.org/presentationml/2006/main">
+  <p:cSld>
+    <p:spTree>
+      <p:nvGrpSpPr>
+        <p:cNvPr id="1" name=""/>
+        <p:cNvGrpSpPr/>
+        <p:nvPr/>
+      </p:nvGrpSpPr>
+      <p:grpSpPr>
+        <a:xfrm>
+          <a:off x="0" y="0"/>
+          <a:ext cx="0" cy="0"/>
+          <a:chOff x="0" y="0"/>
+          <a:chExt cx="0" cy="0"/>
+        </a:xfrm>
+      </p:grpSpPr>
+      <p:sp>
+        <p:nvSpPr>
+          <p:cNvPr id="2" name="Title 1"/>
+          <p:cNvSpPr>
+            <a:spLocks noGrp="1"/>
+          </p:cNvSpPr>
+          <p:nvPr>
+            <p:ph type="title"/>
+          </p:nvPr>
+        </p:nvSpPr>
+        <p:spPr/>
+        <p:txBody>
+          <a:bodyPr/>
+          <a:lstStyle/>
+          <a:p>
+            <a:pPr algn="ctr"/>
+            <a:r>
+              <a:rPr lang="bg-BG" noProof="0" dirty="0" err="1"/>
+              <a:t>Web</a:t>
+            </a:r>
+            <a:r>
+              <a:rPr lang="bg-BG" noProof="0" dirty="0"/>
+              <a:t> Приложение</a:t>
+            </a:r>
+            <a:br>
+              <a:rPr lang="bg-BG" noProof="0" dirty="0"/>
+            </a:br>
+            <a:endParaRPr lang="bg-BG" noProof="0" dirty="0"/>
+          </a:p>
+        </p:txBody>
+      </p:sp>
+      <p:sp>
+        <p:nvSpPr>
+          <p:cNvPr id="3" name="Content Placeholder 2"/>
+          <p:cNvSpPr>
+            <a:spLocks noGrp="1"/>
+          </p:cNvSpPr>
+          <p:nvPr>
+            <p:ph idx="1"/>
+          </p:nvPr>
+        </p:nvSpPr>
+        <p:spPr>
+          <a:xfrm>
+            <a:off x="838200" y="1520825"/>
+            <a:ext cx="10515600" cy="1425575"/>
+          </a:xfrm>
+        </p:spPr>
+        <p:txBody>
+          <a:bodyPr/>
+          <a:lstStyle/>
+          <a:p>
+            <a:pPr marL="0" indent="0">
+              <a:buNone/>
+            </a:pPr>
+            <a:r>
+              <a:rPr lang="bg-BG" noProof="0" dirty="0"/>
+              <a:t>Проектът е под формата на </a:t>
+            </a:r>
+            <a:r>
+              <a:rPr lang="bg-BG" noProof="0" dirty="0" err="1"/>
+              <a:t>Web</a:t>
+            </a:r>
+            <a:r>
+              <a:rPr lang="bg-BG" noProof="0" dirty="0"/>
+              <a:t> приложение. Това е поради използваната технология. NET </a:t>
+            </a:r>
+            <a:r>
+              <a:rPr lang="bg-BG" noProof="0" dirty="0" err="1"/>
+              <a:t>Web</a:t>
+            </a:r>
+            <a:r>
+              <a:rPr lang="bg-BG" noProof="0" dirty="0"/>
+              <a:t> </a:t>
+            </a:r>
+            <a:r>
+              <a:rPr lang="bg-BG" noProof="0" dirty="0" err="1"/>
+              <a:t>App</a:t>
+            </a:r>
+            <a:r>
+              <a:rPr lang="bg-BG" noProof="0" dirty="0"/>
+              <a:t> със структура MVC (</a:t>
+            </a:r>
+            <a:r>
+              <a:rPr lang="bg-BG" noProof="0" dirty="0" err="1"/>
+              <a:t>Model</a:t>
+            </a:r>
+            <a:r>
+              <a:rPr lang="bg-BG" noProof="0" dirty="0"/>
+              <a:t> </a:t>
+            </a:r>
+            <a:r>
+              <a:rPr lang="bg-BG" noProof="0" dirty="0" err="1"/>
+              <a:t>View</a:t>
+            </a:r>
+            <a:r>
+              <a:rPr lang="bg-BG" noProof="0" dirty="0"/>
+              <a:t> </a:t>
+            </a:r>
+            <a:r>
+              <a:rPr lang="bg-BG" noProof="0" dirty="0" err="1"/>
+              <a:t>Controller</a:t>
+            </a:r>
+            <a:r>
+              <a:rPr lang="bg-BG" noProof="0" dirty="0"/>
+              <a:t>).</a:t>
+            </a:r>
+          </a:p>
+          <a:p>
+            <a:endParaRPr lang="bg-BG" noProof="0" dirty="0"/>
+          </a:p>
+        </p:txBody>
+      </p:sp>
+      <p:pic>
+        <p:nvPicPr>
+          <p:cNvPr id="4" name="Picture 3"/>
+          <p:cNvPicPr>
+            <a:picLocks noChangeAspect="1"/>
+          </p:cNvPicPr>
+          <p:nvPr/>
+        </p:nvPicPr>
+        <p:blipFill>
+          <a:blip r:embed="rId2"/>
+          <a:stretch>
+            <a:fillRect/>
+          </a:stretch>
+        </p:blipFill>
+        <p:spPr>
+          <a:xfrm>
+            <a:off x="1568070" y="2846388"/>
+            <a:ext cx="8573457" cy="3915001"/>
+          </a:xfrm>
+          <a:prstGeom prst="rect">
+            <a:avLst/>
+          </a:prstGeom>
+        </p:spPr>
+      </p:pic>
+    </p:spTree>
+    <p:extLst>
+      <p:ext uri="{BB962C8B-B14F-4D97-AF65-F5344CB8AC3E}">
+        <p14:creationId xmlns:p14="http://schemas.microsoft.com/office/powerpoint/2010/main" val="1685781362"/>
+      </p:ext>
+    </p:extLst>
+  </p:cSld>
+  <p:clrMapOvr>
+    <a:masterClrMapping/>
+  </p:clrMapOvr>
+</p:sld>
+</file>
+
+<file path=ppt/slides/slide8.xml><?xml version="1.0" encoding="utf-8"?>
+<p:sld xmlns:a="http://schemas.openxmlformats.org/drawingml/2006/main" xmlns:r="http://schemas.openxmlformats.org/officeDocument/2006/relationships" xmlns:p="http://schemas.openxmlformats.org/presentationml/2006/main">
+  <p:cSld>
+    <p:spTree>
+      <p:nvGrpSpPr>
+        <p:cNvPr id="1" name=""/>
+        <p:cNvGrpSpPr/>
+        <p:nvPr/>
+      </p:nvGrpSpPr>
+      <p:grpSpPr>
+        <a:xfrm>
+          <a:off x="0" y="0"/>
+          <a:ext cx="0" cy="0"/>
+          <a:chOff x="0" y="0"/>
+          <a:chExt cx="0" cy="0"/>
+        </a:xfrm>
+      </p:grpSpPr>
+      <p:pic>
+        <p:nvPicPr>
+          <p:cNvPr id="5" name="Picture 4"/>
+          <p:cNvPicPr>
+            <a:picLocks noChangeAspect="1"/>
+          </p:cNvPicPr>
+          <p:nvPr/>
+        </p:nvPicPr>
+        <p:blipFill>
+          <a:blip r:embed="rId2"/>
+          <a:stretch>
+            <a:fillRect/>
+          </a:stretch>
+        </p:blipFill>
+        <p:spPr>
+          <a:xfrm>
+            <a:off x="9102436" y="2913348"/>
+            <a:ext cx="2933354" cy="2092039"/>
+          </a:xfrm>
+          <a:prstGeom prst="rect">
+            <a:avLst/>
+          </a:prstGeom>
+        </p:spPr>
+      </p:pic>
+      <p:sp>
+        <p:nvSpPr>
+          <p:cNvPr id="2" name="Title 1"/>
+          <p:cNvSpPr>
+            <a:spLocks noGrp="1"/>
+          </p:cNvSpPr>
+          <p:nvPr>
+            <p:ph type="title"/>
+          </p:nvPr>
+        </p:nvSpPr>
+        <p:spPr/>
+        <p:txBody>
+          <a:bodyPr/>
+          <a:lstStyle/>
+          <a:p>
+            <a:pPr algn="ctr"/>
+            <a:r>
+              <a:rPr lang="bg-BG" noProof="0" dirty="0"/>
+              <a:t>Използвани функционалности</a:t>
+            </a:r>
+            <a:br>
+              <a:rPr lang="bg-BG" noProof="0" dirty="0"/>
+            </a:br>
+            <a:endParaRPr lang="bg-BG" noProof="0" dirty="0"/>
+          </a:p>
+        </p:txBody>
+      </p:sp>
+      <p:sp>
+        <p:nvSpPr>
+          <p:cNvPr id="3" name="Content Placeholder 2"/>
+          <p:cNvSpPr>
+            <a:spLocks noGrp="1"/>
+          </p:cNvSpPr>
+          <p:nvPr>
+            <p:ph idx="1"/>
+          </p:nvPr>
+        </p:nvSpPr>
+        <p:spPr>
+          <a:xfrm>
+            <a:off x="58189" y="1168920"/>
+            <a:ext cx="12133811" cy="2380615"/>
+          </a:xfrm>
+        </p:spPr>
+        <p:txBody>
+          <a:bodyPr>
+            <a:normAutofit/>
+          </a:bodyPr>
+          <a:lstStyle/>
+          <a:p>
+            <a:r>
+              <a:rPr lang="bg-BG" noProof="0" dirty="0"/>
+              <a:t>Приложението дава възможност на регистрирани потребители да добавят, променят и изтриват песни. След като една песен е добавена, тя може да се види в главната страница на приложението, от където също може да се ходи директно във външни уеб страници, посочени от добавените песни. Песни могат да се търсят по техните създатели, име, жанр и година.</a:t>
+            </a:r>
+          </a:p>
+          <a:p>
+            <a:endParaRPr lang="bg-BG" noProof="0" dirty="0"/>
+          </a:p>
+        </p:txBody>
+      </p:sp>
+      <p:pic>
+        <p:nvPicPr>
+          <p:cNvPr id="4" name="Picture 3"/>
+          <p:cNvPicPr>
+            <a:picLocks noChangeAspect="1"/>
+          </p:cNvPicPr>
+          <p:nvPr/>
+        </p:nvPicPr>
+        <p:blipFill>
+          <a:blip r:embed="rId3"/>
+          <a:stretch>
+            <a:fillRect/>
+          </a:stretch>
+        </p:blipFill>
+        <p:spPr>
+          <a:xfrm>
+            <a:off x="174568" y="3356091"/>
+            <a:ext cx="6916188" cy="3105150"/>
+          </a:xfrm>
+          <a:prstGeom prst="rect">
+            <a:avLst/>
+          </a:prstGeom>
+        </p:spPr>
+      </p:pic>
+      <p:pic>
+        <p:nvPicPr>
+          <p:cNvPr id="6" name="Picture 5"/>
+          <p:cNvPicPr>
+            <a:picLocks noChangeAspect="1"/>
+          </p:cNvPicPr>
+          <p:nvPr/>
+        </p:nvPicPr>
+        <p:blipFill>
+          <a:blip r:embed="rId4"/>
+          <a:stretch>
+            <a:fillRect/>
+          </a:stretch>
+        </p:blipFill>
+        <p:spPr>
+          <a:xfrm>
+            <a:off x="8019963" y="5293963"/>
+            <a:ext cx="4087004" cy="1360952"/>
+          </a:xfrm>
+          <a:prstGeom prst="rect">
+            <a:avLst/>
+          </a:prstGeom>
+        </p:spPr>
+      </p:pic>
+    </p:spTree>
+    <p:extLst>
+      <p:ext uri="{BB962C8B-B14F-4D97-AF65-F5344CB8AC3E}">
+        <p14:creationId xmlns:p14="http://schemas.microsoft.com/office/powerpoint/2010/main" val="3479705222"/>
+      </p:ext>
+    </p:extLst>
+  </p:cSld>
+  <p:clrMapOvr>
+    <a:masterClrMapping/>
+  </p:clrMapOvr>
+</p:sld>
+</file>
+
 <file path=ppt/slides/slide9.xml><?xml version="1.0" encoding="utf-8"?>
 <p:sld xmlns:a="http://schemas.openxmlformats.org/drawingml/2006/main" xmlns:r="http://schemas.openxmlformats.org/officeDocument/2006/relationships" xmlns:p="http://schemas.openxmlformats.org/presentationml/2006/main">
   <p:cSld>
@@ -4598,22 +4863,19 @@
         <p:spPr/>
         <p:txBody>
           <a:bodyPr>
-            <a:normAutofit fontScale="90000"/>
+            <a:normAutofit/>
           </a:bodyPr>
           <a:lstStyle/>
           <a:p>
-            <a:r>
-              <a:rPr lang="ru-RU"/>
-              <a:t>8.Стъпки, зависещи от конкретния подход за разработка</a:t>
-            </a:r>
-            <a:r>
-              <a:rPr lang="en-US"/>
-              <a:t/>
+            <a:pPr algn="ctr"/>
+            <a:r>
+              <a:rPr lang="bg-BG" noProof="0" dirty="0"/>
+              <a:t>Методологии за разработка на софтуера</a:t>
             </a:r>
             <a:br>
-              <a:rPr lang="en-US"/>
+              <a:rPr lang="bg-BG" noProof="0" dirty="0"/>
             </a:br>
-            <a:endParaRPr lang="en-US"/>
+            <a:endParaRPr lang="bg-BG" noProof="0" dirty="0"/>
           </a:p>
         </p:txBody>
       </p:sp>
@@ -4624,74 +4886,61 @@
             <a:spLocks noGrp="1"/>
           </p:cNvSpPr>
           <p:nvPr>
-            <p:ph idx="1"/>
-          </p:nvPr>
-        </p:nvSpPr>
-        <p:spPr/>
-        <p:txBody>
-          <a:bodyPr>
-            <a:normAutofit fontScale="92500" lnSpcReduction="10000"/>
-          </a:bodyPr>
-          <a:lstStyle/>
-          <a:p>
-            <a:pPr marL="0" indent="0">
-              <a:buNone/>
-            </a:pPr>
-            <a:r>
-              <a:rPr lang="ru-RU"/>
-              <a:t>Използваната за създаване на проекта </a:t>
-            </a:r>
-            <a:r>
-              <a:rPr lang="en-US"/>
-              <a:t>MVC </a:t>
-            </a:r>
-            <a:r>
-              <a:rPr lang="bg-BG"/>
-              <a:t>структура , изисква някои спецификации , за да може да функционира приложението. Трябва да се останови връзка към базата данни  , за да може да се съхраняват и взимат данните за песни в приложението . Трябва да се направят модели , чрез които се създават обекти . Нужни са контролери , които да съдържат логиката за работа с обектите направени от моделите . </a:t>
-            </a:r>
-            <a:r>
-              <a:rPr lang="en-US"/>
-              <a:t>ViewModels </a:t>
-            </a:r>
-            <a:r>
-              <a:rPr lang="bg-BG"/>
-              <a:t>са класове, които се използват за да помагат с четенето и писането на данни в обектите, като различните </a:t>
-            </a:r>
-            <a:r>
-              <a:rPr lang="en-US"/>
-              <a:t>ViewModel-</a:t>
-            </a:r>
-            <a:r>
-              <a:rPr lang="bg-BG"/>
-              <a:t>и имат различен подбор от данни, които да използват за различни страници от </a:t>
-            </a:r>
-            <a:r>
-              <a:rPr lang="en-US"/>
-              <a:t>Web </a:t>
-            </a:r>
-            <a:r>
-              <a:rPr lang="bg-BG"/>
-              <a:t>приложението. </a:t>
-            </a:r>
-            <a:r>
-              <a:rPr lang="en-US"/>
-              <a:t>View-</a:t>
-            </a:r>
-            <a:r>
-              <a:rPr lang="bg-BG"/>
-              <a:t>тата са структурите на страниците в приложението. Те представляват  как ще изглежда и как ще е структурирана една страница. </a:t>
-            </a:r>
-            <a:endParaRPr lang="en-US"/>
-          </a:p>
-          <a:p>
-            <a:endParaRPr lang="en-US"/>
+            <p:ph sz="half" idx="1"/>
+          </p:nvPr>
+        </p:nvSpPr>
+        <p:spPr/>
+        <p:txBody>
+          <a:bodyPr/>
+          <a:lstStyle/>
+          <a:p>
+            <a:r>
+              <a:rPr lang="bg-BG" noProof="0" dirty="0" err="1"/>
+              <a:t>Hacking</a:t>
+            </a:r>
+            <a:r>
+              <a:rPr lang="bg-BG" noProof="0" dirty="0"/>
+              <a:t> е практиката да се прави работа по приложението без предварително разясняване на нужни задачи и средства. Поради малкият отбор и обхват на проекта, методологията може да бъде употребена.</a:t>
+            </a:r>
+          </a:p>
+        </p:txBody>
+      </p:sp>
+      <p:sp>
+        <p:nvSpPr>
+          <p:cNvPr id="4" name="Контейнер за съдържание 3">
+            <a:extLst>
+              <a:ext uri="{FF2B5EF4-FFF2-40B4-BE49-F238E27FC236}">
+                <a16:creationId xmlns:a16="http://schemas.microsoft.com/office/drawing/2014/main" id="{BBBEFE92-2C83-1C94-4524-2F7A3E7B67F5}"/>
+              </a:ext>
+            </a:extLst>
+          </p:cNvPr>
+          <p:cNvSpPr>
+            <a:spLocks noGrp="1"/>
+          </p:cNvSpPr>
+          <p:nvPr>
+            <p:ph sz="half" idx="2"/>
+          </p:nvPr>
+        </p:nvSpPr>
+        <p:spPr/>
+        <p:txBody>
+          <a:bodyPr/>
+          <a:lstStyle/>
+          <a:p>
+            <a:r>
+              <a:rPr lang="bg-BG" noProof="0" dirty="0" err="1"/>
+              <a:t>Kanban</a:t>
+            </a:r>
+            <a:r>
+              <a:rPr lang="bg-BG" noProof="0" dirty="0"/>
+              <a:t> е предпочитан за този проект, поради ниския брой задачи, които могат лесно да се запишат на дъска, и винаги може да се запишат нови задачи или редактират стари по време на разработката.</a:t>
+            </a:r>
           </a:p>
         </p:txBody>
       </p:sp>
     </p:spTree>
     <p:extLst>
       <p:ext uri="{BB962C8B-B14F-4D97-AF65-F5344CB8AC3E}">
-        <p14:creationId xmlns:p14="http://schemas.microsoft.com/office/powerpoint/2010/main" val="3329442785"/>
+        <p14:creationId xmlns:p14="http://schemas.microsoft.com/office/powerpoint/2010/main" val="3916397861"/>
       </p:ext>
     </p:extLst>
   </p:cSld>

</xml_diff>

<commit_message>
Thanks for the attention
</commit_message>
<xml_diff>
--- a/ТУ ВАРНА Music App Presentation.pptx
+++ b/ТУ ВАРНА Music App Presentation.pptx
@@ -17,6 +17,7 @@
     <p:sldId id="263" r:id="rId11"/>
     <p:sldId id="264" r:id="rId12"/>
     <p:sldId id="265" r:id="rId13"/>
+    <p:sldId id="268" r:id="rId14"/>
   </p:sldIdLst>
   <p:sldSz cx="12192000" cy="6858000"/>
   <p:notesSz cx="6858000" cy="9144000"/>
@@ -252,7 +253,7 @@
           <a:p>
             <a:fld id="{343BBA07-A3FE-4952-8777-070CB8556D2F}" type="datetimeFigureOut">
               <a:rPr lang="en-US" smtClean="0"/>
-              <a:t>5/18/2026</a:t>
+              <a:t>5/19/2026</a:t>
             </a:fld>
             <a:endParaRPr lang="en-US"/>
           </a:p>
@@ -420,7 +421,7 @@
           <a:p>
             <a:fld id="{343BBA07-A3FE-4952-8777-070CB8556D2F}" type="datetimeFigureOut">
               <a:rPr lang="en-US" smtClean="0"/>
-              <a:t>5/18/2026</a:t>
+              <a:t>5/19/2026</a:t>
             </a:fld>
             <a:endParaRPr lang="en-US"/>
           </a:p>
@@ -598,7 +599,7 @@
           <a:p>
             <a:fld id="{343BBA07-A3FE-4952-8777-070CB8556D2F}" type="datetimeFigureOut">
               <a:rPr lang="en-US" smtClean="0"/>
-              <a:t>5/18/2026</a:t>
+              <a:t>5/19/2026</a:t>
             </a:fld>
             <a:endParaRPr lang="en-US"/>
           </a:p>
@@ -766,7 +767,7 @@
           <a:p>
             <a:fld id="{343BBA07-A3FE-4952-8777-070CB8556D2F}" type="datetimeFigureOut">
               <a:rPr lang="en-US" smtClean="0"/>
-              <a:t>5/18/2026</a:t>
+              <a:t>5/19/2026</a:t>
             </a:fld>
             <a:endParaRPr lang="en-US"/>
           </a:p>
@@ -1011,7 +1012,7 @@
           <a:p>
             <a:fld id="{343BBA07-A3FE-4952-8777-070CB8556D2F}" type="datetimeFigureOut">
               <a:rPr lang="en-US" smtClean="0"/>
-              <a:t>5/18/2026</a:t>
+              <a:t>5/19/2026</a:t>
             </a:fld>
             <a:endParaRPr lang="en-US"/>
           </a:p>
@@ -1240,7 +1241,7 @@
           <a:p>
             <a:fld id="{343BBA07-A3FE-4952-8777-070CB8556D2F}" type="datetimeFigureOut">
               <a:rPr lang="en-US" smtClean="0"/>
-              <a:t>5/18/2026</a:t>
+              <a:t>5/19/2026</a:t>
             </a:fld>
             <a:endParaRPr lang="en-US"/>
           </a:p>
@@ -1604,7 +1605,7 @@
           <a:p>
             <a:fld id="{343BBA07-A3FE-4952-8777-070CB8556D2F}" type="datetimeFigureOut">
               <a:rPr lang="en-US" smtClean="0"/>
-              <a:t>5/18/2026</a:t>
+              <a:t>5/19/2026</a:t>
             </a:fld>
             <a:endParaRPr lang="en-US"/>
           </a:p>
@@ -1721,7 +1722,7 @@
           <a:p>
             <a:fld id="{343BBA07-A3FE-4952-8777-070CB8556D2F}" type="datetimeFigureOut">
               <a:rPr lang="en-US" smtClean="0"/>
-              <a:t>5/18/2026</a:t>
+              <a:t>5/19/2026</a:t>
             </a:fld>
             <a:endParaRPr lang="en-US"/>
           </a:p>
@@ -1816,7 +1817,7 @@
           <a:p>
             <a:fld id="{343BBA07-A3FE-4952-8777-070CB8556D2F}" type="datetimeFigureOut">
               <a:rPr lang="en-US" smtClean="0"/>
-              <a:t>5/18/2026</a:t>
+              <a:t>5/19/2026</a:t>
             </a:fld>
             <a:endParaRPr lang="en-US"/>
           </a:p>
@@ -2091,7 +2092,7 @@
           <a:p>
             <a:fld id="{343BBA07-A3FE-4952-8777-070CB8556D2F}" type="datetimeFigureOut">
               <a:rPr lang="en-US" smtClean="0"/>
-              <a:t>5/18/2026</a:t>
+              <a:t>5/19/2026</a:t>
             </a:fld>
             <a:endParaRPr lang="en-US"/>
           </a:p>
@@ -2343,7 +2344,7 @@
           <a:p>
             <a:fld id="{343BBA07-A3FE-4952-8777-070CB8556D2F}" type="datetimeFigureOut">
               <a:rPr lang="en-US" smtClean="0"/>
-              <a:t>5/18/2026</a:t>
+              <a:t>5/19/2026</a:t>
             </a:fld>
             <a:endParaRPr lang="en-US"/>
           </a:p>
@@ -2554,7 +2555,7 @@
           <a:p>
             <a:fld id="{343BBA07-A3FE-4952-8777-070CB8556D2F}" type="datetimeFigureOut">
               <a:rPr lang="en-US" smtClean="0"/>
-              <a:t>5/18/2026</a:t>
+              <a:t>5/19/2026</a:t>
             </a:fld>
             <a:endParaRPr lang="en-US"/>
           </a:p>
@@ -3867,6 +3868,67 @@
 </p:sld>
 </file>
 
+<file path=ppt/slides/slide13.xml><?xml version="1.0" encoding="utf-8"?>
+<p:sld xmlns:a="http://schemas.openxmlformats.org/drawingml/2006/main" xmlns:r="http://schemas.openxmlformats.org/officeDocument/2006/relationships" xmlns:p="http://schemas.openxmlformats.org/presentationml/2006/main">
+  <p:cSld>
+    <p:spTree>
+      <p:nvGrpSpPr>
+        <p:cNvPr id="1" name=""/>
+        <p:cNvGrpSpPr/>
+        <p:nvPr/>
+      </p:nvGrpSpPr>
+      <p:grpSpPr>
+        <a:xfrm>
+          <a:off x="0" y="0"/>
+          <a:ext cx="0" cy="0"/>
+          <a:chOff x="0" y="0"/>
+          <a:chExt cx="0" cy="0"/>
+        </a:xfrm>
+      </p:grpSpPr>
+      <p:sp>
+        <p:nvSpPr>
+          <p:cNvPr id="2" name="Title 1"/>
+          <p:cNvSpPr>
+            <a:spLocks noGrp="1"/>
+          </p:cNvSpPr>
+          <p:nvPr>
+            <p:ph type="title"/>
+          </p:nvPr>
+        </p:nvSpPr>
+        <p:spPr>
+          <a:xfrm>
+            <a:off x="771698" y="2684376"/>
+            <a:ext cx="10515600" cy="1325563"/>
+          </a:xfrm>
+        </p:spPr>
+        <p:txBody>
+          <a:bodyPr>
+            <a:normAutofit/>
+          </a:bodyPr>
+          <a:lstStyle/>
+          <a:p>
+            <a:pPr algn="ctr"/>
+            <a:r>
+              <a:rPr lang="bg-BG" sz="7200" smtClean="0"/>
+              <a:t>Благодаря за вниманието!</a:t>
+            </a:r>
+            <a:endParaRPr lang="en-US" sz="7200"/>
+          </a:p>
+        </p:txBody>
+      </p:sp>
+    </p:spTree>
+    <p:extLst>
+      <p:ext uri="{BB962C8B-B14F-4D97-AF65-F5344CB8AC3E}">
+        <p14:creationId xmlns:p14="http://schemas.microsoft.com/office/powerpoint/2010/main" val="3190166377"/>
+      </p:ext>
+    </p:extLst>
+  </p:cSld>
+  <p:clrMapOvr>
+    <a:masterClrMapping/>
+  </p:clrMapOvr>
+</p:sld>
+</file>
+
 <file path=ppt/slides/slide2.xml><?xml version="1.0" encoding="utf-8"?>
 <p:sld xmlns:a="http://schemas.openxmlformats.org/drawingml/2006/main" xmlns:r="http://schemas.openxmlformats.org/officeDocument/2006/relationships" xmlns:p="http://schemas.openxmlformats.org/presentationml/2006/main">
   <p:cSld>

</xml_diff>

<commit_message>
db works on my pc now
</commit_message>
<xml_diff>
--- a/ТУ ВАРНА Music App Presentation.pptx
+++ b/ТУ ВАРНА Music App Presentation.pptx
@@ -7,14 +7,16 @@
   <p:sldIdLst>
     <p:sldId id="256" r:id="rId2"/>
     <p:sldId id="257" r:id="rId3"/>
-    <p:sldId id="258" r:id="rId4"/>
-    <p:sldId id="259" r:id="rId5"/>
-    <p:sldId id="260" r:id="rId6"/>
-    <p:sldId id="261" r:id="rId7"/>
-    <p:sldId id="262" r:id="rId8"/>
-    <p:sldId id="263" r:id="rId9"/>
-    <p:sldId id="264" r:id="rId10"/>
-    <p:sldId id="265" r:id="rId11"/>
+    <p:sldId id="266" r:id="rId4"/>
+    <p:sldId id="267" r:id="rId5"/>
+    <p:sldId id="258" r:id="rId6"/>
+    <p:sldId id="259" r:id="rId7"/>
+    <p:sldId id="260" r:id="rId8"/>
+    <p:sldId id="261" r:id="rId9"/>
+    <p:sldId id="262" r:id="rId10"/>
+    <p:sldId id="263" r:id="rId11"/>
+    <p:sldId id="264" r:id="rId12"/>
+    <p:sldId id="265" r:id="rId13"/>
   </p:sldIdLst>
   <p:sldSz cx="12192000" cy="6858000"/>
   <p:notesSz cx="6858000" cy="9144000"/>
@@ -113,6 +115,11 @@
       </a:defRPr>
     </a:lvl9pPr>
   </p:defaultTextStyle>
+  <p:extLst>
+    <p:ext uri="{EFAFB233-063F-42B5-8137-9DF3F51BA10A}">
+      <p15:sldGuideLst xmlns:p15="http://schemas.microsoft.com/office/powerpoint/2012/main"/>
+    </p:ext>
+  </p:extLst>
 </p:presentation>
 </file>
 
@@ -158,10 +165,9 @@
           </a:lstStyle>
           <a:p>
             <a:r>
-              <a:rPr lang="en-US" smtClean="0"/>
+              <a:rPr lang="en-US"/>
               <a:t>Click to edit Master title style</a:t>
             </a:r>
-            <a:endParaRPr lang="en-US"/>
           </a:p>
         </p:txBody>
       </p:sp>
@@ -223,10 +229,9 @@
           </a:lstStyle>
           <a:p>
             <a:r>
-              <a:rPr lang="en-US" smtClean="0"/>
+              <a:rPr lang="en-US"/>
               <a:t>Click to edit Master subtitle style</a:t>
             </a:r>
-            <a:endParaRPr lang="en-US"/>
           </a:p>
         </p:txBody>
       </p:sp>
@@ -247,7 +252,7 @@
           <a:p>
             <a:fld id="{343BBA07-A3FE-4952-8777-070CB8556D2F}" type="datetimeFigureOut">
               <a:rPr lang="en-US" smtClean="0"/>
-              <a:t>5/17/2026</a:t>
+              <a:t>5/18/2026</a:t>
             </a:fld>
             <a:endParaRPr lang="en-US"/>
           </a:p>
@@ -341,10 +346,9 @@
           <a:lstStyle/>
           <a:p>
             <a:r>
-              <a:rPr lang="en-US" smtClean="0"/>
+              <a:rPr lang="en-US"/>
               <a:t>Click to edit Master title style</a:t>
             </a:r>
-            <a:endParaRPr lang="en-US"/>
           </a:p>
         </p:txBody>
       </p:sp>
@@ -365,38 +369,37 @@
           <a:p>
             <a:pPr lvl="0"/>
             <a:r>
-              <a:rPr lang="en-US" smtClean="0"/>
+              <a:rPr lang="en-US"/>
               <a:t>Edit Master text styles</a:t>
             </a:r>
           </a:p>
           <a:p>
             <a:pPr lvl="1"/>
             <a:r>
-              <a:rPr lang="en-US" smtClean="0"/>
+              <a:rPr lang="en-US"/>
               <a:t>Second level</a:t>
             </a:r>
           </a:p>
           <a:p>
             <a:pPr lvl="2"/>
             <a:r>
-              <a:rPr lang="en-US" smtClean="0"/>
+              <a:rPr lang="en-US"/>
               <a:t>Third level</a:t>
             </a:r>
           </a:p>
           <a:p>
             <a:pPr lvl="3"/>
             <a:r>
-              <a:rPr lang="en-US" smtClean="0"/>
+              <a:rPr lang="en-US"/>
               <a:t>Fourth level</a:t>
             </a:r>
           </a:p>
           <a:p>
             <a:pPr lvl="4"/>
             <a:r>
-              <a:rPr lang="en-US" smtClean="0"/>
+              <a:rPr lang="en-US"/>
               <a:t>Fifth level</a:t>
             </a:r>
-            <a:endParaRPr lang="en-US"/>
           </a:p>
         </p:txBody>
       </p:sp>
@@ -417,7 +420,7 @@
           <a:p>
             <a:fld id="{343BBA07-A3FE-4952-8777-070CB8556D2F}" type="datetimeFigureOut">
               <a:rPr lang="en-US" smtClean="0"/>
-              <a:t>5/17/2026</a:t>
+              <a:t>5/18/2026</a:t>
             </a:fld>
             <a:endParaRPr lang="en-US"/>
           </a:p>
@@ -516,10 +519,9 @@
           <a:lstStyle/>
           <a:p>
             <a:r>
-              <a:rPr lang="en-US" smtClean="0"/>
+              <a:rPr lang="en-US"/>
               <a:t>Click to edit Master title style</a:t>
             </a:r>
-            <a:endParaRPr lang="en-US"/>
           </a:p>
         </p:txBody>
       </p:sp>
@@ -545,38 +547,37 @@
           <a:p>
             <a:pPr lvl="0"/>
             <a:r>
-              <a:rPr lang="en-US" smtClean="0"/>
+              <a:rPr lang="en-US"/>
               <a:t>Edit Master text styles</a:t>
             </a:r>
           </a:p>
           <a:p>
             <a:pPr lvl="1"/>
             <a:r>
-              <a:rPr lang="en-US" smtClean="0"/>
+              <a:rPr lang="en-US"/>
               <a:t>Second level</a:t>
             </a:r>
           </a:p>
           <a:p>
             <a:pPr lvl="2"/>
             <a:r>
-              <a:rPr lang="en-US" smtClean="0"/>
+              <a:rPr lang="en-US"/>
               <a:t>Third level</a:t>
             </a:r>
           </a:p>
           <a:p>
             <a:pPr lvl="3"/>
             <a:r>
-              <a:rPr lang="en-US" smtClean="0"/>
+              <a:rPr lang="en-US"/>
               <a:t>Fourth level</a:t>
             </a:r>
           </a:p>
           <a:p>
             <a:pPr lvl="4"/>
             <a:r>
-              <a:rPr lang="en-US" smtClean="0"/>
+              <a:rPr lang="en-US"/>
               <a:t>Fifth level</a:t>
             </a:r>
-            <a:endParaRPr lang="en-US"/>
           </a:p>
         </p:txBody>
       </p:sp>
@@ -597,7 +598,7 @@
           <a:p>
             <a:fld id="{343BBA07-A3FE-4952-8777-070CB8556D2F}" type="datetimeFigureOut">
               <a:rPr lang="en-US" smtClean="0"/>
-              <a:t>5/17/2026</a:t>
+              <a:t>5/18/2026</a:t>
             </a:fld>
             <a:endParaRPr lang="en-US"/>
           </a:p>
@@ -691,10 +692,9 @@
           <a:lstStyle/>
           <a:p>
             <a:r>
-              <a:rPr lang="en-US" smtClean="0"/>
+              <a:rPr lang="en-US"/>
               <a:t>Click to edit Master title style</a:t>
             </a:r>
-            <a:endParaRPr lang="en-US"/>
           </a:p>
         </p:txBody>
       </p:sp>
@@ -715,38 +715,37 @@
           <a:p>
             <a:pPr lvl="0"/>
             <a:r>
-              <a:rPr lang="en-US" smtClean="0"/>
+              <a:rPr lang="en-US"/>
               <a:t>Edit Master text styles</a:t>
             </a:r>
           </a:p>
           <a:p>
             <a:pPr lvl="1"/>
             <a:r>
-              <a:rPr lang="en-US" smtClean="0"/>
+              <a:rPr lang="en-US"/>
               <a:t>Second level</a:t>
             </a:r>
           </a:p>
           <a:p>
             <a:pPr lvl="2"/>
             <a:r>
-              <a:rPr lang="en-US" smtClean="0"/>
+              <a:rPr lang="en-US"/>
               <a:t>Third level</a:t>
             </a:r>
           </a:p>
           <a:p>
             <a:pPr lvl="3"/>
             <a:r>
-              <a:rPr lang="en-US" smtClean="0"/>
+              <a:rPr lang="en-US"/>
               <a:t>Fourth level</a:t>
             </a:r>
           </a:p>
           <a:p>
             <a:pPr lvl="4"/>
             <a:r>
-              <a:rPr lang="en-US" smtClean="0"/>
+              <a:rPr lang="en-US"/>
               <a:t>Fifth level</a:t>
             </a:r>
-            <a:endParaRPr lang="en-US"/>
           </a:p>
         </p:txBody>
       </p:sp>
@@ -767,7 +766,7 @@
           <a:p>
             <a:fld id="{343BBA07-A3FE-4952-8777-070CB8556D2F}" type="datetimeFigureOut">
               <a:rPr lang="en-US" smtClean="0"/>
-              <a:t>5/17/2026</a:t>
+              <a:t>5/18/2026</a:t>
             </a:fld>
             <a:endParaRPr lang="en-US"/>
           </a:p>
@@ -870,10 +869,9 @@
           </a:lstStyle>
           <a:p>
             <a:r>
-              <a:rPr lang="en-US" smtClean="0"/>
+              <a:rPr lang="en-US"/>
               <a:t>Click to edit Master title style</a:t>
             </a:r>
-            <a:endParaRPr lang="en-US"/>
           </a:p>
         </p:txBody>
       </p:sp>
@@ -990,7 +988,7 @@
           <a:p>
             <a:pPr lvl="0"/>
             <a:r>
-              <a:rPr lang="en-US" smtClean="0"/>
+              <a:rPr lang="en-US"/>
               <a:t>Edit Master text styles</a:t>
             </a:r>
           </a:p>
@@ -1013,7 +1011,7 @@
           <a:p>
             <a:fld id="{343BBA07-A3FE-4952-8777-070CB8556D2F}" type="datetimeFigureOut">
               <a:rPr lang="en-US" smtClean="0"/>
-              <a:t>5/17/2026</a:t>
+              <a:t>5/18/2026</a:t>
             </a:fld>
             <a:endParaRPr lang="en-US"/>
           </a:p>
@@ -1107,10 +1105,9 @@
           <a:lstStyle/>
           <a:p>
             <a:r>
-              <a:rPr lang="en-US" smtClean="0"/>
+              <a:rPr lang="en-US"/>
               <a:t>Click to edit Master title style</a:t>
             </a:r>
-            <a:endParaRPr lang="en-US"/>
           </a:p>
         </p:txBody>
       </p:sp>
@@ -1136,38 +1133,37 @@
           <a:p>
             <a:pPr lvl="0"/>
             <a:r>
-              <a:rPr lang="en-US" smtClean="0"/>
+              <a:rPr lang="en-US"/>
               <a:t>Edit Master text styles</a:t>
             </a:r>
           </a:p>
           <a:p>
             <a:pPr lvl="1"/>
             <a:r>
-              <a:rPr lang="en-US" smtClean="0"/>
+              <a:rPr lang="en-US"/>
               <a:t>Second level</a:t>
             </a:r>
           </a:p>
           <a:p>
             <a:pPr lvl="2"/>
             <a:r>
-              <a:rPr lang="en-US" smtClean="0"/>
+              <a:rPr lang="en-US"/>
               <a:t>Third level</a:t>
             </a:r>
           </a:p>
           <a:p>
             <a:pPr lvl="3"/>
             <a:r>
-              <a:rPr lang="en-US" smtClean="0"/>
+              <a:rPr lang="en-US"/>
               <a:t>Fourth level</a:t>
             </a:r>
           </a:p>
           <a:p>
             <a:pPr lvl="4"/>
             <a:r>
-              <a:rPr lang="en-US" smtClean="0"/>
+              <a:rPr lang="en-US"/>
               <a:t>Fifth level</a:t>
             </a:r>
-            <a:endParaRPr lang="en-US"/>
           </a:p>
         </p:txBody>
       </p:sp>
@@ -1193,38 +1189,37 @@
           <a:p>
             <a:pPr lvl="0"/>
             <a:r>
-              <a:rPr lang="en-US" smtClean="0"/>
+              <a:rPr lang="en-US"/>
               <a:t>Edit Master text styles</a:t>
             </a:r>
           </a:p>
           <a:p>
             <a:pPr lvl="1"/>
             <a:r>
-              <a:rPr lang="en-US" smtClean="0"/>
+              <a:rPr lang="en-US"/>
               <a:t>Second level</a:t>
             </a:r>
           </a:p>
           <a:p>
             <a:pPr lvl="2"/>
             <a:r>
-              <a:rPr lang="en-US" smtClean="0"/>
+              <a:rPr lang="en-US"/>
               <a:t>Third level</a:t>
             </a:r>
           </a:p>
           <a:p>
             <a:pPr lvl="3"/>
             <a:r>
-              <a:rPr lang="en-US" smtClean="0"/>
+              <a:rPr lang="en-US"/>
               <a:t>Fourth level</a:t>
             </a:r>
           </a:p>
           <a:p>
             <a:pPr lvl="4"/>
             <a:r>
-              <a:rPr lang="en-US" smtClean="0"/>
+              <a:rPr lang="en-US"/>
               <a:t>Fifth level</a:t>
             </a:r>
-            <a:endParaRPr lang="en-US"/>
           </a:p>
         </p:txBody>
       </p:sp>
@@ -1245,7 +1240,7 @@
           <a:p>
             <a:fld id="{343BBA07-A3FE-4952-8777-070CB8556D2F}" type="datetimeFigureOut">
               <a:rPr lang="en-US" smtClean="0"/>
-              <a:t>5/17/2026</a:t>
+              <a:t>5/18/2026</a:t>
             </a:fld>
             <a:endParaRPr lang="en-US"/>
           </a:p>
@@ -1344,10 +1339,9 @@
           <a:lstStyle/>
           <a:p>
             <a:r>
-              <a:rPr lang="en-US" smtClean="0"/>
+              <a:rPr lang="en-US"/>
               <a:t>Click to edit Master title style</a:t>
             </a:r>
-            <a:endParaRPr lang="en-US"/>
           </a:p>
         </p:txBody>
       </p:sp>
@@ -1410,7 +1404,7 @@
           <a:p>
             <a:pPr lvl="0"/>
             <a:r>
-              <a:rPr lang="en-US" smtClean="0"/>
+              <a:rPr lang="en-US"/>
               <a:t>Edit Master text styles</a:t>
             </a:r>
           </a:p>
@@ -1438,38 +1432,37 @@
           <a:p>
             <a:pPr lvl="0"/>
             <a:r>
-              <a:rPr lang="en-US" smtClean="0"/>
+              <a:rPr lang="en-US"/>
               <a:t>Edit Master text styles</a:t>
             </a:r>
           </a:p>
           <a:p>
             <a:pPr lvl="1"/>
             <a:r>
-              <a:rPr lang="en-US" smtClean="0"/>
+              <a:rPr lang="en-US"/>
               <a:t>Second level</a:t>
             </a:r>
           </a:p>
           <a:p>
             <a:pPr lvl="2"/>
             <a:r>
-              <a:rPr lang="en-US" smtClean="0"/>
+              <a:rPr lang="en-US"/>
               <a:t>Third level</a:t>
             </a:r>
           </a:p>
           <a:p>
             <a:pPr lvl="3"/>
             <a:r>
-              <a:rPr lang="en-US" smtClean="0"/>
+              <a:rPr lang="en-US"/>
               <a:t>Fourth level</a:t>
             </a:r>
           </a:p>
           <a:p>
             <a:pPr lvl="4"/>
             <a:r>
-              <a:rPr lang="en-US" smtClean="0"/>
+              <a:rPr lang="en-US"/>
               <a:t>Fifth level</a:t>
             </a:r>
-            <a:endParaRPr lang="en-US"/>
           </a:p>
         </p:txBody>
       </p:sp>
@@ -1532,7 +1525,7 @@
           <a:p>
             <a:pPr lvl="0"/>
             <a:r>
-              <a:rPr lang="en-US" smtClean="0"/>
+              <a:rPr lang="en-US"/>
               <a:t>Edit Master text styles</a:t>
             </a:r>
           </a:p>
@@ -1560,38 +1553,37 @@
           <a:p>
             <a:pPr lvl="0"/>
             <a:r>
-              <a:rPr lang="en-US" smtClean="0"/>
+              <a:rPr lang="en-US"/>
               <a:t>Edit Master text styles</a:t>
             </a:r>
           </a:p>
           <a:p>
             <a:pPr lvl="1"/>
             <a:r>
-              <a:rPr lang="en-US" smtClean="0"/>
+              <a:rPr lang="en-US"/>
               <a:t>Second level</a:t>
             </a:r>
           </a:p>
           <a:p>
             <a:pPr lvl="2"/>
             <a:r>
-              <a:rPr lang="en-US" smtClean="0"/>
+              <a:rPr lang="en-US"/>
               <a:t>Third level</a:t>
             </a:r>
           </a:p>
           <a:p>
             <a:pPr lvl="3"/>
             <a:r>
-              <a:rPr lang="en-US" smtClean="0"/>
+              <a:rPr lang="en-US"/>
               <a:t>Fourth level</a:t>
             </a:r>
           </a:p>
           <a:p>
             <a:pPr lvl="4"/>
             <a:r>
-              <a:rPr lang="en-US" smtClean="0"/>
+              <a:rPr lang="en-US"/>
               <a:t>Fifth level</a:t>
             </a:r>
-            <a:endParaRPr lang="en-US"/>
           </a:p>
         </p:txBody>
       </p:sp>
@@ -1612,7 +1604,7 @@
           <a:p>
             <a:fld id="{343BBA07-A3FE-4952-8777-070CB8556D2F}" type="datetimeFigureOut">
               <a:rPr lang="en-US" smtClean="0"/>
-              <a:t>5/17/2026</a:t>
+              <a:t>5/18/2026</a:t>
             </a:fld>
             <a:endParaRPr lang="en-US"/>
           </a:p>
@@ -1706,10 +1698,9 @@
           <a:lstStyle/>
           <a:p>
             <a:r>
-              <a:rPr lang="en-US" smtClean="0"/>
+              <a:rPr lang="en-US"/>
               <a:t>Click to edit Master title style</a:t>
             </a:r>
-            <a:endParaRPr lang="en-US"/>
           </a:p>
         </p:txBody>
       </p:sp>
@@ -1730,7 +1721,7 @@
           <a:p>
             <a:fld id="{343BBA07-A3FE-4952-8777-070CB8556D2F}" type="datetimeFigureOut">
               <a:rPr lang="en-US" smtClean="0"/>
-              <a:t>5/17/2026</a:t>
+              <a:t>5/18/2026</a:t>
             </a:fld>
             <a:endParaRPr lang="en-US"/>
           </a:p>
@@ -1825,7 +1816,7 @@
           <a:p>
             <a:fld id="{343BBA07-A3FE-4952-8777-070CB8556D2F}" type="datetimeFigureOut">
               <a:rPr lang="en-US" smtClean="0"/>
-              <a:t>5/17/2026</a:t>
+              <a:t>5/18/2026</a:t>
             </a:fld>
             <a:endParaRPr lang="en-US"/>
           </a:p>
@@ -1928,10 +1919,9 @@
           </a:lstStyle>
           <a:p>
             <a:r>
-              <a:rPr lang="en-US" smtClean="0"/>
+              <a:rPr lang="en-US"/>
               <a:t>Click to edit Master title style</a:t>
             </a:r>
-            <a:endParaRPr lang="en-US"/>
           </a:p>
         </p:txBody>
       </p:sp>
@@ -1985,38 +1975,37 @@
           <a:p>
             <a:pPr lvl="0"/>
             <a:r>
-              <a:rPr lang="en-US" smtClean="0"/>
+              <a:rPr lang="en-US"/>
               <a:t>Edit Master text styles</a:t>
             </a:r>
           </a:p>
           <a:p>
             <a:pPr lvl="1"/>
             <a:r>
-              <a:rPr lang="en-US" smtClean="0"/>
+              <a:rPr lang="en-US"/>
               <a:t>Second level</a:t>
             </a:r>
           </a:p>
           <a:p>
             <a:pPr lvl="2"/>
             <a:r>
-              <a:rPr lang="en-US" smtClean="0"/>
+              <a:rPr lang="en-US"/>
               <a:t>Third level</a:t>
             </a:r>
           </a:p>
           <a:p>
             <a:pPr lvl="3"/>
             <a:r>
-              <a:rPr lang="en-US" smtClean="0"/>
+              <a:rPr lang="en-US"/>
               <a:t>Fourth level</a:t>
             </a:r>
           </a:p>
           <a:p>
             <a:pPr lvl="4"/>
             <a:r>
-              <a:rPr lang="en-US" smtClean="0"/>
+              <a:rPr lang="en-US"/>
               <a:t>Fifth level</a:t>
             </a:r>
-            <a:endParaRPr lang="en-US"/>
           </a:p>
         </p:txBody>
       </p:sp>
@@ -2079,7 +2068,7 @@
           <a:p>
             <a:pPr lvl="0"/>
             <a:r>
-              <a:rPr lang="en-US" smtClean="0"/>
+              <a:rPr lang="en-US"/>
               <a:t>Edit Master text styles</a:t>
             </a:r>
           </a:p>
@@ -2102,7 +2091,7 @@
           <a:p>
             <a:fld id="{343BBA07-A3FE-4952-8777-070CB8556D2F}" type="datetimeFigureOut">
               <a:rPr lang="en-US" smtClean="0"/>
-              <a:t>5/17/2026</a:t>
+              <a:t>5/18/2026</a:t>
             </a:fld>
             <a:endParaRPr lang="en-US"/>
           </a:p>
@@ -2205,10 +2194,9 @@
           </a:lstStyle>
           <a:p>
             <a:r>
-              <a:rPr lang="en-US" smtClean="0"/>
+              <a:rPr lang="en-US"/>
               <a:t>Click to edit Master title style</a:t>
             </a:r>
-            <a:endParaRPr lang="en-US"/>
           </a:p>
         </p:txBody>
       </p:sp>
@@ -2332,7 +2320,7 @@
           <a:p>
             <a:pPr lvl="0"/>
             <a:r>
-              <a:rPr lang="en-US" smtClean="0"/>
+              <a:rPr lang="en-US"/>
               <a:t>Edit Master text styles</a:t>
             </a:r>
           </a:p>
@@ -2355,7 +2343,7 @@
           <a:p>
             <a:fld id="{343BBA07-A3FE-4952-8777-070CB8556D2F}" type="datetimeFigureOut">
               <a:rPr lang="en-US" smtClean="0"/>
-              <a:t>5/17/2026</a:t>
+              <a:t>5/18/2026</a:t>
             </a:fld>
             <a:endParaRPr lang="en-US"/>
           </a:p>
@@ -2464,10 +2452,9 @@
           <a:lstStyle/>
           <a:p>
             <a:r>
-              <a:rPr lang="en-US" smtClean="0"/>
+              <a:rPr lang="en-US"/>
               <a:t>Click to edit Master title style</a:t>
             </a:r>
-            <a:endParaRPr lang="en-US"/>
           </a:p>
         </p:txBody>
       </p:sp>
@@ -2498,38 +2485,37 @@
           <a:p>
             <a:pPr lvl="0"/>
             <a:r>
-              <a:rPr lang="en-US" smtClean="0"/>
+              <a:rPr lang="en-US"/>
               <a:t>Edit Master text styles</a:t>
             </a:r>
           </a:p>
           <a:p>
             <a:pPr lvl="1"/>
             <a:r>
-              <a:rPr lang="en-US" smtClean="0"/>
+              <a:rPr lang="en-US"/>
               <a:t>Second level</a:t>
             </a:r>
           </a:p>
           <a:p>
             <a:pPr lvl="2"/>
             <a:r>
-              <a:rPr lang="en-US" smtClean="0"/>
+              <a:rPr lang="en-US"/>
               <a:t>Third level</a:t>
             </a:r>
           </a:p>
           <a:p>
             <a:pPr lvl="3"/>
             <a:r>
-              <a:rPr lang="en-US" smtClean="0"/>
+              <a:rPr lang="en-US"/>
               <a:t>Fourth level</a:t>
             </a:r>
           </a:p>
           <a:p>
             <a:pPr lvl="4"/>
             <a:r>
-              <a:rPr lang="en-US" smtClean="0"/>
+              <a:rPr lang="en-US"/>
               <a:t>Fifth level</a:t>
             </a:r>
-            <a:endParaRPr lang="en-US"/>
           </a:p>
         </p:txBody>
       </p:sp>
@@ -2568,7 +2554,7 @@
           <a:p>
             <a:fld id="{343BBA07-A3FE-4952-8777-070CB8556D2F}" type="datetimeFigureOut">
               <a:rPr lang="en-US" smtClean="0"/>
-              <a:t>5/17/2026</a:t>
+              <a:t>5/18/2026</a:t>
             </a:fld>
             <a:endParaRPr lang="en-US"/>
           </a:p>
@@ -2983,52 +2969,53 @@
             <p:ph type="ctrTitle"/>
           </p:nvPr>
         </p:nvSpPr>
-        <p:spPr>
-          <a:xfrm>
-            <a:off x="1490749" y="2161454"/>
-            <a:ext cx="9144000" cy="2387600"/>
-          </a:xfrm>
-        </p:spPr>
+        <p:spPr/>
         <p:txBody>
           <a:bodyPr>
-            <a:normAutofit fontScale="90000"/>
+            <a:normAutofit/>
           </a:bodyPr>
           <a:lstStyle/>
           <a:p>
             <a:r>
-              <a:rPr lang="bg-BG"/>
-              <a:t>ТУ ВАРНА</a:t>
-            </a:r>
-            <a:r>
-              <a:rPr lang="en-US"/>
-              <a:t/>
-            </a:r>
-            <a:br>
-              <a:rPr lang="en-US"/>
-            </a:br>
-            <a:r>
-              <a:rPr lang="bg-BG"/>
-              <a:t>Проект по тема </a:t>
-            </a:r>
-            <a:r>
-              <a:rPr lang="en-US"/>
-              <a:t/>
-            </a:r>
-            <a:br>
-              <a:rPr lang="en-US"/>
-            </a:br>
-            <a:r>
-              <a:rPr lang="bg-BG"/>
-              <a:t>“Система за избор на песен“</a:t>
-            </a:r>
-            <a:r>
-              <a:rPr lang="en-US"/>
-              <a:t/>
-            </a:r>
-            <a:br>
-              <a:rPr lang="en-US"/>
-            </a:br>
-            <a:endParaRPr lang="en-US"/>
+              <a:rPr lang="bg-BG" noProof="0" dirty="0"/>
+              <a:t>ТЕМА 6 – СИСТЕМА ЗА ИЗБОР НА ПЕСЕН</a:t>
+            </a:r>
+          </a:p>
+        </p:txBody>
+      </p:sp>
+      <p:sp>
+        <p:nvSpPr>
+          <p:cNvPr id="4" name="Подзаглавие 3">
+            <a:extLst>
+              <a:ext uri="{FF2B5EF4-FFF2-40B4-BE49-F238E27FC236}">
+                <a16:creationId xmlns:a16="http://schemas.microsoft.com/office/drawing/2014/main" id="{EBA7FFAA-E257-AE54-AF44-2A65B50D3A4E}"/>
+              </a:ext>
+            </a:extLst>
+          </p:cNvPr>
+          <p:cNvSpPr>
+            <a:spLocks noGrp="1"/>
+          </p:cNvSpPr>
+          <p:nvPr>
+            <p:ph type="subTitle" idx="1"/>
+          </p:nvPr>
+        </p:nvSpPr>
+        <p:spPr/>
+        <p:txBody>
+          <a:bodyPr>
+            <a:normAutofit/>
+          </a:bodyPr>
+          <a:lstStyle/>
+          <a:p>
+            <a:r>
+              <a:rPr lang="bg-BG" noProof="0" dirty="0"/>
+              <a:t>Изработена от Теодор Ангелов и Йово Неделчев</a:t>
+            </a:r>
+          </a:p>
+          <a:p>
+            <a:r>
+              <a:rPr lang="bg-BG" noProof="0" dirty="0"/>
+              <a:t>Курсов проект от ТУ Варна</a:t>
+            </a:r>
           </a:p>
         </p:txBody>
       </p:sp>
@@ -3074,1111 +3061,20 @@
         </p:nvSpPr>
         <p:spPr/>
         <p:txBody>
-          <a:bodyPr/>
-          <a:lstStyle/>
-          <a:p>
-            <a:r>
-              <a:rPr lang="en-US"/>
-              <a:t>9.</a:t>
-            </a:r>
-            <a:r>
-              <a:rPr lang="bg-BG"/>
-              <a:t>Използвани класове</a:t>
-            </a:r>
-            <a:r>
-              <a:rPr lang="en-US"/>
-              <a:t/>
+          <a:bodyPr>
+            <a:normAutofit/>
+          </a:bodyPr>
+          <a:lstStyle/>
+          <a:p>
+            <a:pPr algn="ctr"/>
+            <a:r>
+              <a:rPr lang="bg-BG" noProof="0" dirty="0"/>
+              <a:t>Програмни средства за реализацията </a:t>
             </a:r>
             <a:br>
-              <a:rPr lang="en-US"/>
+              <a:rPr lang="bg-BG" noProof="0" dirty="0"/>
             </a:br>
-            <a:endParaRPr lang="en-US"/>
-          </a:p>
-        </p:txBody>
-      </p:sp>
-      <p:sp>
-        <p:nvSpPr>
-          <p:cNvPr id="3" name="Content Placeholder 2"/>
-          <p:cNvSpPr>
-            <a:spLocks noGrp="1"/>
-          </p:cNvSpPr>
-          <p:nvPr>
-            <p:ph idx="1"/>
-          </p:nvPr>
-        </p:nvSpPr>
-        <p:spPr>
-          <a:xfrm>
-            <a:off x="0" y="1038224"/>
-            <a:ext cx="8801100" cy="5819775"/>
-          </a:xfrm>
-        </p:spPr>
-        <p:txBody>
-          <a:bodyPr>
-            <a:normAutofit fontScale="85000" lnSpcReduction="20000"/>
-          </a:bodyPr>
-          <a:lstStyle/>
-          <a:p>
-            <a:r>
-              <a:rPr lang="en-US"/>
-              <a:t>Program – </a:t>
-            </a:r>
-            <a:r>
-              <a:rPr lang="bg-BG"/>
-              <a:t>Класът, който съдържа логиката за подкарване на </a:t>
-            </a:r>
-            <a:r>
-              <a:rPr lang="en-US"/>
-              <a:t>web </a:t>
-            </a:r>
-            <a:r>
-              <a:rPr lang="bg-BG"/>
-              <a:t>апликацията.</a:t>
-            </a:r>
-            <a:endParaRPr lang="en-US"/>
-          </a:p>
-          <a:p>
-            <a:r>
-              <a:rPr lang="en-US"/>
-              <a:t>ApplicationDbContext</a:t>
-            </a:r>
-            <a:r>
-              <a:rPr lang="bg-BG"/>
-              <a:t> – В този клас се съдържа информацията за песните, коята се извилича от базата данни, и от коята се пише в базата данни.</a:t>
-            </a:r>
-            <a:endParaRPr lang="en-US"/>
-          </a:p>
-          <a:p>
-            <a:r>
-              <a:rPr lang="en-US"/>
-              <a:t>Song – </a:t>
-            </a:r>
-            <a:r>
-              <a:rPr lang="bg-BG"/>
-              <a:t>Това е класът модел, който служи за създаване на обектите за песни.</a:t>
-            </a:r>
-            <a:endParaRPr lang="en-US"/>
-          </a:p>
-          <a:p>
-            <a:r>
-              <a:rPr lang="en-US"/>
-              <a:t>Genres – </a:t>
-            </a:r>
-            <a:r>
-              <a:rPr lang="bg-BG"/>
-              <a:t>Клас, който съдържа статичен лист с популярни жанрове на песни, с цел да помага в създаването на обекти.</a:t>
-            </a:r>
-            <a:endParaRPr lang="en-US"/>
-          </a:p>
-          <a:p>
-            <a:r>
-              <a:rPr lang="en-US"/>
-              <a:t>HomeController – </a:t>
-            </a:r>
-            <a:r>
-              <a:rPr lang="bg-BG"/>
-              <a:t>Класът за контролера, който съдържа всички методи, които позволяват работата между базата данни и потребителският интерфейс.</a:t>
-            </a:r>
-            <a:endParaRPr lang="en-US"/>
-          </a:p>
-          <a:p>
-            <a:r>
-              <a:rPr lang="en-US"/>
-              <a:t>AddSongViewModel/BasicSongViewModel/DeleteSongViewModel – </a:t>
-            </a:r>
-            <a:r>
-              <a:rPr lang="bg-BG"/>
-              <a:t>класове, които служат за помощ с иползването на данни от модела </a:t>
-            </a:r>
-            <a:r>
-              <a:rPr lang="en-US"/>
-              <a:t>Song </a:t>
-            </a:r>
-            <a:r>
-              <a:rPr lang="bg-BG"/>
-              <a:t>в страниците на апликацията.</a:t>
-            </a:r>
-            <a:endParaRPr lang="en-US"/>
-          </a:p>
-          <a:p>
-            <a:r>
-              <a:rPr lang="en-US"/>
-              <a:t>Add</a:t>
-            </a:r>
-            <a:r>
-              <a:rPr lang="bg-BG"/>
-              <a:t>/</a:t>
-            </a:r>
-            <a:r>
-              <a:rPr lang="en-US"/>
-              <a:t>Edit/Delete/Index – View </a:t>
-            </a:r>
-            <a:r>
-              <a:rPr lang="bg-BG"/>
-              <a:t>файлoвете, които съдържат структурата на страниците за апликацията.</a:t>
-            </a:r>
-            <a:endParaRPr lang="en-US"/>
-          </a:p>
-        </p:txBody>
-      </p:sp>
-      <p:pic>
-        <p:nvPicPr>
-          <p:cNvPr id="4" name="Picture 3"/>
-          <p:cNvPicPr>
-            <a:picLocks noChangeAspect="1"/>
-          </p:cNvPicPr>
-          <p:nvPr/>
-        </p:nvPicPr>
-        <p:blipFill>
-          <a:blip r:embed="rId2"/>
-          <a:stretch>
-            <a:fillRect/>
-          </a:stretch>
-        </p:blipFill>
-        <p:spPr>
-          <a:xfrm>
-            <a:off x="9534524" y="128587"/>
-            <a:ext cx="2533651" cy="6656390"/>
-          </a:xfrm>
-          <a:prstGeom prst="rect">
-            <a:avLst/>
-          </a:prstGeom>
-        </p:spPr>
-      </p:pic>
-    </p:spTree>
-    <p:extLst>
-      <p:ext uri="{BB962C8B-B14F-4D97-AF65-F5344CB8AC3E}">
-        <p14:creationId xmlns:p14="http://schemas.microsoft.com/office/powerpoint/2010/main" val="233053847"/>
-      </p:ext>
-    </p:extLst>
-  </p:cSld>
-  <p:clrMapOvr>
-    <a:masterClrMapping/>
-  </p:clrMapOvr>
-</p:sld>
-</file>
-
-<file path=ppt/slides/slide2.xml><?xml version="1.0" encoding="utf-8"?>
-<p:sld xmlns:a="http://schemas.openxmlformats.org/drawingml/2006/main" xmlns:r="http://schemas.openxmlformats.org/officeDocument/2006/relationships" xmlns:p="http://schemas.openxmlformats.org/presentationml/2006/main">
-  <p:cSld>
-    <p:spTree>
-      <p:nvGrpSpPr>
-        <p:cNvPr id="1" name=""/>
-        <p:cNvGrpSpPr/>
-        <p:nvPr/>
-      </p:nvGrpSpPr>
-      <p:grpSpPr>
-        <a:xfrm>
-          <a:off x="0" y="0"/>
-          <a:ext cx="0" cy="0"/>
-          <a:chOff x="0" y="0"/>
-          <a:chExt cx="0" cy="0"/>
-        </a:xfrm>
-      </p:grpSpPr>
-      <p:sp>
-        <p:nvSpPr>
-          <p:cNvPr id="2" name="Title 1"/>
-          <p:cNvSpPr>
-            <a:spLocks noGrp="1"/>
-          </p:cNvSpPr>
-          <p:nvPr>
-            <p:ph type="title"/>
-          </p:nvPr>
-        </p:nvSpPr>
-        <p:spPr/>
-        <p:txBody>
-          <a:bodyPr/>
-          <a:lstStyle/>
-          <a:p>
-            <a:r>
-              <a:rPr lang="bg-BG"/>
-              <a:t>1.Техническо Задание</a:t>
-            </a:r>
-            <a:r>
-              <a:rPr lang="en-US"/>
-              <a:t/>
-            </a:r>
-            <a:br>
-              <a:rPr lang="en-US"/>
-            </a:br>
-            <a:endParaRPr lang="en-US"/>
-          </a:p>
-        </p:txBody>
-      </p:sp>
-      <p:pic>
-        <p:nvPicPr>
-          <p:cNvPr id="1026" name="Picture 2" descr="https://cdn.discordapp.com/attachments/1422853389347455053/1495497283985346701/image.png?ex=6a0ab721&amp;is=6a0965a1&amp;hm=9a2e02aad2993d7120b8b8182d290f112d47b42f7fc38aa751a05fbbaec48b6e&amp;"/>
-          <p:cNvPicPr>
-            <a:picLocks noGrp="1" noChangeAspect="1" noChangeArrowheads="1"/>
-          </p:cNvPicPr>
-          <p:nvPr>
-            <p:ph idx="1"/>
-          </p:nvPr>
-        </p:nvPicPr>
-        <p:blipFill>
-          <a:blip r:embed="rId2">
-            <a:extLst>
-              <a:ext uri="{28A0092B-C50C-407E-A947-70E740481C1C}">
-                <a14:useLocalDpi xmlns:a14="http://schemas.microsoft.com/office/drawing/2010/main" val="0"/>
-              </a:ext>
-            </a:extLst>
-          </a:blip>
-          <a:srcRect/>
-          <a:stretch>
-            <a:fillRect/>
-          </a:stretch>
-        </p:blipFill>
-        <p:spPr bwMode="auto">
-          <a:xfrm>
-            <a:off x="778766" y="1690688"/>
-            <a:ext cx="10327557" cy="2074977"/>
-          </a:xfrm>
-          <a:prstGeom prst="rect">
-            <a:avLst/>
-          </a:prstGeom>
-          <a:noFill/>
-          <a:extLst>
-            <a:ext uri="{909E8E84-426E-40DD-AFC4-6F175D3DCCD1}">
-              <a14:hiddenFill xmlns:a14="http://schemas.microsoft.com/office/drawing/2010/main">
-                <a:solidFill>
-                  <a:srgbClr val="FFFFFF"/>
-                </a:solidFill>
-              </a14:hiddenFill>
-            </a:ext>
-          </a:extLst>
-        </p:spPr>
-      </p:pic>
-    </p:spTree>
-    <p:extLst>
-      <p:ext uri="{BB962C8B-B14F-4D97-AF65-F5344CB8AC3E}">
-        <p14:creationId xmlns:p14="http://schemas.microsoft.com/office/powerpoint/2010/main" val="1768123233"/>
-      </p:ext>
-    </p:extLst>
-  </p:cSld>
-  <p:clrMapOvr>
-    <a:masterClrMapping/>
-  </p:clrMapOvr>
-</p:sld>
-</file>
-
-<file path=ppt/slides/slide3.xml><?xml version="1.0" encoding="utf-8"?>
-<p:sld xmlns:a="http://schemas.openxmlformats.org/drawingml/2006/main" xmlns:r="http://schemas.openxmlformats.org/officeDocument/2006/relationships" xmlns:p="http://schemas.openxmlformats.org/presentationml/2006/main">
-  <p:cSld>
-    <p:spTree>
-      <p:nvGrpSpPr>
-        <p:cNvPr id="1" name=""/>
-        <p:cNvGrpSpPr/>
-        <p:nvPr/>
-      </p:nvGrpSpPr>
-      <p:grpSpPr>
-        <a:xfrm>
-          <a:off x="0" y="0"/>
-          <a:ext cx="0" cy="0"/>
-          <a:chOff x="0" y="0"/>
-          <a:chExt cx="0" cy="0"/>
-        </a:xfrm>
-      </p:grpSpPr>
-      <p:sp>
-        <p:nvSpPr>
-          <p:cNvPr id="2" name="Title 1"/>
-          <p:cNvSpPr>
-            <a:spLocks noGrp="1"/>
-          </p:cNvSpPr>
-          <p:nvPr>
-            <p:ph type="title"/>
-          </p:nvPr>
-        </p:nvSpPr>
-        <p:spPr/>
-        <p:txBody>
-          <a:bodyPr>
-            <a:normAutofit fontScale="90000"/>
-          </a:bodyPr>
-          <a:lstStyle/>
-          <a:p>
-            <a:r>
-              <a:rPr lang="en-US"/>
-              <a:t>2.</a:t>
-            </a:r>
-            <a:r>
-              <a:rPr lang="bg-BG"/>
-              <a:t>Избраната система за контрол на версиите </a:t>
-            </a:r>
-            <a:r>
-              <a:rPr lang="en-US"/>
-              <a:t/>
-            </a:r>
-            <a:br>
-              <a:rPr lang="en-US"/>
-            </a:br>
-            <a:endParaRPr lang="en-US"/>
-          </a:p>
-        </p:txBody>
-      </p:sp>
-      <p:sp>
-        <p:nvSpPr>
-          <p:cNvPr id="3" name="Content Placeholder 2"/>
-          <p:cNvSpPr>
-            <a:spLocks noGrp="1"/>
-          </p:cNvSpPr>
-          <p:nvPr>
-            <p:ph idx="1"/>
-          </p:nvPr>
-        </p:nvSpPr>
-        <p:spPr>
-          <a:xfrm>
-            <a:off x="58189" y="1379913"/>
-            <a:ext cx="12133811" cy="2119745"/>
-          </a:xfrm>
-        </p:spPr>
-        <p:txBody>
-          <a:bodyPr/>
-          <a:lstStyle/>
-          <a:p>
-            <a:pPr marL="0" indent="0">
-              <a:buNone/>
-            </a:pPr>
-            <a:r>
-              <a:rPr lang="bg-BG"/>
-              <a:t>Избраната система е </a:t>
-            </a:r>
-            <a:r>
-              <a:rPr lang="en-US"/>
-              <a:t>Github . </a:t>
-            </a:r>
-            <a:r>
-              <a:rPr lang="bg-BG"/>
-              <a:t>Причината за изборът , е че </a:t>
-            </a:r>
-            <a:r>
-              <a:rPr lang="en-US"/>
-              <a:t>Github</a:t>
-            </a:r>
-            <a:r>
-              <a:rPr lang="bg-BG"/>
-              <a:t> е една от най-популярните системи за контрол на версиите и изключително лесна за използване и олеснява работата в екип. Също приложението </a:t>
-            </a:r>
-            <a:r>
-              <a:rPr lang="en-US"/>
-              <a:t>Github Desktop </a:t>
-            </a:r>
-            <a:r>
-              <a:rPr lang="bg-BG"/>
-              <a:t>позволява </a:t>
-            </a:r>
-            <a:r>
-              <a:rPr lang="en-US"/>
-              <a:t>push-</a:t>
-            </a:r>
-            <a:r>
-              <a:rPr lang="bg-BG"/>
-              <a:t>ването </a:t>
-            </a:r>
-            <a:r>
-              <a:rPr lang="en-US"/>
-              <a:t>и commit-</a:t>
-            </a:r>
-            <a:r>
-              <a:rPr lang="bg-BG"/>
-              <a:t>ването на промени по-лесно , понеже не се налага да се пишат команди в конзолата.</a:t>
-            </a:r>
-            <a:endParaRPr lang="en-US"/>
-          </a:p>
-          <a:p>
-            <a:pPr marL="0" indent="0">
-              <a:buNone/>
-            </a:pPr>
-            <a:endParaRPr lang="en-US"/>
-          </a:p>
-        </p:txBody>
-      </p:sp>
-      <p:pic>
-        <p:nvPicPr>
-          <p:cNvPr id="2050" name="Picture 2" descr="Logo - Brand Toolkit"/>
-          <p:cNvPicPr>
-            <a:picLocks noChangeAspect="1" noChangeArrowheads="1"/>
-          </p:cNvPicPr>
-          <p:nvPr/>
-        </p:nvPicPr>
-        <p:blipFill>
-          <a:blip r:embed="rId2" cstate="print">
-            <a:extLst>
-              <a:ext uri="{28A0092B-C50C-407E-A947-70E740481C1C}">
-                <a14:useLocalDpi xmlns:a14="http://schemas.microsoft.com/office/drawing/2010/main" val="0"/>
-              </a:ext>
-            </a:extLst>
-          </a:blip>
-          <a:srcRect/>
-          <a:stretch>
-            <a:fillRect/>
-          </a:stretch>
-        </p:blipFill>
-        <p:spPr bwMode="auto">
-          <a:xfrm>
-            <a:off x="297028" y="4080230"/>
-            <a:ext cx="5546970" cy="2059313"/>
-          </a:xfrm>
-          <a:prstGeom prst="rect">
-            <a:avLst/>
-          </a:prstGeom>
-          <a:noFill/>
-          <a:extLst>
-            <a:ext uri="{909E8E84-426E-40DD-AFC4-6F175D3DCCD1}">
-              <a14:hiddenFill xmlns:a14="http://schemas.microsoft.com/office/drawing/2010/main">
-                <a:solidFill>
-                  <a:srgbClr val="FFFFFF"/>
-                </a:solidFill>
-              </a14:hiddenFill>
-            </a:ext>
-          </a:extLst>
-        </p:spPr>
-      </p:pic>
-      <p:pic>
-        <p:nvPicPr>
-          <p:cNvPr id="2052" name="Picture 4" descr="Getting Started with G... | Wiki | UAL Creative Computing Institute"/>
-          <p:cNvPicPr>
-            <a:picLocks noChangeAspect="1" noChangeArrowheads="1"/>
-          </p:cNvPicPr>
-          <p:nvPr/>
-        </p:nvPicPr>
-        <p:blipFill>
-          <a:blip r:embed="rId3">
-            <a:extLst>
-              <a:ext uri="{28A0092B-C50C-407E-A947-70E740481C1C}">
-                <a14:useLocalDpi xmlns:a14="http://schemas.microsoft.com/office/drawing/2010/main" val="0"/>
-              </a:ext>
-            </a:extLst>
-          </a:blip>
-          <a:srcRect/>
-          <a:stretch>
-            <a:fillRect/>
-          </a:stretch>
-        </p:blipFill>
-        <p:spPr bwMode="auto">
-          <a:xfrm>
-            <a:off x="5961289" y="4157386"/>
-            <a:ext cx="5715000" cy="1905000"/>
-          </a:xfrm>
-          <a:prstGeom prst="rect">
-            <a:avLst/>
-          </a:prstGeom>
-          <a:noFill/>
-          <a:extLst>
-            <a:ext uri="{909E8E84-426E-40DD-AFC4-6F175D3DCCD1}">
-              <a14:hiddenFill xmlns:a14="http://schemas.microsoft.com/office/drawing/2010/main">
-                <a:solidFill>
-                  <a:srgbClr val="FFFFFF"/>
-                </a:solidFill>
-              </a14:hiddenFill>
-            </a:ext>
-          </a:extLst>
-        </p:spPr>
-      </p:pic>
-    </p:spTree>
-    <p:extLst>
-      <p:ext uri="{BB962C8B-B14F-4D97-AF65-F5344CB8AC3E}">
-        <p14:creationId xmlns:p14="http://schemas.microsoft.com/office/powerpoint/2010/main" val="1432200802"/>
-      </p:ext>
-    </p:extLst>
-  </p:cSld>
-  <p:clrMapOvr>
-    <a:masterClrMapping/>
-  </p:clrMapOvr>
-</p:sld>
-</file>
-
-<file path=ppt/slides/slide4.xml><?xml version="1.0" encoding="utf-8"?>
-<p:sld xmlns:a="http://schemas.openxmlformats.org/drawingml/2006/main" xmlns:r="http://schemas.openxmlformats.org/officeDocument/2006/relationships" xmlns:p="http://schemas.openxmlformats.org/presentationml/2006/main">
-  <p:cSld>
-    <p:spTree>
-      <p:nvGrpSpPr>
-        <p:cNvPr id="1" name=""/>
-        <p:cNvGrpSpPr/>
-        <p:nvPr/>
-      </p:nvGrpSpPr>
-      <p:grpSpPr>
-        <a:xfrm>
-          <a:off x="0" y="0"/>
-          <a:ext cx="0" cy="0"/>
-          <a:chOff x="0" y="0"/>
-          <a:chExt cx="0" cy="0"/>
-        </a:xfrm>
-      </p:grpSpPr>
-      <p:sp>
-        <p:nvSpPr>
-          <p:cNvPr id="2" name="Title 1"/>
-          <p:cNvSpPr>
-            <a:spLocks noGrp="1"/>
-          </p:cNvSpPr>
-          <p:nvPr>
-            <p:ph type="title"/>
-          </p:nvPr>
-        </p:nvSpPr>
-        <p:spPr/>
-        <p:txBody>
-          <a:bodyPr>
-            <a:normAutofit fontScale="90000"/>
-          </a:bodyPr>
-          <a:lstStyle/>
-          <a:p>
-            <a:r>
-              <a:rPr lang="en-US"/>
-              <a:t>3. </a:t>
-            </a:r>
-            <a:r>
-              <a:rPr lang="bg-BG"/>
-              <a:t>Избраната система за управление на проекта</a:t>
-            </a:r>
-            <a:r>
-              <a:rPr lang="en-US"/>
-              <a:t/>
-            </a:r>
-            <a:br>
-              <a:rPr lang="en-US"/>
-            </a:br>
-            <a:endParaRPr lang="en-US"/>
-          </a:p>
-        </p:txBody>
-      </p:sp>
-      <p:pic>
-        <p:nvPicPr>
-          <p:cNvPr id="3074" name="Picture 2" descr="File:Jira Logo.svg - Wikimedia Commons"/>
-          <p:cNvPicPr>
-            <a:picLocks noGrp="1" noChangeAspect="1" noChangeArrowheads="1"/>
-          </p:cNvPicPr>
-          <p:nvPr>
-            <p:ph idx="1"/>
-          </p:nvPr>
-        </p:nvPicPr>
-        <p:blipFill>
-          <a:blip r:embed="rId2" cstate="print">
-            <a:extLst>
-              <a:ext uri="{28A0092B-C50C-407E-A947-70E740481C1C}">
-                <a14:useLocalDpi xmlns:a14="http://schemas.microsoft.com/office/drawing/2010/main" val="0"/>
-              </a:ext>
-            </a:extLst>
-          </a:blip>
-          <a:srcRect/>
-          <a:stretch>
-            <a:fillRect/>
-          </a:stretch>
-        </p:blipFill>
-        <p:spPr bwMode="auto">
-          <a:xfrm>
-            <a:off x="1176034" y="1690688"/>
-            <a:ext cx="2394480" cy="1008301"/>
-          </a:xfrm>
-          <a:prstGeom prst="rect">
-            <a:avLst/>
-          </a:prstGeom>
-          <a:noFill/>
-          <a:extLst>
-            <a:ext uri="{909E8E84-426E-40DD-AFC4-6F175D3DCCD1}">
-              <a14:hiddenFill xmlns:a14="http://schemas.microsoft.com/office/drawing/2010/main">
-                <a:solidFill>
-                  <a:srgbClr val="FFFFFF"/>
-                </a:solidFill>
-              </a14:hiddenFill>
-            </a:ext>
-          </a:extLst>
-        </p:spPr>
-      </p:pic>
-    </p:spTree>
-    <p:extLst>
-      <p:ext uri="{BB962C8B-B14F-4D97-AF65-F5344CB8AC3E}">
-        <p14:creationId xmlns:p14="http://schemas.microsoft.com/office/powerpoint/2010/main" val="1157703078"/>
-      </p:ext>
-    </p:extLst>
-  </p:cSld>
-  <p:clrMapOvr>
-    <a:masterClrMapping/>
-  </p:clrMapOvr>
-</p:sld>
-</file>
-
-<file path=ppt/slides/slide5.xml><?xml version="1.0" encoding="utf-8"?>
-<p:sld xmlns:a="http://schemas.openxmlformats.org/drawingml/2006/main" xmlns:r="http://schemas.openxmlformats.org/officeDocument/2006/relationships" xmlns:p="http://schemas.openxmlformats.org/presentationml/2006/main">
-  <p:cSld>
-    <p:spTree>
-      <p:nvGrpSpPr>
-        <p:cNvPr id="1" name=""/>
-        <p:cNvGrpSpPr/>
-        <p:nvPr/>
-      </p:nvGrpSpPr>
-      <p:grpSpPr>
-        <a:xfrm>
-          <a:off x="0" y="0"/>
-          <a:ext cx="0" cy="0"/>
-          <a:chOff x="0" y="0"/>
-          <a:chExt cx="0" cy="0"/>
-        </a:xfrm>
-      </p:grpSpPr>
-      <p:sp>
-        <p:nvSpPr>
-          <p:cNvPr id="2" name="Title 1"/>
-          <p:cNvSpPr>
-            <a:spLocks noGrp="1"/>
-          </p:cNvSpPr>
-          <p:nvPr>
-            <p:ph type="title"/>
-          </p:nvPr>
-        </p:nvSpPr>
-        <p:spPr/>
-        <p:txBody>
-          <a:bodyPr/>
-          <a:lstStyle/>
-          <a:p>
-            <a:r>
-              <a:rPr lang="en-US"/>
-              <a:t>4.Web </a:t>
-            </a:r>
-            <a:r>
-              <a:rPr lang="bg-BG"/>
-              <a:t>Приложение</a:t>
-            </a:r>
-            <a:r>
-              <a:rPr lang="en-US"/>
-              <a:t/>
-            </a:r>
-            <a:br>
-              <a:rPr lang="en-US"/>
-            </a:br>
-            <a:endParaRPr lang="en-US"/>
-          </a:p>
-        </p:txBody>
-      </p:sp>
-      <p:sp>
-        <p:nvSpPr>
-          <p:cNvPr id="3" name="Content Placeholder 2"/>
-          <p:cNvSpPr>
-            <a:spLocks noGrp="1"/>
-          </p:cNvSpPr>
-          <p:nvPr>
-            <p:ph idx="1"/>
-          </p:nvPr>
-        </p:nvSpPr>
-        <p:spPr>
-          <a:xfrm>
-            <a:off x="838200" y="1520825"/>
-            <a:ext cx="10515600" cy="1425575"/>
-          </a:xfrm>
-        </p:spPr>
-        <p:txBody>
-          <a:bodyPr/>
-          <a:lstStyle/>
-          <a:p>
-            <a:pPr marL="0" indent="0">
-              <a:buNone/>
-            </a:pPr>
-            <a:r>
-              <a:rPr lang="bg-BG"/>
-              <a:t>Проектът е под формата на </a:t>
-            </a:r>
-            <a:r>
-              <a:rPr lang="en-US"/>
-              <a:t>Web </a:t>
-            </a:r>
-            <a:r>
-              <a:rPr lang="bg-BG"/>
-              <a:t>приложение . Това е поради използваната технология </a:t>
-            </a:r>
-            <a:r>
-              <a:rPr lang="en-US"/>
-              <a:t>.NET Web App </a:t>
-            </a:r>
-            <a:r>
-              <a:rPr lang="bg-BG"/>
-              <a:t>със структура </a:t>
-            </a:r>
-            <a:r>
-              <a:rPr lang="en-US"/>
-              <a:t>MVC (Model View Controller).</a:t>
-            </a:r>
-          </a:p>
-          <a:p>
-            <a:endParaRPr lang="en-US"/>
-          </a:p>
-        </p:txBody>
-      </p:sp>
-      <p:pic>
-        <p:nvPicPr>
-          <p:cNvPr id="4" name="Picture 3"/>
-          <p:cNvPicPr>
-            <a:picLocks noChangeAspect="1"/>
-          </p:cNvPicPr>
-          <p:nvPr/>
-        </p:nvPicPr>
-        <p:blipFill>
-          <a:blip r:embed="rId2"/>
-          <a:stretch>
-            <a:fillRect/>
-          </a:stretch>
-        </p:blipFill>
-        <p:spPr>
-          <a:xfrm>
-            <a:off x="1568070" y="2846388"/>
-            <a:ext cx="8573457" cy="3915001"/>
-          </a:xfrm>
-          <a:prstGeom prst="rect">
-            <a:avLst/>
-          </a:prstGeom>
-        </p:spPr>
-      </p:pic>
-    </p:spTree>
-    <p:extLst>
-      <p:ext uri="{BB962C8B-B14F-4D97-AF65-F5344CB8AC3E}">
-        <p14:creationId xmlns:p14="http://schemas.microsoft.com/office/powerpoint/2010/main" val="1685781362"/>
-      </p:ext>
-    </p:extLst>
-  </p:cSld>
-  <p:clrMapOvr>
-    <a:masterClrMapping/>
-  </p:clrMapOvr>
-</p:sld>
-</file>
-
-<file path=ppt/slides/slide6.xml><?xml version="1.0" encoding="utf-8"?>
-<p:sld xmlns:a="http://schemas.openxmlformats.org/drawingml/2006/main" xmlns:r="http://schemas.openxmlformats.org/officeDocument/2006/relationships" xmlns:p="http://schemas.openxmlformats.org/presentationml/2006/main">
-  <p:cSld>
-    <p:spTree>
-      <p:nvGrpSpPr>
-        <p:cNvPr id="1" name=""/>
-        <p:cNvGrpSpPr/>
-        <p:nvPr/>
-      </p:nvGrpSpPr>
-      <p:grpSpPr>
-        <a:xfrm>
-          <a:off x="0" y="0"/>
-          <a:ext cx="0" cy="0"/>
-          <a:chOff x="0" y="0"/>
-          <a:chExt cx="0" cy="0"/>
-        </a:xfrm>
-      </p:grpSpPr>
-      <p:sp>
-        <p:nvSpPr>
-          <p:cNvPr id="2" name="Title 1"/>
-          <p:cNvSpPr>
-            <a:spLocks noGrp="1"/>
-          </p:cNvSpPr>
-          <p:nvPr>
-            <p:ph type="title"/>
-          </p:nvPr>
-        </p:nvSpPr>
-        <p:spPr/>
-        <p:txBody>
-          <a:bodyPr/>
-          <a:lstStyle/>
-          <a:p>
-            <a:r>
-              <a:rPr lang="bg-BG"/>
-              <a:t>5.Използвани функционалности</a:t>
-            </a:r>
-            <a:r>
-              <a:rPr lang="en-US"/>
-              <a:t/>
-            </a:r>
-            <a:br>
-              <a:rPr lang="en-US"/>
-            </a:br>
-            <a:endParaRPr lang="en-US"/>
-          </a:p>
-        </p:txBody>
-      </p:sp>
-      <p:sp>
-        <p:nvSpPr>
-          <p:cNvPr id="3" name="Content Placeholder 2"/>
-          <p:cNvSpPr>
-            <a:spLocks noGrp="1"/>
-          </p:cNvSpPr>
-          <p:nvPr>
-            <p:ph idx="1"/>
-          </p:nvPr>
-        </p:nvSpPr>
-        <p:spPr>
-          <a:xfrm>
-            <a:off x="58189" y="1168920"/>
-            <a:ext cx="12133811" cy="2380615"/>
-          </a:xfrm>
-        </p:spPr>
-        <p:txBody>
-          <a:bodyPr>
-            <a:normAutofit lnSpcReduction="10000"/>
-          </a:bodyPr>
-          <a:lstStyle/>
-          <a:p>
-            <a:pPr marL="0" indent="0">
-              <a:buNone/>
-            </a:pPr>
-            <a:r>
-              <a:rPr lang="bg-BG"/>
-              <a:t>Приложението дава възможност на потребителите да добавят , променят и изтриват песни . След като една песен е добавена , тя може да се види в </a:t>
-            </a:r>
-            <a:r>
-              <a:rPr lang="en-US"/>
-              <a:t>Home Page-</a:t>
-            </a:r>
-            <a:r>
-              <a:rPr lang="bg-BG"/>
-              <a:t>а на приложението , от където също може да се ходи директно в </a:t>
-            </a:r>
-            <a:r>
-              <a:rPr lang="en-US"/>
-              <a:t>Wikipedia  </a:t>
-            </a:r>
-            <a:r>
-              <a:rPr lang="bg-BG"/>
-              <a:t>и </a:t>
-            </a:r>
-            <a:r>
-              <a:rPr lang="en-US"/>
-              <a:t>Youtube </a:t>
-            </a:r>
-            <a:r>
-              <a:rPr lang="bg-BG"/>
-              <a:t>страниците на песента ( ако са добавени адресите към данните на песента). Песни могат да се търсят по техните създатели , име , жанр и година.</a:t>
-            </a:r>
-            <a:endParaRPr lang="en-US"/>
-          </a:p>
-          <a:p>
-            <a:endParaRPr lang="en-US"/>
-          </a:p>
-        </p:txBody>
-      </p:sp>
-      <p:pic>
-        <p:nvPicPr>
-          <p:cNvPr id="4" name="Picture 3"/>
-          <p:cNvPicPr>
-            <a:picLocks noChangeAspect="1"/>
-          </p:cNvPicPr>
-          <p:nvPr/>
-        </p:nvPicPr>
-        <p:blipFill>
-          <a:blip r:embed="rId2"/>
-          <a:stretch>
-            <a:fillRect/>
-          </a:stretch>
-        </p:blipFill>
-        <p:spPr>
-          <a:xfrm>
-            <a:off x="174568" y="3356091"/>
-            <a:ext cx="6916188" cy="3105150"/>
-          </a:xfrm>
-          <a:prstGeom prst="rect">
-            <a:avLst/>
-          </a:prstGeom>
-        </p:spPr>
-      </p:pic>
-      <p:pic>
-        <p:nvPicPr>
-          <p:cNvPr id="5" name="Picture 4"/>
-          <p:cNvPicPr>
-            <a:picLocks noChangeAspect="1"/>
-          </p:cNvPicPr>
-          <p:nvPr/>
-        </p:nvPicPr>
-        <p:blipFill>
-          <a:blip r:embed="rId3"/>
-          <a:stretch>
-            <a:fillRect/>
-          </a:stretch>
-        </p:blipFill>
-        <p:spPr>
-          <a:xfrm>
-            <a:off x="9102436" y="2913348"/>
-            <a:ext cx="2933354" cy="2092039"/>
-          </a:xfrm>
-          <a:prstGeom prst="rect">
-            <a:avLst/>
-          </a:prstGeom>
-        </p:spPr>
-      </p:pic>
-      <p:pic>
-        <p:nvPicPr>
-          <p:cNvPr id="6" name="Picture 5"/>
-          <p:cNvPicPr>
-            <a:picLocks noChangeAspect="1"/>
-          </p:cNvPicPr>
-          <p:nvPr/>
-        </p:nvPicPr>
-        <p:blipFill>
-          <a:blip r:embed="rId4"/>
-          <a:stretch>
-            <a:fillRect/>
-          </a:stretch>
-        </p:blipFill>
-        <p:spPr>
-          <a:xfrm>
-            <a:off x="8019963" y="5293963"/>
-            <a:ext cx="4087004" cy="1360952"/>
-          </a:xfrm>
-          <a:prstGeom prst="rect">
-            <a:avLst/>
-          </a:prstGeom>
-        </p:spPr>
-      </p:pic>
-    </p:spTree>
-    <p:extLst>
-      <p:ext uri="{BB962C8B-B14F-4D97-AF65-F5344CB8AC3E}">
-        <p14:creationId xmlns:p14="http://schemas.microsoft.com/office/powerpoint/2010/main" val="3479705222"/>
-      </p:ext>
-    </p:extLst>
-  </p:cSld>
-  <p:clrMapOvr>
-    <a:masterClrMapping/>
-  </p:clrMapOvr>
-</p:sld>
-</file>
-
-<file path=ppt/slides/slide7.xml><?xml version="1.0" encoding="utf-8"?>
-<p:sld xmlns:a="http://schemas.openxmlformats.org/drawingml/2006/main" xmlns:r="http://schemas.openxmlformats.org/officeDocument/2006/relationships" xmlns:p="http://schemas.openxmlformats.org/presentationml/2006/main">
-  <p:cSld>
-    <p:spTree>
-      <p:nvGrpSpPr>
-        <p:cNvPr id="1" name=""/>
-        <p:cNvGrpSpPr/>
-        <p:nvPr/>
-      </p:nvGrpSpPr>
-      <p:grpSpPr>
-        <a:xfrm>
-          <a:off x="0" y="0"/>
-          <a:ext cx="0" cy="0"/>
-          <a:chOff x="0" y="0"/>
-          <a:chExt cx="0" cy="0"/>
-        </a:xfrm>
-      </p:grpSpPr>
-      <p:sp>
-        <p:nvSpPr>
-          <p:cNvPr id="2" name="Title 1"/>
-          <p:cNvSpPr>
-            <a:spLocks noGrp="1"/>
-          </p:cNvSpPr>
-          <p:nvPr>
-            <p:ph type="title"/>
-          </p:nvPr>
-        </p:nvSpPr>
-        <p:spPr/>
-        <p:txBody>
-          <a:bodyPr>
-            <a:normAutofit fontScale="90000"/>
-          </a:bodyPr>
-          <a:lstStyle/>
-          <a:p>
-            <a:r>
-              <a:rPr lang="bg-BG"/>
-              <a:t>6. </a:t>
-            </a:r>
-            <a:r>
-              <a:rPr lang="ru-RU"/>
-              <a:t>Обосновка и разяснения към избраната методология за разработка на софтуера</a:t>
-            </a:r>
-            <a:r>
-              <a:rPr lang="en-US"/>
-              <a:t/>
-            </a:r>
-            <a:br>
-              <a:rPr lang="en-US"/>
-            </a:br>
-            <a:endParaRPr lang="en-US"/>
-          </a:p>
-        </p:txBody>
-      </p:sp>
-      <p:sp>
-        <p:nvSpPr>
-          <p:cNvPr id="3" name="Content Placeholder 2"/>
-          <p:cNvSpPr>
-            <a:spLocks noGrp="1"/>
-          </p:cNvSpPr>
-          <p:nvPr>
-            <p:ph idx="1"/>
-          </p:nvPr>
-        </p:nvSpPr>
-        <p:spPr/>
-        <p:txBody>
-          <a:bodyPr/>
-          <a:lstStyle/>
-          <a:p>
-            <a:pPr marL="0" indent="0">
-              <a:buNone/>
-            </a:pPr>
-            <a:r>
-              <a:rPr lang="bg-BG"/>
-              <a:t>Използваната методология е </a:t>
-            </a:r>
-            <a:r>
-              <a:rPr lang="en-US"/>
-              <a:t>Kanban . </a:t>
-            </a:r>
-          </a:p>
-          <a:p>
-            <a:endParaRPr lang="en-US"/>
-          </a:p>
-        </p:txBody>
-      </p:sp>
-    </p:spTree>
-    <p:extLst>
-      <p:ext uri="{BB962C8B-B14F-4D97-AF65-F5344CB8AC3E}">
-        <p14:creationId xmlns:p14="http://schemas.microsoft.com/office/powerpoint/2010/main" val="3916397861"/>
-      </p:ext>
-    </p:extLst>
-  </p:cSld>
-  <p:clrMapOvr>
-    <a:masterClrMapping/>
-  </p:clrMapOvr>
-</p:sld>
-</file>
-
-<file path=ppt/slides/slide8.xml><?xml version="1.0" encoding="utf-8"?>
-<p:sld xmlns:a="http://schemas.openxmlformats.org/drawingml/2006/main" xmlns:r="http://schemas.openxmlformats.org/officeDocument/2006/relationships" xmlns:p="http://schemas.openxmlformats.org/presentationml/2006/main">
-  <p:cSld>
-    <p:spTree>
-      <p:nvGrpSpPr>
-        <p:cNvPr id="1" name=""/>
-        <p:cNvGrpSpPr/>
-        <p:nvPr/>
-      </p:nvGrpSpPr>
-      <p:grpSpPr>
-        <a:xfrm>
-          <a:off x="0" y="0"/>
-          <a:ext cx="0" cy="0"/>
-          <a:chOff x="0" y="0"/>
-          <a:chExt cx="0" cy="0"/>
-        </a:xfrm>
-      </p:grpSpPr>
-      <p:sp>
-        <p:nvSpPr>
-          <p:cNvPr id="2" name="Title 1"/>
-          <p:cNvSpPr>
-            <a:spLocks noGrp="1"/>
-          </p:cNvSpPr>
-          <p:nvPr>
-            <p:ph type="title"/>
-          </p:nvPr>
-        </p:nvSpPr>
-        <p:spPr/>
-        <p:txBody>
-          <a:bodyPr>
-            <a:normAutofit fontScale="90000"/>
-          </a:bodyPr>
-          <a:lstStyle/>
-          <a:p>
-            <a:r>
-              <a:rPr lang="en-US"/>
-              <a:t>7.</a:t>
-            </a:r>
-            <a:r>
-              <a:rPr lang="bg-BG"/>
-              <a:t>И</a:t>
-            </a:r>
-            <a:r>
-              <a:rPr lang="ru-RU"/>
-              <a:t>збор на програмни средства за реализацията </a:t>
-            </a:r>
-            <a:r>
-              <a:rPr lang="en-US"/>
-              <a:t/>
-            </a:r>
-            <a:br>
-              <a:rPr lang="en-US"/>
-            </a:br>
-            <a:endParaRPr lang="en-US"/>
+            <a:endParaRPr lang="bg-BG" noProof="0" dirty="0"/>
           </a:p>
         </p:txBody>
       </p:sp>
@@ -4206,106 +3102,97 @@
               <a:buNone/>
             </a:pPr>
             <a:r>
-              <a:rPr lang="ru-RU"/>
-              <a:t>Избраният програмен език за проекта е </a:t>
-            </a:r>
-            <a:r>
-              <a:rPr lang="en-US"/>
-              <a:t>C# , </a:t>
-            </a:r>
-            <a:r>
-              <a:rPr lang="bg-BG"/>
-              <a:t>а избраната среда за разработка е </a:t>
-            </a:r>
-            <a:r>
-              <a:rPr lang="en-US"/>
-              <a:t>Microsoft Visual Studio . </a:t>
-            </a:r>
-            <a:r>
-              <a:rPr lang="bg-BG"/>
-              <a:t>Причинините за избора са , че </a:t>
-            </a:r>
-            <a:r>
-              <a:rPr lang="en-US"/>
-              <a:t>Microsoft Visual Studio </a:t>
-            </a:r>
-            <a:r>
-              <a:rPr lang="bg-BG"/>
-              <a:t>е направено специално за използването на </a:t>
-            </a:r>
-            <a:r>
-              <a:rPr lang="en-US"/>
-              <a:t>C# , </a:t>
-            </a:r>
-            <a:r>
-              <a:rPr lang="bg-BG"/>
-              <a:t>а </a:t>
-            </a:r>
-            <a:r>
-              <a:rPr lang="en-US"/>
-              <a:t>C# </a:t>
-            </a:r>
-            <a:r>
-              <a:rPr lang="bg-BG"/>
-              <a:t>позволява достъпа до </a:t>
-            </a:r>
-            <a:r>
-              <a:rPr lang="en-US"/>
-              <a:t>.NET </a:t>
-            </a:r>
-            <a:r>
-              <a:rPr lang="bg-BG"/>
-              <a:t>библиотеките за създаване на </a:t>
-            </a:r>
-            <a:r>
-              <a:rPr lang="en-US"/>
-              <a:t>Web </a:t>
-            </a:r>
-            <a:r>
-              <a:rPr lang="bg-BG"/>
-              <a:t>апликации . Използваната среда за съхранение на базата данни е </a:t>
-            </a:r>
-            <a:r>
-              <a:rPr lang="en-US"/>
-              <a:t>Microsoft Server Management Studio , </a:t>
-            </a:r>
-            <a:r>
-              <a:rPr lang="bg-BG"/>
-              <a:t>поради това че функционира добре с </a:t>
-            </a:r>
-            <a:r>
-              <a:rPr lang="en-US"/>
-              <a:t>.NET </a:t>
-            </a:r>
-            <a:r>
-              <a:rPr lang="bg-BG"/>
-              <a:t>приложения (защото също е направена от </a:t>
-            </a:r>
-            <a:r>
-              <a:rPr lang="en-US"/>
-              <a:t>Microsoft).</a:t>
-            </a:r>
-            <a:r>
-              <a:rPr lang="bg-BG"/>
-              <a:t> Използвани са също и езиците </a:t>
-            </a:r>
-            <a:r>
-              <a:rPr lang="en-US"/>
-              <a:t>JavaScript/Html/CSS , </a:t>
-            </a:r>
-            <a:r>
-              <a:rPr lang="bg-BG"/>
-              <a:t>защото те са стандартните програмни езици за работа с </a:t>
-            </a:r>
-            <a:r>
-              <a:rPr lang="en-US"/>
-              <a:t>Web </a:t>
-            </a:r>
-            <a:r>
-              <a:rPr lang="bg-BG"/>
-              <a:t>приложения и сайтове.</a:t>
-            </a:r>
-            <a:endParaRPr lang="en-US"/>
+              <a:rPr lang="bg-BG" noProof="0" dirty="0"/>
+              <a:t>Избраният програмен език за проекта е C# , а избраната среда за разработка е Microsoft </a:t>
+            </a:r>
+            <a:r>
+              <a:rPr lang="bg-BG" noProof="0" dirty="0" err="1"/>
+              <a:t>Visual</a:t>
+            </a:r>
+            <a:r>
+              <a:rPr lang="bg-BG" noProof="0" dirty="0"/>
+              <a:t> </a:t>
+            </a:r>
+            <a:r>
+              <a:rPr lang="bg-BG" noProof="0" dirty="0" err="1"/>
+              <a:t>Studio</a:t>
+            </a:r>
+            <a:r>
+              <a:rPr lang="bg-BG" noProof="0" dirty="0"/>
+              <a:t> . </a:t>
+            </a:r>
+            <a:r>
+              <a:rPr lang="bg-BG" noProof="0" dirty="0" err="1"/>
+              <a:t>Причинините</a:t>
+            </a:r>
+            <a:r>
+              <a:rPr lang="bg-BG" noProof="0" dirty="0"/>
+              <a:t> за избора са , че Microsoft </a:t>
+            </a:r>
+            <a:r>
+              <a:rPr lang="bg-BG" noProof="0" dirty="0" err="1"/>
+              <a:t>Visual</a:t>
+            </a:r>
+            <a:r>
+              <a:rPr lang="bg-BG" noProof="0" dirty="0"/>
+              <a:t> </a:t>
+            </a:r>
+            <a:r>
+              <a:rPr lang="bg-BG" noProof="0" dirty="0" err="1"/>
+              <a:t>Studio</a:t>
+            </a:r>
+            <a:r>
+              <a:rPr lang="bg-BG" noProof="0" dirty="0"/>
+              <a:t> е направено специално за използването на C# , а C# позволява достъпа до .NET библиотеките за създаване на </a:t>
+            </a:r>
+            <a:r>
+              <a:rPr lang="bg-BG" noProof="0" dirty="0" err="1"/>
+              <a:t>Web</a:t>
+            </a:r>
+            <a:r>
+              <a:rPr lang="bg-BG" noProof="0" dirty="0"/>
+              <a:t> апликации . Използваната среда за съхранение на базата данни е Microsoft Server </a:t>
+            </a:r>
+            <a:r>
+              <a:rPr lang="bg-BG" noProof="0" dirty="0" err="1"/>
+              <a:t>Management</a:t>
+            </a:r>
+            <a:r>
+              <a:rPr lang="bg-BG" noProof="0" dirty="0"/>
+              <a:t> </a:t>
+            </a:r>
+            <a:r>
+              <a:rPr lang="bg-BG" noProof="0" dirty="0" err="1"/>
+              <a:t>Studio</a:t>
+            </a:r>
+            <a:r>
+              <a:rPr lang="bg-BG" noProof="0" dirty="0"/>
+              <a:t> , поради това че функционира добре с .NET приложения (защото също е направена от Microsoft). Използвани са също и езиците </a:t>
+            </a:r>
+            <a:r>
+              <a:rPr lang="bg-BG" noProof="0" dirty="0" err="1"/>
+              <a:t>JavaScript</a:t>
+            </a:r>
+            <a:r>
+              <a:rPr lang="bg-BG" noProof="0" dirty="0"/>
+              <a:t>/</a:t>
+            </a:r>
+            <a:r>
+              <a:rPr lang="bg-BG" noProof="0" dirty="0" err="1"/>
+              <a:t>Html</a:t>
+            </a:r>
+            <a:r>
+              <a:rPr lang="bg-BG" noProof="0" dirty="0"/>
+              <a:t>/CSS , защото те са стандартните програмни езици за работа с </a:t>
+            </a:r>
+            <a:r>
+              <a:rPr lang="bg-BG" noProof="0" dirty="0" err="1"/>
+              <a:t>Web</a:t>
+            </a:r>
+            <a:r>
+              <a:rPr lang="bg-BG" noProof="0" dirty="0"/>
+              <a:t> приложения и сайтове.</a:t>
+            </a:r>
           </a:p>
         </p:txBody>
       </p:sp>
@@ -4568,6 +3455,1384 @@
 </p:sld>
 </file>
 
+<file path=ppt/slides/slide11.xml><?xml version="1.0" encoding="utf-8"?>
+<p:sld xmlns:a="http://schemas.openxmlformats.org/drawingml/2006/main" xmlns:r="http://schemas.openxmlformats.org/officeDocument/2006/relationships" xmlns:p="http://schemas.openxmlformats.org/presentationml/2006/main">
+  <p:cSld>
+    <p:spTree>
+      <p:nvGrpSpPr>
+        <p:cNvPr id="1" name=""/>
+        <p:cNvGrpSpPr/>
+        <p:nvPr/>
+      </p:nvGrpSpPr>
+      <p:grpSpPr>
+        <a:xfrm>
+          <a:off x="0" y="0"/>
+          <a:ext cx="0" cy="0"/>
+          <a:chOff x="0" y="0"/>
+          <a:chExt cx="0" cy="0"/>
+        </a:xfrm>
+      </p:grpSpPr>
+      <p:sp>
+        <p:nvSpPr>
+          <p:cNvPr id="2" name="Title 1"/>
+          <p:cNvSpPr>
+            <a:spLocks noGrp="1"/>
+          </p:cNvSpPr>
+          <p:nvPr>
+            <p:ph type="title"/>
+          </p:nvPr>
+        </p:nvSpPr>
+        <p:spPr/>
+        <p:txBody>
+          <a:bodyPr>
+            <a:normAutofit fontScale="90000"/>
+          </a:bodyPr>
+          <a:lstStyle/>
+          <a:p>
+            <a:pPr algn="ctr"/>
+            <a:r>
+              <a:rPr lang="bg-BG" noProof="0" dirty="0"/>
+              <a:t>Стъпки, зависещи от конкретния подход за разработка</a:t>
+            </a:r>
+            <a:br>
+              <a:rPr lang="bg-BG" noProof="0" dirty="0"/>
+            </a:br>
+            <a:endParaRPr lang="bg-BG" noProof="0" dirty="0"/>
+          </a:p>
+        </p:txBody>
+      </p:sp>
+      <p:sp>
+        <p:nvSpPr>
+          <p:cNvPr id="3" name="Content Placeholder 2"/>
+          <p:cNvSpPr>
+            <a:spLocks noGrp="1"/>
+          </p:cNvSpPr>
+          <p:nvPr>
+            <p:ph idx="1"/>
+          </p:nvPr>
+        </p:nvSpPr>
+        <p:spPr/>
+        <p:txBody>
+          <a:bodyPr>
+            <a:normAutofit fontScale="92500" lnSpcReduction="10000"/>
+          </a:bodyPr>
+          <a:lstStyle/>
+          <a:p>
+            <a:pPr marL="0" indent="0">
+              <a:buNone/>
+            </a:pPr>
+            <a:r>
+              <a:rPr lang="bg-BG" noProof="0" dirty="0"/>
+              <a:t>Използваната за създаване на проекта MVC структура , изисква някои спецификации , за да може да функционира приложението. Трябва да се </a:t>
+            </a:r>
+            <a:r>
+              <a:rPr lang="bg-BG" noProof="0" dirty="0" err="1"/>
+              <a:t>останови</a:t>
+            </a:r>
+            <a:r>
+              <a:rPr lang="bg-BG" noProof="0" dirty="0"/>
+              <a:t> връзка към базата данни  , за да може да се съхраняват и взимат данните за песни в приложението . Трябва да се направят модели , чрез които се създават обекти . Нужни са контролери , които да съдържат логиката за работа с обектите направени от моделите . </a:t>
+            </a:r>
+            <a:r>
+              <a:rPr lang="bg-BG" noProof="0" dirty="0" err="1"/>
+              <a:t>ViewModels</a:t>
+            </a:r>
+            <a:r>
+              <a:rPr lang="bg-BG" noProof="0" dirty="0"/>
+              <a:t> са класове, които се използват за да помагат с четенето и писането на данни в обектите, като различните </a:t>
+            </a:r>
+            <a:r>
+              <a:rPr lang="bg-BG" noProof="0" dirty="0" err="1"/>
+              <a:t>ViewModel</a:t>
+            </a:r>
+            <a:r>
+              <a:rPr lang="bg-BG" noProof="0" dirty="0"/>
+              <a:t>-и имат различен подбор от данни, които да използват за различни страници от </a:t>
+            </a:r>
+            <a:r>
+              <a:rPr lang="bg-BG" noProof="0" dirty="0" err="1"/>
+              <a:t>Web</a:t>
+            </a:r>
+            <a:r>
+              <a:rPr lang="bg-BG" noProof="0" dirty="0"/>
+              <a:t> приложението. </a:t>
+            </a:r>
+            <a:r>
+              <a:rPr lang="bg-BG" noProof="0" dirty="0" err="1"/>
+              <a:t>View</a:t>
+            </a:r>
+            <a:r>
+              <a:rPr lang="bg-BG" noProof="0" dirty="0"/>
+              <a:t>-тата са структурите на страниците в приложението. Те представляват  как ще изглежда и как ще е структурирана една страница. </a:t>
+            </a:r>
+          </a:p>
+          <a:p>
+            <a:endParaRPr lang="bg-BG" noProof="0" dirty="0"/>
+          </a:p>
+        </p:txBody>
+      </p:sp>
+    </p:spTree>
+    <p:extLst>
+      <p:ext uri="{BB962C8B-B14F-4D97-AF65-F5344CB8AC3E}">
+        <p14:creationId xmlns:p14="http://schemas.microsoft.com/office/powerpoint/2010/main" val="3329442785"/>
+      </p:ext>
+    </p:extLst>
+  </p:cSld>
+  <p:clrMapOvr>
+    <a:masterClrMapping/>
+  </p:clrMapOvr>
+</p:sld>
+</file>
+
+<file path=ppt/slides/slide12.xml><?xml version="1.0" encoding="utf-8"?>
+<p:sld xmlns:a="http://schemas.openxmlformats.org/drawingml/2006/main" xmlns:r="http://schemas.openxmlformats.org/officeDocument/2006/relationships" xmlns:p="http://schemas.openxmlformats.org/presentationml/2006/main">
+  <p:cSld>
+    <p:spTree>
+      <p:nvGrpSpPr>
+        <p:cNvPr id="1" name=""/>
+        <p:cNvGrpSpPr/>
+        <p:nvPr/>
+      </p:nvGrpSpPr>
+      <p:grpSpPr>
+        <a:xfrm>
+          <a:off x="0" y="0"/>
+          <a:ext cx="0" cy="0"/>
+          <a:chOff x="0" y="0"/>
+          <a:chExt cx="0" cy="0"/>
+        </a:xfrm>
+      </p:grpSpPr>
+      <p:sp>
+        <p:nvSpPr>
+          <p:cNvPr id="2" name="Title 1"/>
+          <p:cNvSpPr>
+            <a:spLocks noGrp="1"/>
+          </p:cNvSpPr>
+          <p:nvPr>
+            <p:ph type="title"/>
+          </p:nvPr>
+        </p:nvSpPr>
+        <p:spPr>
+          <a:xfrm>
+            <a:off x="838200" y="365125"/>
+            <a:ext cx="8570720" cy="1325563"/>
+          </a:xfrm>
+        </p:spPr>
+        <p:txBody>
+          <a:bodyPr/>
+          <a:lstStyle/>
+          <a:p>
+            <a:pPr algn="ctr"/>
+            <a:r>
+              <a:rPr lang="bg-BG" noProof="0" dirty="0"/>
+              <a:t>Използвани класове</a:t>
+            </a:r>
+            <a:br>
+              <a:rPr lang="bg-BG" noProof="0" dirty="0"/>
+            </a:br>
+            <a:endParaRPr lang="bg-BG" noProof="0" dirty="0"/>
+          </a:p>
+        </p:txBody>
+      </p:sp>
+      <p:sp>
+        <p:nvSpPr>
+          <p:cNvPr id="3" name="Content Placeholder 2"/>
+          <p:cNvSpPr>
+            <a:spLocks noGrp="1"/>
+          </p:cNvSpPr>
+          <p:nvPr>
+            <p:ph idx="1"/>
+          </p:nvPr>
+        </p:nvSpPr>
+        <p:spPr>
+          <a:xfrm>
+            <a:off x="0" y="1038224"/>
+            <a:ext cx="8801100" cy="5819775"/>
+          </a:xfrm>
+        </p:spPr>
+        <p:txBody>
+          <a:bodyPr>
+            <a:normAutofit fontScale="85000" lnSpcReduction="20000"/>
+          </a:bodyPr>
+          <a:lstStyle/>
+          <a:p>
+            <a:r>
+              <a:rPr lang="bg-BG" noProof="0" dirty="0" err="1"/>
+              <a:t>Program</a:t>
+            </a:r>
+            <a:r>
+              <a:rPr lang="bg-BG" noProof="0" dirty="0"/>
+              <a:t> – Класът, който съдържа логиката за подкарване на </a:t>
+            </a:r>
+            <a:r>
+              <a:rPr lang="bg-BG" noProof="0" dirty="0" err="1"/>
+              <a:t>web</a:t>
+            </a:r>
+            <a:r>
+              <a:rPr lang="bg-BG" noProof="0" dirty="0"/>
+              <a:t> апликацията.</a:t>
+            </a:r>
+          </a:p>
+          <a:p>
+            <a:r>
+              <a:rPr lang="bg-BG" noProof="0" dirty="0" err="1"/>
+              <a:t>ApplicationDbContext</a:t>
+            </a:r>
+            <a:r>
+              <a:rPr lang="bg-BG" noProof="0" dirty="0"/>
+              <a:t> – В този клас се съдържа информацията за песните, </a:t>
+            </a:r>
+            <a:r>
+              <a:rPr lang="bg-BG" noProof="0" dirty="0" err="1"/>
+              <a:t>коята</a:t>
+            </a:r>
+            <a:r>
+              <a:rPr lang="bg-BG" noProof="0" dirty="0"/>
+              <a:t> се </a:t>
+            </a:r>
+            <a:r>
+              <a:rPr lang="bg-BG" noProof="0" dirty="0" err="1"/>
+              <a:t>извилича</a:t>
+            </a:r>
+            <a:r>
+              <a:rPr lang="bg-BG" noProof="0" dirty="0"/>
+              <a:t> от базата данни, и от </a:t>
+            </a:r>
+            <a:r>
+              <a:rPr lang="bg-BG" noProof="0" dirty="0" err="1"/>
+              <a:t>коята</a:t>
+            </a:r>
+            <a:r>
+              <a:rPr lang="bg-BG" noProof="0" dirty="0"/>
+              <a:t> се пише в базата данни.</a:t>
+            </a:r>
+          </a:p>
+          <a:p>
+            <a:r>
+              <a:rPr lang="bg-BG" noProof="0" dirty="0" err="1"/>
+              <a:t>Song</a:t>
+            </a:r>
+            <a:r>
+              <a:rPr lang="bg-BG" noProof="0" dirty="0"/>
+              <a:t> – Това е класът модел, който служи за създаване на обектите за песни.</a:t>
+            </a:r>
+          </a:p>
+          <a:p>
+            <a:r>
+              <a:rPr lang="bg-BG" noProof="0" dirty="0" err="1"/>
+              <a:t>Genres</a:t>
+            </a:r>
+            <a:r>
+              <a:rPr lang="bg-BG" noProof="0" dirty="0"/>
+              <a:t> – Клас, който съдържа статичен лист с популярни жанрове на песни, с цел да помага в създаването на обекти.</a:t>
+            </a:r>
+          </a:p>
+          <a:p>
+            <a:r>
+              <a:rPr lang="bg-BG" noProof="0" dirty="0" err="1"/>
+              <a:t>HomeController</a:t>
+            </a:r>
+            <a:r>
+              <a:rPr lang="bg-BG" noProof="0" dirty="0"/>
+              <a:t> – Класът за контролера, който съдържа всички методи, които позволяват работата между базата данни и потребителският интерфейс.</a:t>
+            </a:r>
+          </a:p>
+          <a:p>
+            <a:r>
+              <a:rPr lang="bg-BG" noProof="0" dirty="0" err="1"/>
+              <a:t>AddSongViewModel</a:t>
+            </a:r>
+            <a:r>
+              <a:rPr lang="bg-BG" noProof="0" dirty="0"/>
+              <a:t>/</a:t>
+            </a:r>
+            <a:r>
+              <a:rPr lang="bg-BG" noProof="0" dirty="0" err="1"/>
+              <a:t>BasicSongViewModel</a:t>
+            </a:r>
+            <a:r>
+              <a:rPr lang="bg-BG" noProof="0" dirty="0"/>
+              <a:t>/</a:t>
+            </a:r>
+            <a:r>
+              <a:rPr lang="bg-BG" noProof="0" dirty="0" err="1"/>
+              <a:t>DeleteSongViewModel</a:t>
+            </a:r>
+            <a:r>
+              <a:rPr lang="bg-BG" noProof="0" dirty="0"/>
+              <a:t> – класове, които служат за помощ с </a:t>
+            </a:r>
+            <a:r>
+              <a:rPr lang="bg-BG" noProof="0" dirty="0" err="1"/>
+              <a:t>иползването</a:t>
+            </a:r>
+            <a:r>
+              <a:rPr lang="bg-BG" noProof="0" dirty="0"/>
+              <a:t> на данни от модела </a:t>
+            </a:r>
+            <a:r>
+              <a:rPr lang="bg-BG" noProof="0" dirty="0" err="1"/>
+              <a:t>Song</a:t>
+            </a:r>
+            <a:r>
+              <a:rPr lang="bg-BG" noProof="0" dirty="0"/>
+              <a:t> в страниците на апликацията.</a:t>
+            </a:r>
+          </a:p>
+          <a:p>
+            <a:r>
+              <a:rPr lang="bg-BG" noProof="0" dirty="0" err="1"/>
+              <a:t>Add</a:t>
+            </a:r>
+            <a:r>
+              <a:rPr lang="bg-BG" noProof="0" dirty="0"/>
+              <a:t>/</a:t>
+            </a:r>
+            <a:r>
+              <a:rPr lang="bg-BG" noProof="0" dirty="0" err="1"/>
+              <a:t>Edit</a:t>
+            </a:r>
+            <a:r>
+              <a:rPr lang="bg-BG" noProof="0" dirty="0"/>
+              <a:t>/</a:t>
+            </a:r>
+            <a:r>
+              <a:rPr lang="bg-BG" noProof="0" dirty="0" err="1"/>
+              <a:t>Delete</a:t>
+            </a:r>
+            <a:r>
+              <a:rPr lang="bg-BG" noProof="0" dirty="0"/>
+              <a:t>/</a:t>
+            </a:r>
+            <a:r>
+              <a:rPr lang="bg-BG" noProof="0" dirty="0" err="1"/>
+              <a:t>Index</a:t>
+            </a:r>
+            <a:r>
+              <a:rPr lang="bg-BG" noProof="0" dirty="0"/>
+              <a:t> – </a:t>
+            </a:r>
+            <a:r>
+              <a:rPr lang="bg-BG" noProof="0" dirty="0" err="1"/>
+              <a:t>View</a:t>
+            </a:r>
+            <a:r>
+              <a:rPr lang="bg-BG" noProof="0" dirty="0"/>
+              <a:t> </a:t>
+            </a:r>
+            <a:r>
+              <a:rPr lang="bg-BG" noProof="0" dirty="0" err="1"/>
+              <a:t>файлoвете</a:t>
+            </a:r>
+            <a:r>
+              <a:rPr lang="bg-BG" noProof="0" dirty="0"/>
+              <a:t>, които съдържат структурата на страниците за апликацията.</a:t>
+            </a:r>
+          </a:p>
+        </p:txBody>
+      </p:sp>
+      <p:pic>
+        <p:nvPicPr>
+          <p:cNvPr id="4" name="Picture 3"/>
+          <p:cNvPicPr>
+            <a:picLocks noChangeAspect="1"/>
+          </p:cNvPicPr>
+          <p:nvPr/>
+        </p:nvPicPr>
+        <p:blipFill>
+          <a:blip r:embed="rId2"/>
+          <a:stretch>
+            <a:fillRect/>
+          </a:stretch>
+        </p:blipFill>
+        <p:spPr>
+          <a:xfrm>
+            <a:off x="9534524" y="128587"/>
+            <a:ext cx="2533651" cy="6656390"/>
+          </a:xfrm>
+          <a:prstGeom prst="rect">
+            <a:avLst/>
+          </a:prstGeom>
+        </p:spPr>
+      </p:pic>
+    </p:spTree>
+    <p:extLst>
+      <p:ext uri="{BB962C8B-B14F-4D97-AF65-F5344CB8AC3E}">
+        <p14:creationId xmlns:p14="http://schemas.microsoft.com/office/powerpoint/2010/main" val="233053847"/>
+      </p:ext>
+    </p:extLst>
+  </p:cSld>
+  <p:clrMapOvr>
+    <a:masterClrMapping/>
+  </p:clrMapOvr>
+</p:sld>
+</file>
+
+<file path=ppt/slides/slide2.xml><?xml version="1.0" encoding="utf-8"?>
+<p:sld xmlns:a="http://schemas.openxmlformats.org/drawingml/2006/main" xmlns:r="http://schemas.openxmlformats.org/officeDocument/2006/relationships" xmlns:p="http://schemas.openxmlformats.org/presentationml/2006/main">
+  <p:cSld>
+    <p:spTree>
+      <p:nvGrpSpPr>
+        <p:cNvPr id="1" name=""/>
+        <p:cNvGrpSpPr/>
+        <p:nvPr/>
+      </p:nvGrpSpPr>
+      <p:grpSpPr>
+        <a:xfrm>
+          <a:off x="0" y="0"/>
+          <a:ext cx="0" cy="0"/>
+          <a:chOff x="0" y="0"/>
+          <a:chExt cx="0" cy="0"/>
+        </a:xfrm>
+      </p:grpSpPr>
+      <p:sp>
+        <p:nvSpPr>
+          <p:cNvPr id="2" name="Title 1"/>
+          <p:cNvSpPr>
+            <a:spLocks noGrp="1"/>
+          </p:cNvSpPr>
+          <p:nvPr>
+            <p:ph type="title"/>
+          </p:nvPr>
+        </p:nvSpPr>
+        <p:spPr/>
+        <p:txBody>
+          <a:bodyPr/>
+          <a:lstStyle/>
+          <a:p>
+            <a:pPr algn="ctr"/>
+            <a:r>
+              <a:rPr lang="bg-BG" noProof="0" dirty="0"/>
+              <a:t>Техническо Задание</a:t>
+            </a:r>
+            <a:br>
+              <a:rPr lang="bg-BG" noProof="0" dirty="0"/>
+            </a:br>
+            <a:endParaRPr lang="bg-BG" noProof="0" dirty="0"/>
+          </a:p>
+        </p:txBody>
+      </p:sp>
+      <p:pic>
+        <p:nvPicPr>
+          <p:cNvPr id="1026" name="Picture 2" descr="https://cdn.discordapp.com/attachments/1422853389347455053/1495497283985346701/image.png?ex=6a0ab721&amp;is=6a0965a1&amp;hm=9a2e02aad2993d7120b8b8182d290f112d47b42f7fc38aa751a05fbbaec48b6e&amp;"/>
+          <p:cNvPicPr>
+            <a:picLocks noGrp="1" noChangeAspect="1" noChangeArrowheads="1"/>
+          </p:cNvPicPr>
+          <p:nvPr>
+            <p:ph idx="1"/>
+          </p:nvPr>
+        </p:nvPicPr>
+        <p:blipFill>
+          <a:blip r:embed="rId2">
+            <a:extLst>
+              <a:ext uri="{28A0092B-C50C-407E-A947-70E740481C1C}">
+                <a14:useLocalDpi xmlns:a14="http://schemas.microsoft.com/office/drawing/2010/main" val="0"/>
+              </a:ext>
+            </a:extLst>
+          </a:blip>
+          <a:srcRect/>
+          <a:stretch>
+            <a:fillRect/>
+          </a:stretch>
+        </p:blipFill>
+        <p:spPr bwMode="auto">
+          <a:xfrm>
+            <a:off x="778766" y="1690689"/>
+            <a:ext cx="10327557" cy="1738311"/>
+          </a:xfrm>
+          <a:prstGeom prst="rect">
+            <a:avLst/>
+          </a:prstGeom>
+          <a:noFill/>
+          <a:extLst>
+            <a:ext uri="{909E8E84-426E-40DD-AFC4-6F175D3DCCD1}">
+              <a14:hiddenFill xmlns:a14="http://schemas.microsoft.com/office/drawing/2010/main">
+                <a:solidFill>
+                  <a:srgbClr val="FFFFFF"/>
+                </a:solidFill>
+              </a14:hiddenFill>
+            </a:ext>
+          </a:extLst>
+        </p:spPr>
+      </p:pic>
+    </p:spTree>
+    <p:extLst>
+      <p:ext uri="{BB962C8B-B14F-4D97-AF65-F5344CB8AC3E}">
+        <p14:creationId xmlns:p14="http://schemas.microsoft.com/office/powerpoint/2010/main" val="1768123233"/>
+      </p:ext>
+    </p:extLst>
+  </p:cSld>
+  <p:clrMapOvr>
+    <a:masterClrMapping/>
+  </p:clrMapOvr>
+</p:sld>
+</file>
+
+<file path=ppt/slides/slide3.xml><?xml version="1.0" encoding="utf-8"?>
+<p:sld xmlns:a="http://schemas.openxmlformats.org/drawingml/2006/main" xmlns:r="http://schemas.openxmlformats.org/officeDocument/2006/relationships" xmlns:p="http://schemas.openxmlformats.org/presentationml/2006/main">
+  <p:cSld>
+    <p:spTree>
+      <p:nvGrpSpPr>
+        <p:cNvPr id="1" name=""/>
+        <p:cNvGrpSpPr/>
+        <p:nvPr/>
+      </p:nvGrpSpPr>
+      <p:grpSpPr>
+        <a:xfrm>
+          <a:off x="0" y="0"/>
+          <a:ext cx="0" cy="0"/>
+          <a:chOff x="0" y="0"/>
+          <a:chExt cx="0" cy="0"/>
+        </a:xfrm>
+      </p:grpSpPr>
+      <p:sp>
+        <p:nvSpPr>
+          <p:cNvPr id="2" name="Заглавие 1">
+            <a:extLst>
+              <a:ext uri="{FF2B5EF4-FFF2-40B4-BE49-F238E27FC236}">
+                <a16:creationId xmlns:a16="http://schemas.microsoft.com/office/drawing/2014/main" id="{4535143F-BD9F-A2EE-8911-02B997326E37}"/>
+              </a:ext>
+            </a:extLst>
+          </p:cNvPr>
+          <p:cNvSpPr>
+            <a:spLocks noGrp="1"/>
+          </p:cNvSpPr>
+          <p:nvPr>
+            <p:ph type="title"/>
+          </p:nvPr>
+        </p:nvSpPr>
+        <p:spPr/>
+        <p:txBody>
+          <a:bodyPr/>
+          <a:lstStyle/>
+          <a:p>
+            <a:pPr algn="ctr"/>
+            <a:r>
+              <a:rPr lang="bg-BG" noProof="0" dirty="0"/>
+              <a:t>Цел на проекта</a:t>
+            </a:r>
+          </a:p>
+        </p:txBody>
+      </p:sp>
+      <p:sp>
+        <p:nvSpPr>
+          <p:cNvPr id="3" name="Контейнер за съдържание 2">
+            <a:extLst>
+              <a:ext uri="{FF2B5EF4-FFF2-40B4-BE49-F238E27FC236}">
+                <a16:creationId xmlns:a16="http://schemas.microsoft.com/office/drawing/2014/main" id="{C97A9712-540C-819E-2D95-42F40EF5EFA2}"/>
+              </a:ext>
+            </a:extLst>
+          </p:cNvPr>
+          <p:cNvSpPr>
+            <a:spLocks noGrp="1"/>
+          </p:cNvSpPr>
+          <p:nvPr>
+            <p:ph idx="1"/>
+          </p:nvPr>
+        </p:nvSpPr>
+        <p:spPr/>
+        <p:txBody>
+          <a:bodyPr/>
+          <a:lstStyle/>
+          <a:p>
+            <a:pPr fontAlgn="base"/>
+            <a:r>
+              <a:rPr lang="bg-BG" noProof="0" dirty="0"/>
+              <a:t>Бързо, лесно, достъпно и удобно споделяне и откриване на музика</a:t>
+            </a:r>
+          </a:p>
+          <a:p>
+            <a:pPr fontAlgn="base"/>
+            <a:r>
+              <a:rPr lang="bg-BG" noProof="0" dirty="0"/>
+              <a:t>Всеки може да качва линкове към песни</a:t>
+            </a:r>
+          </a:p>
+          <a:p>
+            <a:pPr fontAlgn="base"/>
+            <a:r>
+              <a:rPr lang="bg-BG" noProof="0" dirty="0"/>
+              <a:t>Полезно за събиране на песни, когато изпълнители качват на няколко платформи</a:t>
+            </a:r>
+          </a:p>
+        </p:txBody>
+      </p:sp>
+    </p:spTree>
+    <p:extLst>
+      <p:ext uri="{BB962C8B-B14F-4D97-AF65-F5344CB8AC3E}">
+        <p14:creationId xmlns:p14="http://schemas.microsoft.com/office/powerpoint/2010/main" val="1721509745"/>
+      </p:ext>
+    </p:extLst>
+  </p:cSld>
+  <p:clrMapOvr>
+    <a:masterClrMapping/>
+  </p:clrMapOvr>
+</p:sld>
+</file>
+
+<file path=ppt/slides/slide4.xml><?xml version="1.0" encoding="utf-8"?>
+<p:sld xmlns:a="http://schemas.openxmlformats.org/drawingml/2006/main" xmlns:r="http://schemas.openxmlformats.org/officeDocument/2006/relationships" xmlns:p="http://schemas.openxmlformats.org/presentationml/2006/main">
+  <p:cSld>
+    <p:spTree>
+      <p:nvGrpSpPr>
+        <p:cNvPr id="1" name=""/>
+        <p:cNvGrpSpPr/>
+        <p:nvPr/>
+      </p:nvGrpSpPr>
+      <p:grpSpPr>
+        <a:xfrm>
+          <a:off x="0" y="0"/>
+          <a:ext cx="0" cy="0"/>
+          <a:chOff x="0" y="0"/>
+          <a:chExt cx="0" cy="0"/>
+        </a:xfrm>
+      </p:grpSpPr>
+      <p:sp>
+        <p:nvSpPr>
+          <p:cNvPr id="2" name="Заглавие 1">
+            <a:extLst>
+              <a:ext uri="{FF2B5EF4-FFF2-40B4-BE49-F238E27FC236}">
+                <a16:creationId xmlns:a16="http://schemas.microsoft.com/office/drawing/2014/main" id="{7EB9B3BA-0A8C-766F-1917-31BA6F8FDC15}"/>
+              </a:ext>
+            </a:extLst>
+          </p:cNvPr>
+          <p:cNvSpPr>
+            <a:spLocks noGrp="1"/>
+          </p:cNvSpPr>
+          <p:nvPr>
+            <p:ph type="title"/>
+          </p:nvPr>
+        </p:nvSpPr>
+        <p:spPr/>
+        <p:txBody>
+          <a:bodyPr/>
+          <a:lstStyle/>
+          <a:p>
+            <a:pPr algn="ctr"/>
+            <a:r>
+              <a:rPr lang="bg-BG" dirty="0"/>
+              <a:t>Задачи</a:t>
+            </a:r>
+            <a:endParaRPr lang="en-US" dirty="0"/>
+          </a:p>
+        </p:txBody>
+      </p:sp>
+      <p:pic>
+        <p:nvPicPr>
+          <p:cNvPr id="5" name="Контейнер за съдържание 4">
+            <a:extLst>
+              <a:ext uri="{FF2B5EF4-FFF2-40B4-BE49-F238E27FC236}">
+                <a16:creationId xmlns:a16="http://schemas.microsoft.com/office/drawing/2014/main" id="{88E4B618-9710-6F4D-FB42-E1DF08640B32}"/>
+              </a:ext>
+            </a:extLst>
+          </p:cNvPr>
+          <p:cNvPicPr>
+            <a:picLocks noGrp="1" noChangeAspect="1"/>
+          </p:cNvPicPr>
+          <p:nvPr>
+            <p:ph idx="1"/>
+          </p:nvPr>
+        </p:nvPicPr>
+        <p:blipFill>
+          <a:blip r:embed="rId2"/>
+          <a:stretch>
+            <a:fillRect/>
+          </a:stretch>
+        </p:blipFill>
+        <p:spPr>
+          <a:xfrm>
+            <a:off x="4121911" y="1825625"/>
+            <a:ext cx="3948178" cy="4351338"/>
+          </a:xfrm>
+          <a:prstGeom prst="rect">
+            <a:avLst/>
+          </a:prstGeom>
+        </p:spPr>
+      </p:pic>
+    </p:spTree>
+    <p:extLst>
+      <p:ext uri="{BB962C8B-B14F-4D97-AF65-F5344CB8AC3E}">
+        <p14:creationId xmlns:p14="http://schemas.microsoft.com/office/powerpoint/2010/main" val="3811949936"/>
+      </p:ext>
+    </p:extLst>
+  </p:cSld>
+  <p:clrMapOvr>
+    <a:masterClrMapping/>
+  </p:clrMapOvr>
+</p:sld>
+</file>
+
+<file path=ppt/slides/slide5.xml><?xml version="1.0" encoding="utf-8"?>
+<p:sld xmlns:a="http://schemas.openxmlformats.org/drawingml/2006/main" xmlns:r="http://schemas.openxmlformats.org/officeDocument/2006/relationships" xmlns:p="http://schemas.openxmlformats.org/presentationml/2006/main">
+  <p:cSld>
+    <p:spTree>
+      <p:nvGrpSpPr>
+        <p:cNvPr id="1" name=""/>
+        <p:cNvGrpSpPr/>
+        <p:nvPr/>
+      </p:nvGrpSpPr>
+      <p:grpSpPr>
+        <a:xfrm>
+          <a:off x="0" y="0"/>
+          <a:ext cx="0" cy="0"/>
+          <a:chOff x="0" y="0"/>
+          <a:chExt cx="0" cy="0"/>
+        </a:xfrm>
+      </p:grpSpPr>
+      <p:sp>
+        <p:nvSpPr>
+          <p:cNvPr id="2" name="Title 1"/>
+          <p:cNvSpPr>
+            <a:spLocks noGrp="1"/>
+          </p:cNvSpPr>
+          <p:nvPr>
+            <p:ph type="title"/>
+          </p:nvPr>
+        </p:nvSpPr>
+        <p:spPr/>
+        <p:txBody>
+          <a:bodyPr>
+            <a:normAutofit/>
+          </a:bodyPr>
+          <a:lstStyle/>
+          <a:p>
+            <a:pPr algn="ctr"/>
+            <a:r>
+              <a:rPr lang="bg-BG" noProof="0" dirty="0"/>
+              <a:t>Система за контрол на версиите </a:t>
+            </a:r>
+            <a:br>
+              <a:rPr lang="bg-BG" noProof="0" dirty="0"/>
+            </a:br>
+            <a:endParaRPr lang="bg-BG" noProof="0" dirty="0"/>
+          </a:p>
+        </p:txBody>
+      </p:sp>
+      <p:sp>
+        <p:nvSpPr>
+          <p:cNvPr id="3" name="Content Placeholder 2"/>
+          <p:cNvSpPr>
+            <a:spLocks noGrp="1"/>
+          </p:cNvSpPr>
+          <p:nvPr>
+            <p:ph idx="1"/>
+          </p:nvPr>
+        </p:nvSpPr>
+        <p:spPr>
+          <a:xfrm>
+            <a:off x="58189" y="1379913"/>
+            <a:ext cx="12133811" cy="2119745"/>
+          </a:xfrm>
+        </p:spPr>
+        <p:txBody>
+          <a:bodyPr/>
+          <a:lstStyle/>
+          <a:p>
+            <a:pPr marL="0" indent="0">
+              <a:buNone/>
+            </a:pPr>
+            <a:r>
+              <a:rPr lang="bg-BG" noProof="0" dirty="0"/>
+              <a:t>Избраната система е </a:t>
+            </a:r>
+            <a:r>
+              <a:rPr lang="bg-BG" noProof="0" dirty="0" err="1"/>
+              <a:t>GitHub</a:t>
+            </a:r>
+            <a:r>
+              <a:rPr lang="bg-BG" noProof="0" dirty="0"/>
+              <a:t>. Причината за изборът, е че </a:t>
+            </a:r>
+            <a:r>
+              <a:rPr lang="bg-BG" noProof="0" dirty="0" err="1"/>
+              <a:t>GitHub</a:t>
+            </a:r>
+            <a:r>
+              <a:rPr lang="bg-BG" noProof="0" dirty="0"/>
+              <a:t> е една от най-популярните системи за контрол на версиите и изключително лесна за използване и улеснява работата в екип. Също приложението </a:t>
+            </a:r>
+            <a:r>
+              <a:rPr lang="bg-BG" noProof="0" dirty="0" err="1"/>
+              <a:t>GitHub</a:t>
+            </a:r>
+            <a:r>
+              <a:rPr lang="bg-BG" noProof="0" dirty="0"/>
+              <a:t> </a:t>
+            </a:r>
+            <a:r>
+              <a:rPr lang="bg-BG" noProof="0" dirty="0" err="1"/>
+              <a:t>Desktop</a:t>
+            </a:r>
+            <a:r>
+              <a:rPr lang="bg-BG" noProof="0" dirty="0"/>
+              <a:t> позволява по-лесна промяна и качване на промени по проекта, понеже не се налага да се пишат команди в конзолата.</a:t>
+            </a:r>
+          </a:p>
+          <a:p>
+            <a:pPr marL="0" indent="0">
+              <a:buNone/>
+            </a:pPr>
+            <a:endParaRPr lang="bg-BG" noProof="0" dirty="0"/>
+          </a:p>
+        </p:txBody>
+      </p:sp>
+      <p:pic>
+        <p:nvPicPr>
+          <p:cNvPr id="2050" name="Picture 2" descr="Logo - Brand Toolkit"/>
+          <p:cNvPicPr>
+            <a:picLocks noChangeAspect="1" noChangeArrowheads="1"/>
+          </p:cNvPicPr>
+          <p:nvPr/>
+        </p:nvPicPr>
+        <p:blipFill>
+          <a:blip r:embed="rId2" cstate="print">
+            <a:extLst>
+              <a:ext uri="{28A0092B-C50C-407E-A947-70E740481C1C}">
+                <a14:useLocalDpi xmlns:a14="http://schemas.microsoft.com/office/drawing/2010/main" val="0"/>
+              </a:ext>
+            </a:extLst>
+          </a:blip>
+          <a:srcRect/>
+          <a:stretch>
+            <a:fillRect/>
+          </a:stretch>
+        </p:blipFill>
+        <p:spPr bwMode="auto">
+          <a:xfrm>
+            <a:off x="297028" y="4080230"/>
+            <a:ext cx="5546970" cy="2059313"/>
+          </a:xfrm>
+          <a:prstGeom prst="rect">
+            <a:avLst/>
+          </a:prstGeom>
+          <a:noFill/>
+          <a:extLst>
+            <a:ext uri="{909E8E84-426E-40DD-AFC4-6F175D3DCCD1}">
+              <a14:hiddenFill xmlns:a14="http://schemas.microsoft.com/office/drawing/2010/main">
+                <a:solidFill>
+                  <a:srgbClr val="FFFFFF"/>
+                </a:solidFill>
+              </a14:hiddenFill>
+            </a:ext>
+          </a:extLst>
+        </p:spPr>
+      </p:pic>
+      <p:pic>
+        <p:nvPicPr>
+          <p:cNvPr id="2052" name="Picture 4" descr="Getting Started with G... | Wiki | UAL Creative Computing Institute"/>
+          <p:cNvPicPr>
+            <a:picLocks noChangeAspect="1" noChangeArrowheads="1"/>
+          </p:cNvPicPr>
+          <p:nvPr/>
+        </p:nvPicPr>
+        <p:blipFill>
+          <a:blip r:embed="rId3">
+            <a:extLst>
+              <a:ext uri="{28A0092B-C50C-407E-A947-70E740481C1C}">
+                <a14:useLocalDpi xmlns:a14="http://schemas.microsoft.com/office/drawing/2010/main" val="0"/>
+              </a:ext>
+            </a:extLst>
+          </a:blip>
+          <a:srcRect/>
+          <a:stretch>
+            <a:fillRect/>
+          </a:stretch>
+        </p:blipFill>
+        <p:spPr bwMode="auto">
+          <a:xfrm>
+            <a:off x="5961289" y="4157386"/>
+            <a:ext cx="5715000" cy="1905000"/>
+          </a:xfrm>
+          <a:prstGeom prst="rect">
+            <a:avLst/>
+          </a:prstGeom>
+          <a:noFill/>
+          <a:extLst>
+            <a:ext uri="{909E8E84-426E-40DD-AFC4-6F175D3DCCD1}">
+              <a14:hiddenFill xmlns:a14="http://schemas.microsoft.com/office/drawing/2010/main">
+                <a:solidFill>
+                  <a:srgbClr val="FFFFFF"/>
+                </a:solidFill>
+              </a14:hiddenFill>
+            </a:ext>
+          </a:extLst>
+        </p:spPr>
+      </p:pic>
+    </p:spTree>
+    <p:extLst>
+      <p:ext uri="{BB962C8B-B14F-4D97-AF65-F5344CB8AC3E}">
+        <p14:creationId xmlns:p14="http://schemas.microsoft.com/office/powerpoint/2010/main" val="1432200802"/>
+      </p:ext>
+    </p:extLst>
+  </p:cSld>
+  <p:clrMapOvr>
+    <a:masterClrMapping/>
+  </p:clrMapOvr>
+</p:sld>
+</file>
+
+<file path=ppt/slides/slide6.xml><?xml version="1.0" encoding="utf-8"?>
+<p:sld xmlns:a="http://schemas.openxmlformats.org/drawingml/2006/main" xmlns:r="http://schemas.openxmlformats.org/officeDocument/2006/relationships" xmlns:p="http://schemas.openxmlformats.org/presentationml/2006/main">
+  <p:cSld>
+    <p:spTree>
+      <p:nvGrpSpPr>
+        <p:cNvPr id="1" name=""/>
+        <p:cNvGrpSpPr/>
+        <p:nvPr/>
+      </p:nvGrpSpPr>
+      <p:grpSpPr>
+        <a:xfrm>
+          <a:off x="0" y="0"/>
+          <a:ext cx="0" cy="0"/>
+          <a:chOff x="0" y="0"/>
+          <a:chExt cx="0" cy="0"/>
+        </a:xfrm>
+      </p:grpSpPr>
+      <p:sp>
+        <p:nvSpPr>
+          <p:cNvPr id="2" name="Title 1"/>
+          <p:cNvSpPr>
+            <a:spLocks noGrp="1"/>
+          </p:cNvSpPr>
+          <p:nvPr>
+            <p:ph type="title"/>
+          </p:nvPr>
+        </p:nvSpPr>
+        <p:spPr/>
+        <p:txBody>
+          <a:bodyPr>
+            <a:normAutofit/>
+          </a:bodyPr>
+          <a:lstStyle/>
+          <a:p>
+            <a:pPr algn="ctr"/>
+            <a:r>
+              <a:rPr lang="bg-BG" noProof="0" dirty="0"/>
+              <a:t>Система за управление на проекта</a:t>
+            </a:r>
+          </a:p>
+        </p:txBody>
+      </p:sp>
+      <p:pic>
+        <p:nvPicPr>
+          <p:cNvPr id="3074" name="Picture 2" descr="File:Jira Logo.svg - Wikimedia Commons"/>
+          <p:cNvPicPr>
+            <a:picLocks noGrp="1" noChangeAspect="1" noChangeArrowheads="1"/>
+          </p:cNvPicPr>
+          <p:nvPr>
+            <p:ph sz="half" idx="1"/>
+          </p:nvPr>
+        </p:nvPicPr>
+        <p:blipFill>
+          <a:blip r:embed="rId2" cstate="print">
+            <a:extLst>
+              <a:ext uri="{28A0092B-C50C-407E-A947-70E740481C1C}">
+                <a14:useLocalDpi xmlns:a14="http://schemas.microsoft.com/office/drawing/2010/main" val="0"/>
+              </a:ext>
+            </a:extLst>
+          </a:blip>
+          <a:stretch>
+            <a:fillRect/>
+          </a:stretch>
+        </p:blipFill>
+        <p:spPr bwMode="auto">
+          <a:xfrm>
+            <a:off x="1018407" y="5290888"/>
+            <a:ext cx="2394181" cy="1010045"/>
+          </a:xfrm>
+          <a:prstGeom prst="rect">
+            <a:avLst/>
+          </a:prstGeom>
+          <a:noFill/>
+          <a:extLst>
+            <a:ext uri="{909E8E84-426E-40DD-AFC4-6F175D3DCCD1}">
+              <a14:hiddenFill xmlns:a14="http://schemas.microsoft.com/office/drawing/2010/main">
+                <a:solidFill>
+                  <a:srgbClr val="FFFFFF"/>
+                </a:solidFill>
+              </a14:hiddenFill>
+            </a:ext>
+          </a:extLst>
+        </p:spPr>
+      </p:pic>
+      <p:sp>
+        <p:nvSpPr>
+          <p:cNvPr id="4" name="Контейнер за съдържание 3">
+            <a:extLst>
+              <a:ext uri="{FF2B5EF4-FFF2-40B4-BE49-F238E27FC236}">
+                <a16:creationId xmlns:a16="http://schemas.microsoft.com/office/drawing/2014/main" id="{A19340FF-5881-8D7C-13AD-5E45FA7B6BDF}"/>
+              </a:ext>
+            </a:extLst>
+          </p:cNvPr>
+          <p:cNvSpPr>
+            <a:spLocks noGrp="1"/>
+          </p:cNvSpPr>
+          <p:nvPr>
+            <p:ph sz="half" idx="2"/>
+          </p:nvPr>
+        </p:nvSpPr>
+        <p:spPr>
+          <a:xfrm>
+            <a:off x="1018407" y="1825625"/>
+            <a:ext cx="10335393" cy="4351338"/>
+          </a:xfrm>
+        </p:spPr>
+        <p:txBody>
+          <a:bodyPr/>
+          <a:lstStyle/>
+          <a:p>
+            <a:r>
+              <a:rPr lang="bg-BG" noProof="0" dirty="0"/>
+              <a:t>Избраната система е JIRA. Системата е подходяща и съвместима с методологиите, използвани от отбора и доставя всички нужни функционалности по удобен и лесен за ползване начин с неговия потребителски интерфейс.</a:t>
+            </a:r>
+          </a:p>
+          <a:p>
+            <a:pPr marL="0" indent="0">
+              <a:buNone/>
+            </a:pPr>
+            <a:endParaRPr lang="bg-BG" noProof="0" dirty="0"/>
+          </a:p>
+        </p:txBody>
+      </p:sp>
+    </p:spTree>
+    <p:extLst>
+      <p:ext uri="{BB962C8B-B14F-4D97-AF65-F5344CB8AC3E}">
+        <p14:creationId xmlns:p14="http://schemas.microsoft.com/office/powerpoint/2010/main" val="1157703078"/>
+      </p:ext>
+    </p:extLst>
+  </p:cSld>
+  <p:clrMapOvr>
+    <a:masterClrMapping/>
+  </p:clrMapOvr>
+</p:sld>
+</file>
+
+<file path=ppt/slides/slide7.xml><?xml version="1.0" encoding="utf-8"?>
+<p:sld xmlns:a="http://schemas.openxmlformats.org/drawingml/2006/main" xmlns:r="http://schemas.openxmlformats.org/officeDocument/2006/relationships" xmlns:p="http://schemas.openxmlformats.org/presentationml/2006/main">
+  <p:cSld>
+    <p:spTree>
+      <p:nvGrpSpPr>
+        <p:cNvPr id="1" name=""/>
+        <p:cNvGrpSpPr/>
+        <p:nvPr/>
+      </p:nvGrpSpPr>
+      <p:grpSpPr>
+        <a:xfrm>
+          <a:off x="0" y="0"/>
+          <a:ext cx="0" cy="0"/>
+          <a:chOff x="0" y="0"/>
+          <a:chExt cx="0" cy="0"/>
+        </a:xfrm>
+      </p:grpSpPr>
+      <p:sp>
+        <p:nvSpPr>
+          <p:cNvPr id="2" name="Title 1"/>
+          <p:cNvSpPr>
+            <a:spLocks noGrp="1"/>
+          </p:cNvSpPr>
+          <p:nvPr>
+            <p:ph type="title"/>
+          </p:nvPr>
+        </p:nvSpPr>
+        <p:spPr/>
+        <p:txBody>
+          <a:bodyPr/>
+          <a:lstStyle/>
+          <a:p>
+            <a:pPr algn="ctr"/>
+            <a:r>
+              <a:rPr lang="bg-BG" noProof="0" dirty="0" err="1"/>
+              <a:t>Web</a:t>
+            </a:r>
+            <a:r>
+              <a:rPr lang="bg-BG" noProof="0" dirty="0"/>
+              <a:t> Приложение</a:t>
+            </a:r>
+            <a:br>
+              <a:rPr lang="bg-BG" noProof="0" dirty="0"/>
+            </a:br>
+            <a:endParaRPr lang="bg-BG" noProof="0" dirty="0"/>
+          </a:p>
+        </p:txBody>
+      </p:sp>
+      <p:sp>
+        <p:nvSpPr>
+          <p:cNvPr id="3" name="Content Placeholder 2"/>
+          <p:cNvSpPr>
+            <a:spLocks noGrp="1"/>
+          </p:cNvSpPr>
+          <p:nvPr>
+            <p:ph idx="1"/>
+          </p:nvPr>
+        </p:nvSpPr>
+        <p:spPr>
+          <a:xfrm>
+            <a:off x="838200" y="1520825"/>
+            <a:ext cx="10515600" cy="1425575"/>
+          </a:xfrm>
+        </p:spPr>
+        <p:txBody>
+          <a:bodyPr/>
+          <a:lstStyle/>
+          <a:p>
+            <a:pPr marL="0" indent="0">
+              <a:buNone/>
+            </a:pPr>
+            <a:r>
+              <a:rPr lang="bg-BG" noProof="0" dirty="0"/>
+              <a:t>Проектът е под формата на </a:t>
+            </a:r>
+            <a:r>
+              <a:rPr lang="bg-BG" noProof="0" dirty="0" err="1"/>
+              <a:t>Web</a:t>
+            </a:r>
+            <a:r>
+              <a:rPr lang="bg-BG" noProof="0" dirty="0"/>
+              <a:t> приложение. Това е поради използваната технология. NET </a:t>
+            </a:r>
+            <a:r>
+              <a:rPr lang="bg-BG" noProof="0" dirty="0" err="1"/>
+              <a:t>Web</a:t>
+            </a:r>
+            <a:r>
+              <a:rPr lang="bg-BG" noProof="0" dirty="0"/>
+              <a:t> </a:t>
+            </a:r>
+            <a:r>
+              <a:rPr lang="bg-BG" noProof="0" dirty="0" err="1"/>
+              <a:t>App</a:t>
+            </a:r>
+            <a:r>
+              <a:rPr lang="bg-BG" noProof="0" dirty="0"/>
+              <a:t> със структура MVC (</a:t>
+            </a:r>
+            <a:r>
+              <a:rPr lang="bg-BG" noProof="0" dirty="0" err="1"/>
+              <a:t>Model</a:t>
+            </a:r>
+            <a:r>
+              <a:rPr lang="bg-BG" noProof="0" dirty="0"/>
+              <a:t> </a:t>
+            </a:r>
+            <a:r>
+              <a:rPr lang="bg-BG" noProof="0" dirty="0" err="1"/>
+              <a:t>View</a:t>
+            </a:r>
+            <a:r>
+              <a:rPr lang="bg-BG" noProof="0" dirty="0"/>
+              <a:t> </a:t>
+            </a:r>
+            <a:r>
+              <a:rPr lang="bg-BG" noProof="0" dirty="0" err="1"/>
+              <a:t>Controller</a:t>
+            </a:r>
+            <a:r>
+              <a:rPr lang="bg-BG" noProof="0" dirty="0"/>
+              <a:t>).</a:t>
+            </a:r>
+          </a:p>
+          <a:p>
+            <a:endParaRPr lang="bg-BG" noProof="0" dirty="0"/>
+          </a:p>
+        </p:txBody>
+      </p:sp>
+      <p:pic>
+        <p:nvPicPr>
+          <p:cNvPr id="4" name="Picture 3"/>
+          <p:cNvPicPr>
+            <a:picLocks noChangeAspect="1"/>
+          </p:cNvPicPr>
+          <p:nvPr/>
+        </p:nvPicPr>
+        <p:blipFill>
+          <a:blip r:embed="rId2"/>
+          <a:stretch>
+            <a:fillRect/>
+          </a:stretch>
+        </p:blipFill>
+        <p:spPr>
+          <a:xfrm>
+            <a:off x="1568070" y="2846388"/>
+            <a:ext cx="8573457" cy="3915001"/>
+          </a:xfrm>
+          <a:prstGeom prst="rect">
+            <a:avLst/>
+          </a:prstGeom>
+        </p:spPr>
+      </p:pic>
+    </p:spTree>
+    <p:extLst>
+      <p:ext uri="{BB962C8B-B14F-4D97-AF65-F5344CB8AC3E}">
+        <p14:creationId xmlns:p14="http://schemas.microsoft.com/office/powerpoint/2010/main" val="1685781362"/>
+      </p:ext>
+    </p:extLst>
+  </p:cSld>
+  <p:clrMapOvr>
+    <a:masterClrMapping/>
+  </p:clrMapOvr>
+</p:sld>
+</file>
+
+<file path=ppt/slides/slide8.xml><?xml version="1.0" encoding="utf-8"?>
+<p:sld xmlns:a="http://schemas.openxmlformats.org/drawingml/2006/main" xmlns:r="http://schemas.openxmlformats.org/officeDocument/2006/relationships" xmlns:p="http://schemas.openxmlformats.org/presentationml/2006/main">
+  <p:cSld>
+    <p:spTree>
+      <p:nvGrpSpPr>
+        <p:cNvPr id="1" name=""/>
+        <p:cNvGrpSpPr/>
+        <p:nvPr/>
+      </p:nvGrpSpPr>
+      <p:grpSpPr>
+        <a:xfrm>
+          <a:off x="0" y="0"/>
+          <a:ext cx="0" cy="0"/>
+          <a:chOff x="0" y="0"/>
+          <a:chExt cx="0" cy="0"/>
+        </a:xfrm>
+      </p:grpSpPr>
+      <p:pic>
+        <p:nvPicPr>
+          <p:cNvPr id="5" name="Picture 4"/>
+          <p:cNvPicPr>
+            <a:picLocks noChangeAspect="1"/>
+          </p:cNvPicPr>
+          <p:nvPr/>
+        </p:nvPicPr>
+        <p:blipFill>
+          <a:blip r:embed="rId2"/>
+          <a:stretch>
+            <a:fillRect/>
+          </a:stretch>
+        </p:blipFill>
+        <p:spPr>
+          <a:xfrm>
+            <a:off x="9102436" y="2913348"/>
+            <a:ext cx="2933354" cy="2092039"/>
+          </a:xfrm>
+          <a:prstGeom prst="rect">
+            <a:avLst/>
+          </a:prstGeom>
+        </p:spPr>
+      </p:pic>
+      <p:sp>
+        <p:nvSpPr>
+          <p:cNvPr id="2" name="Title 1"/>
+          <p:cNvSpPr>
+            <a:spLocks noGrp="1"/>
+          </p:cNvSpPr>
+          <p:nvPr>
+            <p:ph type="title"/>
+          </p:nvPr>
+        </p:nvSpPr>
+        <p:spPr/>
+        <p:txBody>
+          <a:bodyPr/>
+          <a:lstStyle/>
+          <a:p>
+            <a:pPr algn="ctr"/>
+            <a:r>
+              <a:rPr lang="bg-BG" noProof="0" dirty="0"/>
+              <a:t>Използвани функционалности</a:t>
+            </a:r>
+            <a:br>
+              <a:rPr lang="bg-BG" noProof="0" dirty="0"/>
+            </a:br>
+            <a:endParaRPr lang="bg-BG" noProof="0" dirty="0"/>
+          </a:p>
+        </p:txBody>
+      </p:sp>
+      <p:sp>
+        <p:nvSpPr>
+          <p:cNvPr id="3" name="Content Placeholder 2"/>
+          <p:cNvSpPr>
+            <a:spLocks noGrp="1"/>
+          </p:cNvSpPr>
+          <p:nvPr>
+            <p:ph idx="1"/>
+          </p:nvPr>
+        </p:nvSpPr>
+        <p:spPr>
+          <a:xfrm>
+            <a:off x="58189" y="1168920"/>
+            <a:ext cx="12133811" cy="2380615"/>
+          </a:xfrm>
+        </p:spPr>
+        <p:txBody>
+          <a:bodyPr>
+            <a:normAutofit/>
+          </a:bodyPr>
+          <a:lstStyle/>
+          <a:p>
+            <a:r>
+              <a:rPr lang="bg-BG" noProof="0" dirty="0"/>
+              <a:t>Приложението дава възможност на регистрирани потребители да добавят, променят и изтриват песни. След като една песен е добавена, тя може да се види в главната страница на приложението, от където също може да се ходи директно във външни уеб страници, посочени от добавените песни. Песни могат да се търсят по техните създатели, име, жанр и година.</a:t>
+            </a:r>
+          </a:p>
+          <a:p>
+            <a:endParaRPr lang="bg-BG" noProof="0" dirty="0"/>
+          </a:p>
+        </p:txBody>
+      </p:sp>
+      <p:pic>
+        <p:nvPicPr>
+          <p:cNvPr id="4" name="Picture 3"/>
+          <p:cNvPicPr>
+            <a:picLocks noChangeAspect="1"/>
+          </p:cNvPicPr>
+          <p:nvPr/>
+        </p:nvPicPr>
+        <p:blipFill>
+          <a:blip r:embed="rId3"/>
+          <a:stretch>
+            <a:fillRect/>
+          </a:stretch>
+        </p:blipFill>
+        <p:spPr>
+          <a:xfrm>
+            <a:off x="174568" y="3356091"/>
+            <a:ext cx="6916188" cy="3105150"/>
+          </a:xfrm>
+          <a:prstGeom prst="rect">
+            <a:avLst/>
+          </a:prstGeom>
+        </p:spPr>
+      </p:pic>
+      <p:pic>
+        <p:nvPicPr>
+          <p:cNvPr id="6" name="Picture 5"/>
+          <p:cNvPicPr>
+            <a:picLocks noChangeAspect="1"/>
+          </p:cNvPicPr>
+          <p:nvPr/>
+        </p:nvPicPr>
+        <p:blipFill>
+          <a:blip r:embed="rId4"/>
+          <a:stretch>
+            <a:fillRect/>
+          </a:stretch>
+        </p:blipFill>
+        <p:spPr>
+          <a:xfrm>
+            <a:off x="8019963" y="5293963"/>
+            <a:ext cx="4087004" cy="1360952"/>
+          </a:xfrm>
+          <a:prstGeom prst="rect">
+            <a:avLst/>
+          </a:prstGeom>
+        </p:spPr>
+      </p:pic>
+    </p:spTree>
+    <p:extLst>
+      <p:ext uri="{BB962C8B-B14F-4D97-AF65-F5344CB8AC3E}">
+        <p14:creationId xmlns:p14="http://schemas.microsoft.com/office/powerpoint/2010/main" val="3479705222"/>
+      </p:ext>
+    </p:extLst>
+  </p:cSld>
+  <p:clrMapOvr>
+    <a:masterClrMapping/>
+  </p:clrMapOvr>
+</p:sld>
+</file>
+
 <file path=ppt/slides/slide9.xml><?xml version="1.0" encoding="utf-8"?>
 <p:sld xmlns:a="http://schemas.openxmlformats.org/drawingml/2006/main" xmlns:r="http://schemas.openxmlformats.org/officeDocument/2006/relationships" xmlns:p="http://schemas.openxmlformats.org/presentationml/2006/main">
   <p:cSld>
@@ -4598,22 +4863,19 @@
         <p:spPr/>
         <p:txBody>
           <a:bodyPr>
-            <a:normAutofit fontScale="90000"/>
+            <a:normAutofit/>
           </a:bodyPr>
           <a:lstStyle/>
           <a:p>
-            <a:r>
-              <a:rPr lang="ru-RU"/>
-              <a:t>8.Стъпки, зависещи от конкретния подход за разработка</a:t>
-            </a:r>
-            <a:r>
-              <a:rPr lang="en-US"/>
-              <a:t/>
+            <a:pPr algn="ctr"/>
+            <a:r>
+              <a:rPr lang="bg-BG" noProof="0" dirty="0"/>
+              <a:t>Методологии за разработка на софтуера</a:t>
             </a:r>
             <a:br>
-              <a:rPr lang="en-US"/>
+              <a:rPr lang="bg-BG" noProof="0" dirty="0"/>
             </a:br>
-            <a:endParaRPr lang="en-US"/>
+            <a:endParaRPr lang="bg-BG" noProof="0" dirty="0"/>
           </a:p>
         </p:txBody>
       </p:sp>
@@ -4624,74 +4886,61 @@
             <a:spLocks noGrp="1"/>
           </p:cNvSpPr>
           <p:nvPr>
-            <p:ph idx="1"/>
-          </p:nvPr>
-        </p:nvSpPr>
-        <p:spPr/>
-        <p:txBody>
-          <a:bodyPr>
-            <a:normAutofit fontScale="92500" lnSpcReduction="10000"/>
-          </a:bodyPr>
-          <a:lstStyle/>
-          <a:p>
-            <a:pPr marL="0" indent="0">
-              <a:buNone/>
-            </a:pPr>
-            <a:r>
-              <a:rPr lang="ru-RU"/>
-              <a:t>Използваната за създаване на проекта </a:t>
-            </a:r>
-            <a:r>
-              <a:rPr lang="en-US"/>
-              <a:t>MVC </a:t>
-            </a:r>
-            <a:r>
-              <a:rPr lang="bg-BG"/>
-              <a:t>структура , изисква някои спецификации , за да може да функционира приложението. Трябва да се останови връзка към базата данни  , за да може да се съхраняват и взимат данните за песни в приложението . Трябва да се направят модели , чрез които се създават обекти . Нужни са контролери , които да съдържат логиката за работа с обектите направени от моделите . </a:t>
-            </a:r>
-            <a:r>
-              <a:rPr lang="en-US"/>
-              <a:t>ViewModels </a:t>
-            </a:r>
-            <a:r>
-              <a:rPr lang="bg-BG"/>
-              <a:t>са класове, които се използват за да помагат с четенето и писането на данни в обектите, като различните </a:t>
-            </a:r>
-            <a:r>
-              <a:rPr lang="en-US"/>
-              <a:t>ViewModel-</a:t>
-            </a:r>
-            <a:r>
-              <a:rPr lang="bg-BG"/>
-              <a:t>и имат различен подбор от данни, които да използват за различни страници от </a:t>
-            </a:r>
-            <a:r>
-              <a:rPr lang="en-US"/>
-              <a:t>Web </a:t>
-            </a:r>
-            <a:r>
-              <a:rPr lang="bg-BG"/>
-              <a:t>приложението. </a:t>
-            </a:r>
-            <a:r>
-              <a:rPr lang="en-US"/>
-              <a:t>View-</a:t>
-            </a:r>
-            <a:r>
-              <a:rPr lang="bg-BG"/>
-              <a:t>тата са структурите на страниците в приложението. Те представляват  как ще изглежда и как ще е структурирана една страница. </a:t>
-            </a:r>
-            <a:endParaRPr lang="en-US"/>
-          </a:p>
-          <a:p>
-            <a:endParaRPr lang="en-US"/>
+            <p:ph sz="half" idx="1"/>
+          </p:nvPr>
+        </p:nvSpPr>
+        <p:spPr/>
+        <p:txBody>
+          <a:bodyPr/>
+          <a:lstStyle/>
+          <a:p>
+            <a:r>
+              <a:rPr lang="bg-BG" noProof="0" dirty="0" err="1"/>
+              <a:t>Hacking</a:t>
+            </a:r>
+            <a:r>
+              <a:rPr lang="bg-BG" noProof="0" dirty="0"/>
+              <a:t> е практиката да се прави работа по приложението без предварително разясняване на нужни задачи и средства. Поради малкият отбор и обхват на проекта, методологията може да бъде употребена.</a:t>
+            </a:r>
+          </a:p>
+        </p:txBody>
+      </p:sp>
+      <p:sp>
+        <p:nvSpPr>
+          <p:cNvPr id="4" name="Контейнер за съдържание 3">
+            <a:extLst>
+              <a:ext uri="{FF2B5EF4-FFF2-40B4-BE49-F238E27FC236}">
+                <a16:creationId xmlns:a16="http://schemas.microsoft.com/office/drawing/2014/main" id="{BBBEFE92-2C83-1C94-4524-2F7A3E7B67F5}"/>
+              </a:ext>
+            </a:extLst>
+          </p:cNvPr>
+          <p:cNvSpPr>
+            <a:spLocks noGrp="1"/>
+          </p:cNvSpPr>
+          <p:nvPr>
+            <p:ph sz="half" idx="2"/>
+          </p:nvPr>
+        </p:nvSpPr>
+        <p:spPr/>
+        <p:txBody>
+          <a:bodyPr/>
+          <a:lstStyle/>
+          <a:p>
+            <a:r>
+              <a:rPr lang="bg-BG" noProof="0" dirty="0" err="1"/>
+              <a:t>Kanban</a:t>
+            </a:r>
+            <a:r>
+              <a:rPr lang="bg-BG" noProof="0" dirty="0"/>
+              <a:t> е предпочитан за този проект, поради ниския брой задачи, които могат лесно да се запишат на дъска, и винаги може да се запишат нови задачи или редактират стари по време на разработката.</a:t>
+            </a:r>
           </a:p>
         </p:txBody>
       </p:sp>
     </p:spTree>
     <p:extLst>
       <p:ext uri="{BB962C8B-B14F-4D97-AF65-F5344CB8AC3E}">
-        <p14:creationId xmlns:p14="http://schemas.microsoft.com/office/powerpoint/2010/main" val="3329442785"/>
+        <p14:creationId xmlns:p14="http://schemas.microsoft.com/office/powerpoint/2010/main" val="3916397861"/>
       </p:ext>
     </p:extLst>
   </p:cSld>

</xml_diff>